<commit_message>
chore: sync Android SMS retriever, widget & overlay fixes + ibm.pptx + gitignore
- Add SmsReceiver (SMS_RETRIEVED_ACTION) privacy-safe, SmsRetrieverHelper tweak
- FloatingWidgetService / MainActivity polish (overlay, health chips, lint fixes)
- Update strings.xml, ApiClient minor fix, OcrHelper tweak
- Ignore android/.idea, gradle zip, temp scripts
</commit_message>
<xml_diff>
--- a/ibm.pptx
+++ b/ibm.pptx
@@ -5,7 +5,7 @@
     <p:sldMasterId id="2147483648" r:id="rId1"/>
   </p:sldMasterIdLst>
   <p:notesMasterIdLst>
-    <p:notesMasterId r:id="rId18"/>
+    <p:notesMasterId r:id="rId16"/>
   </p:notesMasterIdLst>
   <p:sldIdLst>
     <p:sldId id="283" r:id="rId2"/>
@@ -14,16 +14,14 @@
     <p:sldId id="285" r:id="rId5"/>
     <p:sldId id="278" r:id="rId6"/>
     <p:sldId id="281" r:id="rId7"/>
-    <p:sldId id="279" r:id="rId8"/>
-    <p:sldId id="262" r:id="rId9"/>
-    <p:sldId id="264" r:id="rId10"/>
-    <p:sldId id="277" r:id="rId11"/>
-    <p:sldId id="286" r:id="rId12"/>
-    <p:sldId id="287" r:id="rId13"/>
-    <p:sldId id="280" r:id="rId14"/>
-    <p:sldId id="288" r:id="rId15"/>
-    <p:sldId id="289" r:id="rId16"/>
-    <p:sldId id="276" r:id="rId17"/>
+    <p:sldId id="262" r:id="rId8"/>
+    <p:sldId id="264" r:id="rId9"/>
+    <p:sldId id="286" r:id="rId10"/>
+    <p:sldId id="287" r:id="rId11"/>
+    <p:sldId id="280" r:id="rId12"/>
+    <p:sldId id="288" r:id="rId13"/>
+    <p:sldId id="289" r:id="rId14"/>
+    <p:sldId id="276" r:id="rId15"/>
   </p:sldIdLst>
   <p:sldSz cx="12192000" cy="6858000"/>
   <p:notesSz cx="6858000" cy="9144000"/>
@@ -479,6 +477,11 @@
         </p:txBody>
       </p:sp>
     </p:spTree>
+    <p:extLst>
+      <p:ext uri="{BB962C8B-B14F-4D97-AF65-F5344CB8AC3E}">
+        <p14:creationId xmlns:p14="http://schemas.microsoft.com/office/powerpoint/2010/main" val="1980031392"/>
+      </p:ext>
+    </p:extLst>
   </p:cSld>
   <p:clrMap bg1="lt1" tx1="dk1" bg2="dk2" tx2="lt2" accent1="accent1" accent2="accent2" accent3="accent3" accent4="accent4" accent5="accent5" accent6="accent6" hlink="hlink" folHlink="folHlink"/>
   <p:notesStyle>
@@ -822,10 +825,10 @@
   <p:cSld>
     <p:spTree>
       <p:nvGrpSpPr>
-        <p:cNvPr id="1" name="Shape 197">
+        <p:cNvPr id="1" name="Shape 271">
           <a:extLst>
             <a:ext uri="{FF2B5EF4-FFF2-40B4-BE49-F238E27FC236}">
-              <a16:creationId xmlns:a16="http://schemas.microsoft.com/office/drawing/2014/main" id="{C2F88CF5-D0C3-0228-6C1A-E849738B9B34}"/>
+              <a16:creationId xmlns="" xmlns:a16="http://schemas.microsoft.com/office/drawing/2014/main" id="{466C47D1-19F6-52AF-3914-DD3C99058916}"/>
             </a:ext>
           </a:extLst>
         </p:cNvPr>
@@ -842,10 +845,10 @@
       </p:grpSpPr>
       <p:sp>
         <p:nvSpPr>
-          <p:cNvPr id="198" name="Google Shape;198;p10:notes">
+          <p:cNvPr id="272" name="Google Shape;272;p18:notes">
             <a:extLst>
               <a:ext uri="{FF2B5EF4-FFF2-40B4-BE49-F238E27FC236}">
-                <a16:creationId xmlns:a16="http://schemas.microsoft.com/office/drawing/2014/main" id="{15C41DBA-EB5E-9EB1-28D2-68EF3081A29D}"/>
+                <a16:creationId xmlns="" xmlns:a16="http://schemas.microsoft.com/office/drawing/2014/main" id="{ACA1F779-4C2B-4CD1-FBDD-A40F0A322340}"/>
               </a:ext>
             </a:extLst>
           </p:cNvPr>
@@ -886,264 +889,10 @@
       </p:sp>
       <p:sp>
         <p:nvSpPr>
-          <p:cNvPr id="199" name="Google Shape;199;p10:notes">
-            <a:extLst>
-              <a:ext uri="{FF2B5EF4-FFF2-40B4-BE49-F238E27FC236}">
-                <a16:creationId xmlns:a16="http://schemas.microsoft.com/office/drawing/2014/main" id="{9AACA92E-BC74-25E5-B8D5-2E658F81C2F0}"/>
-              </a:ext>
-            </a:extLst>
-          </p:cNvPr>
-          <p:cNvSpPr>
-            <a:spLocks noGrp="1" noRot="1" noChangeAspect="1"/>
-          </p:cNvSpPr>
-          <p:nvPr>
-            <p:ph type="sldImg" idx="2"/>
-          </p:nvPr>
-        </p:nvSpPr>
-        <p:spPr>
-          <a:xfrm>
-            <a:off x="381000" y="685800"/>
-            <a:ext cx="6096000" cy="3429000"/>
-          </a:xfrm>
-          <a:custGeom>
-            <a:avLst/>
-            <a:gdLst/>
-            <a:ahLst/>
-            <a:cxnLst/>
-            <a:rect l="l" t="t" r="r" b="b"/>
-            <a:pathLst>
-              <a:path w="120000" h="120000" extrusionOk="0">
-                <a:moveTo>
-                  <a:pt x="0" y="0"/>
-                </a:moveTo>
-                <a:lnTo>
-                  <a:pt x="120000" y="0"/>
-                </a:lnTo>
-                <a:lnTo>
-                  <a:pt x="120000" y="120000"/>
-                </a:lnTo>
-                <a:lnTo>
-                  <a:pt x="0" y="120000"/>
-                </a:lnTo>
-                <a:close/>
-              </a:path>
-            </a:pathLst>
-          </a:custGeom>
-        </p:spPr>
-      </p:sp>
-    </p:spTree>
-    <p:extLst>
-      <p:ext uri="{BB962C8B-B14F-4D97-AF65-F5344CB8AC3E}">
-        <p14:creationId xmlns:p14="http://schemas.microsoft.com/office/powerpoint/2010/main" val="1057587110"/>
-      </p:ext>
-    </p:extLst>
-  </p:cSld>
-  <p:clrMapOvr>
-    <a:masterClrMapping/>
-  </p:clrMapOvr>
-</p:notes>
-</file>
-
-<file path=ppt/notesSlides/notesSlide11.xml><?xml version="1.0" encoding="utf-8"?>
-<p:notes xmlns:a="http://schemas.openxmlformats.org/drawingml/2006/main" xmlns:r="http://schemas.openxmlformats.org/officeDocument/2006/relationships" xmlns:p="http://schemas.openxmlformats.org/presentationml/2006/main" showMasterSp="0" showMasterPhAnim="0">
-  <p:cSld>
-    <p:spTree>
-      <p:nvGrpSpPr>
-        <p:cNvPr id="1" name="Shape 271">
-          <a:extLst>
-            <a:ext uri="{FF2B5EF4-FFF2-40B4-BE49-F238E27FC236}">
-              <a16:creationId xmlns:a16="http://schemas.microsoft.com/office/drawing/2014/main" id="{A795C14E-5D6A-39A3-2018-2C72BB451BBD}"/>
-            </a:ext>
-          </a:extLst>
-        </p:cNvPr>
-        <p:cNvGrpSpPr/>
-        <p:nvPr/>
-      </p:nvGrpSpPr>
-      <p:grpSpPr>
-        <a:xfrm>
-          <a:off x="0" y="0"/>
-          <a:ext cx="0" cy="0"/>
-          <a:chOff x="0" y="0"/>
-          <a:chExt cx="0" cy="0"/>
-        </a:xfrm>
-      </p:grpSpPr>
-      <p:sp>
-        <p:nvSpPr>
-          <p:cNvPr id="272" name="Google Shape;272;p18:notes">
-            <a:extLst>
-              <a:ext uri="{FF2B5EF4-FFF2-40B4-BE49-F238E27FC236}">
-                <a16:creationId xmlns:a16="http://schemas.microsoft.com/office/drawing/2014/main" id="{85B8BB2F-0927-3841-AC64-CC67B5035869}"/>
-              </a:ext>
-            </a:extLst>
-          </p:cNvPr>
-          <p:cNvSpPr txBox="1">
-            <a:spLocks noGrp="1"/>
-          </p:cNvSpPr>
-          <p:nvPr>
-            <p:ph type="body" idx="1"/>
-          </p:nvPr>
-        </p:nvSpPr>
-        <p:spPr>
-          <a:xfrm>
-            <a:off x="685800" y="4343400"/>
-            <a:ext cx="5486400" cy="4114800"/>
-          </a:xfrm>
-          <a:prstGeom prst="rect">
-            <a:avLst/>
-          </a:prstGeom>
-        </p:spPr>
-        <p:txBody>
-          <a:bodyPr spcFirstLastPara="1" wrap="square" lIns="91425" tIns="91425" rIns="91425" bIns="91425" anchor="t" anchorCtr="0">
-            <a:noAutofit/>
-          </a:bodyPr>
-          <a:lstStyle/>
-          <a:p>
-            <a:pPr marL="0" lvl="0" indent="0" algn="l" rtl="0">
-              <a:spcBef>
-                <a:spcPts val="0"/>
-              </a:spcBef>
-              <a:spcAft>
-                <a:spcPts val="0"/>
-              </a:spcAft>
-              <a:buNone/>
-            </a:pPr>
-            <a:endParaRPr/>
-          </a:p>
-        </p:txBody>
-      </p:sp>
-      <p:sp>
-        <p:nvSpPr>
           <p:cNvPr id="273" name="Google Shape;273;p18:notes">
             <a:extLst>
               <a:ext uri="{FF2B5EF4-FFF2-40B4-BE49-F238E27FC236}">
-                <a16:creationId xmlns:a16="http://schemas.microsoft.com/office/drawing/2014/main" id="{58797E72-A3BC-0A49-07C4-DE7FDA752365}"/>
-              </a:ext>
-            </a:extLst>
-          </p:cNvPr>
-          <p:cNvSpPr>
-            <a:spLocks noGrp="1" noRot="1" noChangeAspect="1"/>
-          </p:cNvSpPr>
-          <p:nvPr>
-            <p:ph type="sldImg" idx="2"/>
-          </p:nvPr>
-        </p:nvSpPr>
-        <p:spPr>
-          <a:xfrm>
-            <a:off x="381000" y="685800"/>
-            <a:ext cx="6096000" cy="3429000"/>
-          </a:xfrm>
-          <a:custGeom>
-            <a:avLst/>
-            <a:gdLst/>
-            <a:ahLst/>
-            <a:cxnLst/>
-            <a:rect l="l" t="t" r="r" b="b"/>
-            <a:pathLst>
-              <a:path w="120000" h="120000" extrusionOk="0">
-                <a:moveTo>
-                  <a:pt x="0" y="0"/>
-                </a:moveTo>
-                <a:lnTo>
-                  <a:pt x="120000" y="0"/>
-                </a:lnTo>
-                <a:lnTo>
-                  <a:pt x="120000" y="120000"/>
-                </a:lnTo>
-                <a:lnTo>
-                  <a:pt x="0" y="120000"/>
-                </a:lnTo>
-                <a:close/>
-              </a:path>
-            </a:pathLst>
-          </a:custGeom>
-        </p:spPr>
-      </p:sp>
-    </p:spTree>
-    <p:extLst>
-      <p:ext uri="{BB962C8B-B14F-4D97-AF65-F5344CB8AC3E}">
-        <p14:creationId xmlns:p14="http://schemas.microsoft.com/office/powerpoint/2010/main" val="1052078685"/>
-      </p:ext>
-    </p:extLst>
-  </p:cSld>
-  <p:clrMapOvr>
-    <a:masterClrMapping/>
-  </p:clrMapOvr>
-</p:notes>
-</file>
-
-<file path=ppt/notesSlides/notesSlide12.xml><?xml version="1.0" encoding="utf-8"?>
-<p:notes xmlns:a="http://schemas.openxmlformats.org/drawingml/2006/main" xmlns:r="http://schemas.openxmlformats.org/officeDocument/2006/relationships" xmlns:p="http://schemas.openxmlformats.org/presentationml/2006/main" showMasterSp="0" showMasterPhAnim="0">
-  <p:cSld>
-    <p:spTree>
-      <p:nvGrpSpPr>
-        <p:cNvPr id="1" name="Shape 271">
-          <a:extLst>
-            <a:ext uri="{FF2B5EF4-FFF2-40B4-BE49-F238E27FC236}">
-              <a16:creationId xmlns:a16="http://schemas.microsoft.com/office/drawing/2014/main" id="{466C47D1-19F6-52AF-3914-DD3C99058916}"/>
-            </a:ext>
-          </a:extLst>
-        </p:cNvPr>
-        <p:cNvGrpSpPr/>
-        <p:nvPr/>
-      </p:nvGrpSpPr>
-      <p:grpSpPr>
-        <a:xfrm>
-          <a:off x="0" y="0"/>
-          <a:ext cx="0" cy="0"/>
-          <a:chOff x="0" y="0"/>
-          <a:chExt cx="0" cy="0"/>
-        </a:xfrm>
-      </p:grpSpPr>
-      <p:sp>
-        <p:nvSpPr>
-          <p:cNvPr id="272" name="Google Shape;272;p18:notes">
-            <a:extLst>
-              <a:ext uri="{FF2B5EF4-FFF2-40B4-BE49-F238E27FC236}">
-                <a16:creationId xmlns:a16="http://schemas.microsoft.com/office/drawing/2014/main" id="{ACA1F779-4C2B-4CD1-FBDD-A40F0A322340}"/>
-              </a:ext>
-            </a:extLst>
-          </p:cNvPr>
-          <p:cNvSpPr txBox="1">
-            <a:spLocks noGrp="1"/>
-          </p:cNvSpPr>
-          <p:nvPr>
-            <p:ph type="body" idx="1"/>
-          </p:nvPr>
-        </p:nvSpPr>
-        <p:spPr>
-          <a:xfrm>
-            <a:off x="685800" y="4343400"/>
-            <a:ext cx="5486400" cy="4114800"/>
-          </a:xfrm>
-          <a:prstGeom prst="rect">
-            <a:avLst/>
-          </a:prstGeom>
-        </p:spPr>
-        <p:txBody>
-          <a:bodyPr spcFirstLastPara="1" wrap="square" lIns="91425" tIns="91425" rIns="91425" bIns="91425" anchor="t" anchorCtr="0">
-            <a:noAutofit/>
-          </a:bodyPr>
-          <a:lstStyle/>
-          <a:p>
-            <a:pPr marL="0" lvl="0" indent="0" algn="l" rtl="0">
-              <a:spcBef>
-                <a:spcPts val="0"/>
-              </a:spcBef>
-              <a:spcAft>
-                <a:spcPts val="0"/>
-              </a:spcAft>
-              <a:buNone/>
-            </a:pPr>
-            <a:endParaRPr/>
-          </a:p>
-        </p:txBody>
-      </p:sp>
-      <p:sp>
-        <p:nvSpPr>
-          <p:cNvPr id="273" name="Google Shape;273;p18:notes">
-            <a:extLst>
-              <a:ext uri="{FF2B5EF4-FFF2-40B4-BE49-F238E27FC236}">
-                <a16:creationId xmlns:a16="http://schemas.microsoft.com/office/drawing/2014/main" id="{40004D30-6E86-E263-D5DA-7577B1C759BC}"/>
+                <a16:creationId xmlns="" xmlns:a16="http://schemas.microsoft.com/office/drawing/2014/main" id="{40004D30-6E86-E263-D5DA-7577B1C759BC}"/>
               </a:ext>
             </a:extLst>
           </p:cNvPr>
@@ -1198,7 +947,7 @@
 </p:notes>
 </file>
 
-<file path=ppt/notesSlides/notesSlide13.xml><?xml version="1.0" encoding="utf-8"?>
+<file path=ppt/notesSlides/notesSlide11.xml><?xml version="1.0" encoding="utf-8"?>
 <p:notes xmlns:a="http://schemas.openxmlformats.org/drawingml/2006/main" xmlns:r="http://schemas.openxmlformats.org/officeDocument/2006/relationships" xmlns:p="http://schemas.openxmlformats.org/presentationml/2006/main" showMasterSp="0" showMasterPhAnim="0">
   <p:cSld>
     <p:spTree>
@@ -1310,7 +1059,7 @@
         <p:cNvPr id="1" name="Shape 100">
           <a:extLst>
             <a:ext uri="{FF2B5EF4-FFF2-40B4-BE49-F238E27FC236}">
-              <a16:creationId xmlns:a16="http://schemas.microsoft.com/office/drawing/2014/main" id="{48C2B95B-FB15-C156-6AF1-35B35818164E}"/>
+              <a16:creationId xmlns="" xmlns:a16="http://schemas.microsoft.com/office/drawing/2014/main" id="{48C2B95B-FB15-C156-6AF1-35B35818164E}"/>
             </a:ext>
           </a:extLst>
         </p:cNvPr>
@@ -1330,7 +1079,7 @@
           <p:cNvPr id="101" name="Google Shape;101;p3:notes">
             <a:extLst>
               <a:ext uri="{FF2B5EF4-FFF2-40B4-BE49-F238E27FC236}">
-                <a16:creationId xmlns:a16="http://schemas.microsoft.com/office/drawing/2014/main" id="{770A13E9-BC77-63DA-E106-A3FA8022811A}"/>
+                <a16:creationId xmlns="" xmlns:a16="http://schemas.microsoft.com/office/drawing/2014/main" id="{770A13E9-BC77-63DA-E106-A3FA8022811A}"/>
               </a:ext>
             </a:extLst>
           </p:cNvPr>
@@ -1374,7 +1123,7 @@
           <p:cNvPr id="102" name="Google Shape;102;p3:notes">
             <a:extLst>
               <a:ext uri="{FF2B5EF4-FFF2-40B4-BE49-F238E27FC236}">
-                <a16:creationId xmlns:a16="http://schemas.microsoft.com/office/drawing/2014/main" id="{29067B0F-2F4F-7081-A661-0AE31BFBB786}"/>
+                <a16:creationId xmlns="" xmlns:a16="http://schemas.microsoft.com/office/drawing/2014/main" id="{29067B0F-2F4F-7081-A661-0AE31BFBB786}"/>
               </a:ext>
             </a:extLst>
           </p:cNvPr>
@@ -1437,7 +1186,7 @@
         <p:cNvPr id="1" name="Shape 100">
           <a:extLst>
             <a:ext uri="{FF2B5EF4-FFF2-40B4-BE49-F238E27FC236}">
-              <a16:creationId xmlns:a16="http://schemas.microsoft.com/office/drawing/2014/main" id="{E37D20EF-0791-5303-F96E-0F0C1B50B73D}"/>
+              <a16:creationId xmlns="" xmlns:a16="http://schemas.microsoft.com/office/drawing/2014/main" id="{E37D20EF-0791-5303-F96E-0F0C1B50B73D}"/>
             </a:ext>
           </a:extLst>
         </p:cNvPr>
@@ -1457,7 +1206,7 @@
           <p:cNvPr id="101" name="Google Shape;101;p3:notes">
             <a:extLst>
               <a:ext uri="{FF2B5EF4-FFF2-40B4-BE49-F238E27FC236}">
-                <a16:creationId xmlns:a16="http://schemas.microsoft.com/office/drawing/2014/main" id="{9DCBA8EB-6D71-7B5E-841C-4BFFBDA5F1BE}"/>
+                <a16:creationId xmlns="" xmlns:a16="http://schemas.microsoft.com/office/drawing/2014/main" id="{9DCBA8EB-6D71-7B5E-841C-4BFFBDA5F1BE}"/>
               </a:ext>
             </a:extLst>
           </p:cNvPr>
@@ -1501,7 +1250,7 @@
           <p:cNvPr id="102" name="Google Shape;102;p3:notes">
             <a:extLst>
               <a:ext uri="{FF2B5EF4-FFF2-40B4-BE49-F238E27FC236}">
-                <a16:creationId xmlns:a16="http://schemas.microsoft.com/office/drawing/2014/main" id="{5C2CD162-5BE5-06C8-E06C-B4A49D4BCFF2}"/>
+                <a16:creationId xmlns="" xmlns:a16="http://schemas.microsoft.com/office/drawing/2014/main" id="{5C2CD162-5BE5-06C8-E06C-B4A49D4BCFF2}"/>
               </a:ext>
             </a:extLst>
           </p:cNvPr>
@@ -1564,7 +1313,7 @@
         <p:cNvPr id="1" name="Shape 197">
           <a:extLst>
             <a:ext uri="{FF2B5EF4-FFF2-40B4-BE49-F238E27FC236}">
-              <a16:creationId xmlns:a16="http://schemas.microsoft.com/office/drawing/2014/main" id="{11626E4B-E119-2382-6F8F-518641144E90}"/>
+              <a16:creationId xmlns="" xmlns:a16="http://schemas.microsoft.com/office/drawing/2014/main" id="{11626E4B-E119-2382-6F8F-518641144E90}"/>
             </a:ext>
           </a:extLst>
         </p:cNvPr>
@@ -1584,7 +1333,7 @@
           <p:cNvPr id="198" name="Google Shape;198;p10:notes">
             <a:extLst>
               <a:ext uri="{FF2B5EF4-FFF2-40B4-BE49-F238E27FC236}">
-                <a16:creationId xmlns:a16="http://schemas.microsoft.com/office/drawing/2014/main" id="{01A6FF9F-971F-6CD8-61F5-25638A5985F7}"/>
+                <a16:creationId xmlns="" xmlns:a16="http://schemas.microsoft.com/office/drawing/2014/main" id="{01A6FF9F-971F-6CD8-61F5-25638A5985F7}"/>
               </a:ext>
             </a:extLst>
           </p:cNvPr>
@@ -1628,7 +1377,7 @@
           <p:cNvPr id="199" name="Google Shape;199;p10:notes">
             <a:extLst>
               <a:ext uri="{FF2B5EF4-FFF2-40B4-BE49-F238E27FC236}">
-                <a16:creationId xmlns:a16="http://schemas.microsoft.com/office/drawing/2014/main" id="{C8EB5C80-6A4B-AE05-9BE0-03B5AF5C22AD}"/>
+                <a16:creationId xmlns="" xmlns:a16="http://schemas.microsoft.com/office/drawing/2014/main" id="{C8EB5C80-6A4B-AE05-9BE0-03B5AF5C22AD}"/>
               </a:ext>
             </a:extLst>
           </p:cNvPr>
@@ -1691,7 +1440,7 @@
         <p:cNvPr id="1" name="Shape 128">
           <a:extLst>
             <a:ext uri="{FF2B5EF4-FFF2-40B4-BE49-F238E27FC236}">
-              <a16:creationId xmlns:a16="http://schemas.microsoft.com/office/drawing/2014/main" id="{59B870D7-ED5B-C7CD-FB99-2991954CAA65}"/>
+              <a16:creationId xmlns="" xmlns:a16="http://schemas.microsoft.com/office/drawing/2014/main" id="{59B870D7-ED5B-C7CD-FB99-2991954CAA65}"/>
             </a:ext>
           </a:extLst>
         </p:cNvPr>
@@ -1711,7 +1460,7 @@
           <p:cNvPr id="129" name="Google Shape;129;p5:notes">
             <a:extLst>
               <a:ext uri="{FF2B5EF4-FFF2-40B4-BE49-F238E27FC236}">
-                <a16:creationId xmlns:a16="http://schemas.microsoft.com/office/drawing/2014/main" id="{C8B270BB-F67C-52E3-249C-6FE0C237CA97}"/>
+                <a16:creationId xmlns="" xmlns:a16="http://schemas.microsoft.com/office/drawing/2014/main" id="{C8B270BB-F67C-52E3-249C-6FE0C237CA97}"/>
               </a:ext>
             </a:extLst>
           </p:cNvPr>
@@ -1755,7 +1504,7 @@
           <p:cNvPr id="130" name="Google Shape;130;p5:notes">
             <a:extLst>
               <a:ext uri="{FF2B5EF4-FFF2-40B4-BE49-F238E27FC236}">
-                <a16:creationId xmlns:a16="http://schemas.microsoft.com/office/drawing/2014/main" id="{151B863E-6240-36E9-EB23-2DAA667D2518}"/>
+                <a16:creationId xmlns="" xmlns:a16="http://schemas.microsoft.com/office/drawing/2014/main" id="{151B863E-6240-36E9-EB23-2DAA667D2518}"/>
               </a:ext>
             </a:extLst>
           </p:cNvPr>
@@ -1815,133 +1564,6 @@
   <p:cSld>
     <p:spTree>
       <p:nvGrpSpPr>
-        <p:cNvPr id="1" name="Shape 170">
-          <a:extLst>
-            <a:ext uri="{FF2B5EF4-FFF2-40B4-BE49-F238E27FC236}">
-              <a16:creationId xmlns:a16="http://schemas.microsoft.com/office/drawing/2014/main" id="{279463AA-D7FA-5F7E-C4D0-06BDEDCBB932}"/>
-            </a:ext>
-          </a:extLst>
-        </p:cNvPr>
-        <p:cNvGrpSpPr/>
-        <p:nvPr/>
-      </p:nvGrpSpPr>
-      <p:grpSpPr>
-        <a:xfrm>
-          <a:off x="0" y="0"/>
-          <a:ext cx="0" cy="0"/>
-          <a:chOff x="0" y="0"/>
-          <a:chExt cx="0" cy="0"/>
-        </a:xfrm>
-      </p:grpSpPr>
-      <p:sp>
-        <p:nvSpPr>
-          <p:cNvPr id="171" name="Google Shape;171;p7:notes">
-            <a:extLst>
-              <a:ext uri="{FF2B5EF4-FFF2-40B4-BE49-F238E27FC236}">
-                <a16:creationId xmlns:a16="http://schemas.microsoft.com/office/drawing/2014/main" id="{A84E3171-2C5C-8738-5718-5608CE1B13A4}"/>
-              </a:ext>
-            </a:extLst>
-          </p:cNvPr>
-          <p:cNvSpPr txBox="1">
-            <a:spLocks noGrp="1"/>
-          </p:cNvSpPr>
-          <p:nvPr>
-            <p:ph type="body" idx="1"/>
-          </p:nvPr>
-        </p:nvSpPr>
-        <p:spPr>
-          <a:xfrm>
-            <a:off x="685800" y="4343400"/>
-            <a:ext cx="5486400" cy="4114800"/>
-          </a:xfrm>
-          <a:prstGeom prst="rect">
-            <a:avLst/>
-          </a:prstGeom>
-        </p:spPr>
-        <p:txBody>
-          <a:bodyPr spcFirstLastPara="1" wrap="square" lIns="91425" tIns="91425" rIns="91425" bIns="91425" anchor="t" anchorCtr="0">
-            <a:noAutofit/>
-          </a:bodyPr>
-          <a:lstStyle/>
-          <a:p>
-            <a:pPr marL="0" lvl="0" indent="0" algn="l" rtl="0">
-              <a:spcBef>
-                <a:spcPts val="0"/>
-              </a:spcBef>
-              <a:spcAft>
-                <a:spcPts val="0"/>
-              </a:spcAft>
-              <a:buNone/>
-            </a:pPr>
-            <a:endParaRPr/>
-          </a:p>
-        </p:txBody>
-      </p:sp>
-      <p:sp>
-        <p:nvSpPr>
-          <p:cNvPr id="172" name="Google Shape;172;p7:notes">
-            <a:extLst>
-              <a:ext uri="{FF2B5EF4-FFF2-40B4-BE49-F238E27FC236}">
-                <a16:creationId xmlns:a16="http://schemas.microsoft.com/office/drawing/2014/main" id="{E16E406D-2512-5EF2-0167-6C8953469546}"/>
-              </a:ext>
-            </a:extLst>
-          </p:cNvPr>
-          <p:cNvSpPr>
-            <a:spLocks noGrp="1" noRot="1" noChangeAspect="1"/>
-          </p:cNvSpPr>
-          <p:nvPr>
-            <p:ph type="sldImg" idx="2"/>
-          </p:nvPr>
-        </p:nvSpPr>
-        <p:spPr>
-          <a:xfrm>
-            <a:off x="381000" y="685800"/>
-            <a:ext cx="6096000" cy="3429000"/>
-          </a:xfrm>
-          <a:custGeom>
-            <a:avLst/>
-            <a:gdLst/>
-            <a:ahLst/>
-            <a:cxnLst/>
-            <a:rect l="l" t="t" r="r" b="b"/>
-            <a:pathLst>
-              <a:path w="120000" h="120000" extrusionOk="0">
-                <a:moveTo>
-                  <a:pt x="0" y="0"/>
-                </a:moveTo>
-                <a:lnTo>
-                  <a:pt x="120000" y="0"/>
-                </a:lnTo>
-                <a:lnTo>
-                  <a:pt x="120000" y="120000"/>
-                </a:lnTo>
-                <a:lnTo>
-                  <a:pt x="0" y="120000"/>
-                </a:lnTo>
-                <a:close/>
-              </a:path>
-            </a:pathLst>
-          </a:custGeom>
-        </p:spPr>
-      </p:sp>
-    </p:spTree>
-    <p:extLst>
-      <p:ext uri="{BB962C8B-B14F-4D97-AF65-F5344CB8AC3E}">
-        <p14:creationId xmlns:p14="http://schemas.microsoft.com/office/powerpoint/2010/main" val="3434966627"/>
-      </p:ext>
-    </p:extLst>
-  </p:cSld>
-  <p:clrMapOvr>
-    <a:masterClrMapping/>
-  </p:clrMapOvr>
-</p:notes>
-</file>
-
-<file path=ppt/notesSlides/notesSlide7.xml><?xml version="1.0" encoding="utf-8"?>
-<p:notes xmlns:a="http://schemas.openxmlformats.org/drawingml/2006/main" xmlns:r="http://schemas.openxmlformats.org/officeDocument/2006/relationships" xmlns:p="http://schemas.openxmlformats.org/presentationml/2006/main" showMasterSp="0" showMasterPhAnim="0">
-  <p:cSld>
-    <p:spTree>
-      <p:nvGrpSpPr>
         <p:cNvPr id="1" name="Shape 170"/>
         <p:cNvGrpSpPr/>
         <p:nvPr/>
@@ -2041,7 +1663,7 @@
 </p:notes>
 </file>
 
-<file path=ppt/notesSlides/notesSlide8.xml><?xml version="1.0" encoding="utf-8"?>
+<file path=ppt/notesSlides/notesSlide7.xml><?xml version="1.0" encoding="utf-8"?>
 <p:notes xmlns:a="http://schemas.openxmlformats.org/drawingml/2006/main" xmlns:r="http://schemas.openxmlformats.org/officeDocument/2006/relationships" xmlns:p="http://schemas.openxmlformats.org/presentationml/2006/main" showMasterSp="0" showMasterPhAnim="0">
   <p:cSld>
     <p:spTree>
@@ -2145,15 +1767,15 @@
 </p:notes>
 </file>
 
-<file path=ppt/notesSlides/notesSlide9.xml><?xml version="1.0" encoding="utf-8"?>
+<file path=ppt/notesSlides/notesSlide8.xml><?xml version="1.0" encoding="utf-8"?>
 <p:notes xmlns:a="http://schemas.openxmlformats.org/drawingml/2006/main" xmlns:r="http://schemas.openxmlformats.org/officeDocument/2006/relationships" xmlns:p="http://schemas.openxmlformats.org/presentationml/2006/main" showMasterSp="0" showMasterPhAnim="0">
   <p:cSld>
     <p:spTree>
       <p:nvGrpSpPr>
-        <p:cNvPr id="1" name="Shape 271">
+        <p:cNvPr id="1" name="Shape 197">
           <a:extLst>
             <a:ext uri="{FF2B5EF4-FFF2-40B4-BE49-F238E27FC236}">
-              <a16:creationId xmlns:a16="http://schemas.microsoft.com/office/drawing/2014/main" id="{FB18EFA4-CD13-16C4-504B-6DB7E86CE039}"/>
+              <a16:creationId xmlns="" xmlns:a16="http://schemas.microsoft.com/office/drawing/2014/main" id="{C2F88CF5-D0C3-0228-6C1A-E849738B9B34}"/>
             </a:ext>
           </a:extLst>
         </p:cNvPr>
@@ -2170,10 +1792,10 @@
       </p:grpSpPr>
       <p:sp>
         <p:nvSpPr>
-          <p:cNvPr id="272" name="Google Shape;272;p18:notes">
+          <p:cNvPr id="198" name="Google Shape;198;p10:notes">
             <a:extLst>
               <a:ext uri="{FF2B5EF4-FFF2-40B4-BE49-F238E27FC236}">
-                <a16:creationId xmlns:a16="http://schemas.microsoft.com/office/drawing/2014/main" id="{E8E16183-6BFA-E60A-1235-F3BFB1B1F6E4}"/>
+                <a16:creationId xmlns="" xmlns:a16="http://schemas.microsoft.com/office/drawing/2014/main" id="{15C41DBA-EB5E-9EB1-28D2-68EF3081A29D}"/>
               </a:ext>
             </a:extLst>
           </p:cNvPr>
@@ -2214,10 +1836,10 @@
       </p:sp>
       <p:sp>
         <p:nvSpPr>
-          <p:cNvPr id="273" name="Google Shape;273;p18:notes">
+          <p:cNvPr id="199" name="Google Shape;199;p10:notes">
             <a:extLst>
               <a:ext uri="{FF2B5EF4-FFF2-40B4-BE49-F238E27FC236}">
-                <a16:creationId xmlns:a16="http://schemas.microsoft.com/office/drawing/2014/main" id="{C4420B06-3455-3F20-5E28-90535F24DA27}"/>
+                <a16:creationId xmlns="" xmlns:a16="http://schemas.microsoft.com/office/drawing/2014/main" id="{9AACA92E-BC74-25E5-B8D5-2E658F81C2F0}"/>
               </a:ext>
             </a:extLst>
           </p:cNvPr>
@@ -2262,7 +1884,134 @@
     </p:spTree>
     <p:extLst>
       <p:ext uri="{BB962C8B-B14F-4D97-AF65-F5344CB8AC3E}">
-        <p14:creationId xmlns:p14="http://schemas.microsoft.com/office/powerpoint/2010/main" val="1965175327"/>
+        <p14:creationId xmlns:p14="http://schemas.microsoft.com/office/powerpoint/2010/main" val="1057587110"/>
+      </p:ext>
+    </p:extLst>
+  </p:cSld>
+  <p:clrMapOvr>
+    <a:masterClrMapping/>
+  </p:clrMapOvr>
+</p:notes>
+</file>
+
+<file path=ppt/notesSlides/notesSlide9.xml><?xml version="1.0" encoding="utf-8"?>
+<p:notes xmlns:a="http://schemas.openxmlformats.org/drawingml/2006/main" xmlns:r="http://schemas.openxmlformats.org/officeDocument/2006/relationships" xmlns:p="http://schemas.openxmlformats.org/presentationml/2006/main" showMasterSp="0" showMasterPhAnim="0">
+  <p:cSld>
+    <p:spTree>
+      <p:nvGrpSpPr>
+        <p:cNvPr id="1" name="Shape 271">
+          <a:extLst>
+            <a:ext uri="{FF2B5EF4-FFF2-40B4-BE49-F238E27FC236}">
+              <a16:creationId xmlns="" xmlns:a16="http://schemas.microsoft.com/office/drawing/2014/main" id="{A795C14E-5D6A-39A3-2018-2C72BB451BBD}"/>
+            </a:ext>
+          </a:extLst>
+        </p:cNvPr>
+        <p:cNvGrpSpPr/>
+        <p:nvPr/>
+      </p:nvGrpSpPr>
+      <p:grpSpPr>
+        <a:xfrm>
+          <a:off x="0" y="0"/>
+          <a:ext cx="0" cy="0"/>
+          <a:chOff x="0" y="0"/>
+          <a:chExt cx="0" cy="0"/>
+        </a:xfrm>
+      </p:grpSpPr>
+      <p:sp>
+        <p:nvSpPr>
+          <p:cNvPr id="272" name="Google Shape;272;p18:notes">
+            <a:extLst>
+              <a:ext uri="{FF2B5EF4-FFF2-40B4-BE49-F238E27FC236}">
+                <a16:creationId xmlns="" xmlns:a16="http://schemas.microsoft.com/office/drawing/2014/main" id="{85B8BB2F-0927-3841-AC64-CC67B5035869}"/>
+              </a:ext>
+            </a:extLst>
+          </p:cNvPr>
+          <p:cNvSpPr txBox="1">
+            <a:spLocks noGrp="1"/>
+          </p:cNvSpPr>
+          <p:nvPr>
+            <p:ph type="body" idx="1"/>
+          </p:nvPr>
+        </p:nvSpPr>
+        <p:spPr>
+          <a:xfrm>
+            <a:off x="685800" y="4343400"/>
+            <a:ext cx="5486400" cy="4114800"/>
+          </a:xfrm>
+          <a:prstGeom prst="rect">
+            <a:avLst/>
+          </a:prstGeom>
+        </p:spPr>
+        <p:txBody>
+          <a:bodyPr spcFirstLastPara="1" wrap="square" lIns="91425" tIns="91425" rIns="91425" bIns="91425" anchor="t" anchorCtr="0">
+            <a:noAutofit/>
+          </a:bodyPr>
+          <a:lstStyle/>
+          <a:p>
+            <a:pPr marL="0" lvl="0" indent="0" algn="l" rtl="0">
+              <a:spcBef>
+                <a:spcPts val="0"/>
+              </a:spcBef>
+              <a:spcAft>
+                <a:spcPts val="0"/>
+              </a:spcAft>
+              <a:buNone/>
+            </a:pPr>
+            <a:endParaRPr/>
+          </a:p>
+        </p:txBody>
+      </p:sp>
+      <p:sp>
+        <p:nvSpPr>
+          <p:cNvPr id="273" name="Google Shape;273;p18:notes">
+            <a:extLst>
+              <a:ext uri="{FF2B5EF4-FFF2-40B4-BE49-F238E27FC236}">
+                <a16:creationId xmlns="" xmlns:a16="http://schemas.microsoft.com/office/drawing/2014/main" id="{58797E72-A3BC-0A49-07C4-DE7FDA752365}"/>
+              </a:ext>
+            </a:extLst>
+          </p:cNvPr>
+          <p:cNvSpPr>
+            <a:spLocks noGrp="1" noRot="1" noChangeAspect="1"/>
+          </p:cNvSpPr>
+          <p:nvPr>
+            <p:ph type="sldImg" idx="2"/>
+          </p:nvPr>
+        </p:nvSpPr>
+        <p:spPr>
+          <a:xfrm>
+            <a:off x="381000" y="685800"/>
+            <a:ext cx="6096000" cy="3429000"/>
+          </a:xfrm>
+          <a:custGeom>
+            <a:avLst/>
+            <a:gdLst/>
+            <a:ahLst/>
+            <a:cxnLst/>
+            <a:rect l="l" t="t" r="r" b="b"/>
+            <a:pathLst>
+              <a:path w="120000" h="120000" extrusionOk="0">
+                <a:moveTo>
+                  <a:pt x="0" y="0"/>
+                </a:moveTo>
+                <a:lnTo>
+                  <a:pt x="120000" y="0"/>
+                </a:lnTo>
+                <a:lnTo>
+                  <a:pt x="120000" y="120000"/>
+                </a:lnTo>
+                <a:lnTo>
+                  <a:pt x="0" y="120000"/>
+                </a:lnTo>
+                <a:close/>
+              </a:path>
+            </a:pathLst>
+          </a:custGeom>
+        </p:spPr>
+      </p:sp>
+    </p:spTree>
+    <p:extLst>
+      <p:ext uri="{BB962C8B-B14F-4D97-AF65-F5344CB8AC3E}">
+        <p14:creationId xmlns:p14="http://schemas.microsoft.com/office/powerpoint/2010/main" val="1052078685"/>
       </p:ext>
     </p:extLst>
   </p:cSld>
@@ -11790,7 +11539,7 @@
           <p:cNvPr id="2" name="Title 1">
             <a:extLst>
               <a:ext uri="{FF2B5EF4-FFF2-40B4-BE49-F238E27FC236}">
-                <a16:creationId xmlns:a16="http://schemas.microsoft.com/office/drawing/2014/main" id="{9AF97BF8-B3EC-77A2-9BFD-D66830272D56}"/>
+                <a16:creationId xmlns="" xmlns:a16="http://schemas.microsoft.com/office/drawing/2014/main" id="{9AF97BF8-B3EC-77A2-9BFD-D66830272D56}"/>
               </a:ext>
             </a:extLst>
           </p:cNvPr>
@@ -11803,20 +11552,24 @@
         </p:nvSpPr>
         <p:spPr/>
         <p:txBody>
-          <a:bodyPr>
+          <a:bodyPr wrap="square">
             <a:normAutofit/>
           </a:bodyPr>
           <a:lstStyle/>
           <a:p>
             <a:pPr algn="ctr"/>
             <a:r>
-              <a:rPr lang="en-US" sz="6600" b="1"/>
+              <a:rPr lang="en-US" sz="5280" b="1" dirty="0"/>
               <a:t>IBM University Engagement Project Submission</a:t>
             </a:r>
+            <a:r>
+              <a:rPr lang="en-US" b="1" dirty="0"/>
+              <a:t/>
+            </a:r>
             <a:br>
-              <a:rPr lang="en-US" b="1"/>
+              <a:rPr lang="en-US" b="1" dirty="0"/>
             </a:br>
-            <a:endParaRPr lang="en-IN"/>
+            <a:endParaRPr lang="en-IN" dirty="0"/>
           </a:p>
         </p:txBody>
       </p:sp>
@@ -11825,7 +11578,7 @@
           <p:cNvPr id="3" name="Text Placeholder 2">
             <a:extLst>
               <a:ext uri="{FF2B5EF4-FFF2-40B4-BE49-F238E27FC236}">
-                <a16:creationId xmlns:a16="http://schemas.microsoft.com/office/drawing/2014/main" id="{FFAB85A1-2169-FF43-3E91-E2E8ADA742FF}"/>
+                <a16:creationId xmlns="" xmlns:a16="http://schemas.microsoft.com/office/drawing/2014/main" id="{FFAB85A1-2169-FF43-3E91-E2E8ADA742FF}"/>
               </a:ext>
             </a:extLst>
           </p:cNvPr>
@@ -11843,7 +11596,9 @@
           </a:xfrm>
         </p:spPr>
         <p:txBody>
-          <a:bodyPr/>
+          <a:bodyPr wrap="square">
+            <a:normAutofit/>
+          </a:bodyPr>
           <a:lstStyle/>
           <a:p>
             <a:pPr algn="ctr"/>
@@ -11853,7 +11608,7 @@
             </a:r>
             <a:r>
               <a:rPr lang="en-US" b="1" i="1" err="1"/>
-              <a:t>LangFlow</a:t>
+              <a:t>FastAPI</a:t>
             </a:r>
             <a:r>
               <a:rPr lang="en-US" b="1" i="1"/>
@@ -11884,7 +11639,7 @@
         <p:cNvPr id="1" name="Shape 274">
           <a:extLst>
             <a:ext uri="{FF2B5EF4-FFF2-40B4-BE49-F238E27FC236}">
-              <a16:creationId xmlns:a16="http://schemas.microsoft.com/office/drawing/2014/main" id="{55016524-E738-3D8C-3BB2-B0BE7C665318}"/>
+              <a16:creationId xmlns="" xmlns:a16="http://schemas.microsoft.com/office/drawing/2014/main" id="{7BB3C0CA-2F24-30DF-1D65-4440B864F08E}"/>
             </a:ext>
           </a:extLst>
         </p:cNvPr>
@@ -11904,7 +11659,7 @@
           <p:cNvPr id="278" name="Google Shape;278;p18">
             <a:extLst>
               <a:ext uri="{FF2B5EF4-FFF2-40B4-BE49-F238E27FC236}">
-                <a16:creationId xmlns:a16="http://schemas.microsoft.com/office/drawing/2014/main" id="{D62F03A8-A8A8-CB93-006E-7173DC866F6F}"/>
+                <a16:creationId xmlns="" xmlns:a16="http://schemas.microsoft.com/office/drawing/2014/main" id="{187EEB9C-2E84-113A-3CE6-1507BF5B039F}"/>
               </a:ext>
             </a:extLst>
           </p:cNvPr>
@@ -11913,7 +11668,7 @@
         </p:nvSpPr>
         <p:spPr>
           <a:xfrm>
-            <a:off x="793192" y="341560"/>
+            <a:off x="1218724" y="420729"/>
             <a:ext cx="6444496" cy="704017"/>
           </a:xfrm>
           <a:prstGeom prst="rect">
@@ -11926,11 +11681,48 @@
         </p:spPr>
         <p:txBody>
           <a:bodyPr spcFirstLastPara="1" wrap="square" lIns="0" tIns="0" rIns="0" bIns="0" anchor="t" anchorCtr="0">
-            <a:noAutofit/>
+            <a:normAutofit/>
           </a:bodyPr>
           <a:lstStyle/>
           <a:p>
-            <a:pPr>
+            <a:pPr marL="0" marR="0" lvl="0" indent="0" algn="l" rtl="0">
+              <a:lnSpc>
+                <a:spcPct val="157142"/>
+              </a:lnSpc>
+              <a:spcBef>
+                <a:spcPts val="0"/>
+              </a:spcBef>
+              <a:spcAft>
+                <a:spcPts val="0"/>
+              </a:spcAft>
+              <a:buClr>
+                <a:srgbClr val="051D3A"/>
+              </a:buClr>
+              <a:buSzPts val="3500"/>
+              <a:buFont typeface="Times New Roman"/>
+              <a:buNone/>
+            </a:pPr>
+            <a:r>
+              <a:rPr lang="en-US" sz="1920" b="1" dirty="0" err="1">
+                <a:sym typeface="Times New Roman"/>
+              </a:rPr>
+              <a:t>Git</a:t>
+            </a:r>
+            <a:r>
+              <a:rPr lang="en-US" sz="1920" b="1" dirty="0">
+                <a:sym typeface="Times New Roman"/>
+              </a:rPr>
+              <a:t> Hub </a:t>
+            </a:r>
+            <a:r>
+              <a:rPr lang="en-US" sz="1920" b="1" dirty="0" smtClean="0">
+                <a:sym typeface="Times New Roman"/>
+              </a:rPr>
+              <a:t>Link:</a:t>
+            </a:r>
+          </a:p>
+          <a:p>
+            <a:pPr lvl="0">
               <a:lnSpc>
                 <a:spcPct val="157142"/>
               </a:lnSpc>
@@ -11940,12 +11732,72 @@
               <a:buSzPts val="3500"/>
             </a:pPr>
             <a:r>
-              <a:rPr lang="en-US" sz="2400" b="1">
+              <a:rPr lang="en-IN" b="1" dirty="0">
                 <a:sym typeface="Times New Roman"/>
               </a:rPr>
-              <a:t>Token Usage </a:t>
-            </a:r>
-            <a:endParaRPr sz="2400" b="1">
+              <a:t>https://github.com/Asqi06/IBMhack</a:t>
+            </a:r>
+            <a:endParaRPr b="1" dirty="0">
+              <a:sym typeface="Times New Roman"/>
+            </a:endParaRPr>
+          </a:p>
+        </p:txBody>
+      </p:sp>
+      <p:sp>
+        <p:nvSpPr>
+          <p:cNvPr id="279" name="Google Shape;279;p18">
+            <a:extLst>
+              <a:ext uri="{FF2B5EF4-FFF2-40B4-BE49-F238E27FC236}">
+                <a16:creationId xmlns="" xmlns:a16="http://schemas.microsoft.com/office/drawing/2014/main" id="{3711AF54-94A6-B837-31EF-9A8C4ECB9AF6}"/>
+              </a:ext>
+            </a:extLst>
+          </p:cNvPr>
+          <p:cNvSpPr/>
+          <p:nvPr/>
+        </p:nvSpPr>
+        <p:spPr>
+          <a:xfrm>
+            <a:off x="1218724" y="1153712"/>
+            <a:ext cx="9214580" cy="4277001"/>
+          </a:xfrm>
+          <a:prstGeom prst="rect">
+            <a:avLst/>
+          </a:prstGeom>
+          <a:noFill/>
+          <a:ln>
+            <a:noFill/>
+          </a:ln>
+        </p:spPr>
+        <p:txBody>
+          <a:bodyPr spcFirstLastPara="1" wrap="square" lIns="0" tIns="0" rIns="0" bIns="0" anchor="t" anchorCtr="0">
+            <a:normAutofit/>
+          </a:bodyPr>
+          <a:lstStyle/>
+          <a:p>
+            <a:pPr marL="0" marR="0" lvl="0" indent="0" algn="l" rtl="0">
+              <a:lnSpc>
+                <a:spcPct val="162162"/>
+              </a:lnSpc>
+              <a:spcBef>
+                <a:spcPts val="0"/>
+              </a:spcBef>
+              <a:spcAft>
+                <a:spcPts val="0"/>
+              </a:spcAft>
+              <a:buClr>
+                <a:srgbClr val="2B3541"/>
+              </a:buClr>
+              <a:buSzPts val="1850"/>
+              <a:buFont typeface="Times New Roman"/>
+              <a:buNone/>
+            </a:pPr>
+            <a:endParaRPr sz="1850" b="0" i="0" u="none" strike="noStrike" cap="none" dirty="0">
+              <a:solidFill>
+                <a:srgbClr val="000000"/>
+              </a:solidFill>
+              <a:latin typeface="Times New Roman"/>
+              <a:ea typeface="Times New Roman"/>
+              <a:cs typeface="Times New Roman"/>
               <a:sym typeface="Times New Roman"/>
             </a:endParaRPr>
           </a:p>
@@ -11956,7 +11808,7 @@
           <p:cNvPr id="280" name="Google Shape;280;p18">
             <a:extLst>
               <a:ext uri="{FF2B5EF4-FFF2-40B4-BE49-F238E27FC236}">
-                <a16:creationId xmlns:a16="http://schemas.microsoft.com/office/drawing/2014/main" id="{A4423EF4-BB52-2693-03DD-9F7D92D05218}"/>
+                <a16:creationId xmlns="" xmlns:a16="http://schemas.microsoft.com/office/drawing/2014/main" id="{E228982D-BF81-530A-CBA1-E897A3CA8EF7}"/>
               </a:ext>
             </a:extLst>
           </p:cNvPr>
@@ -11978,7 +11830,7 @@
         </p:spPr>
         <p:txBody>
           <a:bodyPr spcFirstLastPara="1" wrap="square" lIns="0" tIns="0" rIns="0" bIns="0" anchor="t" anchorCtr="0">
-            <a:noAutofit/>
+            <a:normAutofit/>
           </a:bodyPr>
           <a:lstStyle/>
           <a:p>
@@ -12000,7 +11852,7 @@
               <a:buNone/>
             </a:pPr>
             <a:r>
-              <a:rPr lang="en-US" sz="1850" b="0" i="0" u="none" strike="noStrike" cap="none">
+              <a:rPr lang="en-US" sz="1480" b="0" i="0" u="none" strike="noStrike" cap="none">
                 <a:solidFill>
                   <a:srgbClr val="2B3541"/>
                 </a:solidFill>
@@ -12028,7 +11880,7 @@
           <p:cNvPr id="281" name="Google Shape;281;p18">
             <a:extLst>
               <a:ext uri="{FF2B5EF4-FFF2-40B4-BE49-F238E27FC236}">
-                <a16:creationId xmlns:a16="http://schemas.microsoft.com/office/drawing/2014/main" id="{FF042814-8077-DBD5-E8B6-E0D870CADB86}"/>
+                <a16:creationId xmlns="" xmlns:a16="http://schemas.microsoft.com/office/drawing/2014/main" id="{7BC356B8-92F8-3187-D065-667AACF68E72}"/>
               </a:ext>
             </a:extLst>
           </p:cNvPr>
@@ -12050,7 +11902,7 @@
         </p:spPr>
         <p:txBody>
           <a:bodyPr spcFirstLastPara="1" wrap="square" lIns="0" tIns="0" rIns="0" bIns="0" anchor="t" anchorCtr="0">
-            <a:noAutofit/>
+            <a:normAutofit/>
           </a:bodyPr>
           <a:lstStyle/>
           <a:p>
@@ -12072,7 +11924,7 @@
               <a:buNone/>
             </a:pPr>
             <a:r>
-              <a:rPr lang="en-US" sz="1850" b="0" i="0" u="none" strike="noStrike" cap="none">
+              <a:rPr lang="en-US" sz="1480" b="0" i="0" u="none" strike="noStrike" cap="none">
                 <a:solidFill>
                   <a:srgbClr val="2B3541"/>
                 </a:solidFill>
@@ -12100,7 +11952,7 @@
           <p:cNvPr id="282" name="Google Shape;282;p18">
             <a:extLst>
               <a:ext uri="{FF2B5EF4-FFF2-40B4-BE49-F238E27FC236}">
-                <a16:creationId xmlns:a16="http://schemas.microsoft.com/office/drawing/2014/main" id="{6A2761AF-8A54-98F2-52C2-794D9BA61C92}"/>
+                <a16:creationId xmlns="" xmlns:a16="http://schemas.microsoft.com/office/drawing/2014/main" id="{1558A011-60D6-B010-6117-1B9F7C786B2B}"/>
               </a:ext>
             </a:extLst>
           </p:cNvPr>
@@ -12122,7 +11974,7 @@
         </p:spPr>
         <p:txBody>
           <a:bodyPr spcFirstLastPara="1" wrap="square" lIns="0" tIns="0" rIns="0" bIns="0" anchor="t" anchorCtr="0">
-            <a:noAutofit/>
+            <a:normAutofit/>
           </a:bodyPr>
           <a:lstStyle/>
           <a:p>
@@ -12144,7 +11996,7 @@
               <a:buNone/>
             </a:pPr>
             <a:r>
-              <a:rPr lang="en-US" sz="1850" b="0" i="0" u="none" strike="noStrike" cap="none">
+              <a:rPr lang="en-US" sz="1480" b="0" i="0" u="none" strike="noStrike" cap="none">
                 <a:solidFill>
                   <a:srgbClr val="2B3541"/>
                 </a:solidFill>
@@ -12167,184 +12019,10 @@
           </a:p>
         </p:txBody>
       </p:sp>
-      <p:sp>
-        <p:nvSpPr>
-          <p:cNvPr id="5" name="TextBox 4">
-            <a:extLst>
-              <a:ext uri="{FF2B5EF4-FFF2-40B4-BE49-F238E27FC236}">
-                <a16:creationId xmlns:a16="http://schemas.microsoft.com/office/drawing/2014/main" id="{1BD576A0-BF64-32B6-1E59-49AA2C59C5CE}"/>
-              </a:ext>
-            </a:extLst>
-          </p:cNvPr>
-          <p:cNvSpPr txBox="1"/>
-          <p:nvPr/>
-        </p:nvSpPr>
-        <p:spPr>
-          <a:xfrm>
-            <a:off x="897392" y="1042133"/>
-            <a:ext cx="4371171" cy="307777"/>
-          </a:xfrm>
-          <a:prstGeom prst="rect">
-            <a:avLst/>
-          </a:prstGeom>
-          <a:noFill/>
-        </p:spPr>
-        <p:txBody>
-          <a:bodyPr rot="0" spcFirstLastPara="0" vertOverflow="overflow" horzOverflow="overflow" vert="horz" wrap="square" lIns="91440" tIns="45720" rIns="91440" bIns="45720" numCol="1" spcCol="0" rtlCol="0" fromWordArt="0" anchor="t" anchorCtr="0" forceAA="0" compatLnSpc="1">
-            <a:prstTxWarp prst="textNoShape">
-              <a:avLst/>
-            </a:prstTxWarp>
-            <a:spAutoFit/>
-          </a:bodyPr>
-          <a:lstStyle/>
-          <a:p>
-            <a:r>
-              <a:rPr lang="en-US"/>
-              <a:t>11,761 token are used</a:t>
-            </a:r>
-          </a:p>
-        </p:txBody>
-      </p:sp>
-      <p:pic>
-        <p:nvPicPr>
-          <p:cNvPr id="12" name="Picture 11" descr="A screenshot of a computer&#10;&#10;AI-generated content may be incorrect.">
-            <a:extLst>
-              <a:ext uri="{FF2B5EF4-FFF2-40B4-BE49-F238E27FC236}">
-                <a16:creationId xmlns:a16="http://schemas.microsoft.com/office/drawing/2014/main" id="{3E29AF1D-88C4-87E5-74DF-4E97121E06CE}"/>
-              </a:ext>
-            </a:extLst>
-          </p:cNvPr>
-          <p:cNvPicPr>
-            <a:picLocks noChangeAspect="1"/>
-          </p:cNvPicPr>
-          <p:nvPr/>
-        </p:nvPicPr>
-        <p:blipFill>
-          <a:blip r:embed="rId3"/>
-          <a:stretch>
-            <a:fillRect/>
-          </a:stretch>
-        </p:blipFill>
-        <p:spPr>
-          <a:xfrm>
-            <a:off x="114240" y="2453592"/>
-            <a:ext cx="5095875" cy="2857500"/>
-          </a:xfrm>
-          <a:prstGeom prst="rect">
-            <a:avLst/>
-          </a:prstGeom>
-        </p:spPr>
-      </p:pic>
-      <p:pic>
-        <p:nvPicPr>
-          <p:cNvPr id="13" name="Picture 12" descr="A screenshot of a computer&#10;&#10;AI-generated content may be incorrect.">
-            <a:extLst>
-              <a:ext uri="{FF2B5EF4-FFF2-40B4-BE49-F238E27FC236}">
-                <a16:creationId xmlns:a16="http://schemas.microsoft.com/office/drawing/2014/main" id="{C81444F5-0692-DD67-1759-70821E53B029}"/>
-              </a:ext>
-            </a:extLst>
-          </p:cNvPr>
-          <p:cNvPicPr>
-            <a:picLocks noChangeAspect="1"/>
-          </p:cNvPicPr>
-          <p:nvPr/>
-        </p:nvPicPr>
-        <p:blipFill>
-          <a:blip r:embed="rId4"/>
-          <a:stretch>
-            <a:fillRect/>
-          </a:stretch>
-        </p:blipFill>
-        <p:spPr>
-          <a:xfrm>
-            <a:off x="6159601" y="2451181"/>
-            <a:ext cx="5724525" cy="2857500"/>
-          </a:xfrm>
-          <a:prstGeom prst="rect">
-            <a:avLst/>
-          </a:prstGeom>
-        </p:spPr>
-      </p:pic>
-      <p:sp>
-        <p:nvSpPr>
-          <p:cNvPr id="14" name="TextBox 13">
-            <a:extLst>
-              <a:ext uri="{FF2B5EF4-FFF2-40B4-BE49-F238E27FC236}">
-                <a16:creationId xmlns:a16="http://schemas.microsoft.com/office/drawing/2014/main" id="{7B8E599E-5B1D-59CD-4F1D-CEF8D0CA327B}"/>
-              </a:ext>
-            </a:extLst>
-          </p:cNvPr>
-          <p:cNvSpPr txBox="1"/>
-          <p:nvPr/>
-        </p:nvSpPr>
-        <p:spPr>
-          <a:xfrm>
-            <a:off x="1278639" y="1718067"/>
-            <a:ext cx="2743199" cy="400110"/>
-          </a:xfrm>
-          <a:prstGeom prst="rect">
-            <a:avLst/>
-          </a:prstGeom>
-          <a:noFill/>
-        </p:spPr>
-        <p:txBody>
-          <a:bodyPr rot="0" spcFirstLastPara="0" vertOverflow="overflow" horzOverflow="overflow" vert="horz" wrap="square" lIns="91440" tIns="45720" rIns="91440" bIns="45720" numCol="1" spcCol="0" rtlCol="0" fromWordArt="0" anchor="t" anchorCtr="0" forceAA="0" compatLnSpc="1">
-            <a:prstTxWarp prst="textNoShape">
-              <a:avLst/>
-            </a:prstTxWarp>
-            <a:spAutoFit/>
-          </a:bodyPr>
-          <a:lstStyle/>
-          <a:p>
-            <a:r>
-              <a:rPr lang="en-US" sz="2000" u="sng"/>
-              <a:t>Before Prompt</a:t>
-            </a:r>
-          </a:p>
-        </p:txBody>
-      </p:sp>
-      <p:sp>
-        <p:nvSpPr>
-          <p:cNvPr id="15" name="TextBox 14">
-            <a:extLst>
-              <a:ext uri="{FF2B5EF4-FFF2-40B4-BE49-F238E27FC236}">
-                <a16:creationId xmlns:a16="http://schemas.microsoft.com/office/drawing/2014/main" id="{B22EA981-5113-2D05-C1A2-169306E1D47C}"/>
-              </a:ext>
-            </a:extLst>
-          </p:cNvPr>
-          <p:cNvSpPr txBox="1"/>
-          <p:nvPr/>
-        </p:nvSpPr>
-        <p:spPr>
-          <a:xfrm>
-            <a:off x="7106828" y="1722919"/>
-            <a:ext cx="2743199" cy="400110"/>
-          </a:xfrm>
-          <a:prstGeom prst="rect">
-            <a:avLst/>
-          </a:prstGeom>
-          <a:noFill/>
-        </p:spPr>
-        <p:txBody>
-          <a:bodyPr rot="0" spcFirstLastPara="0" vertOverflow="overflow" horzOverflow="overflow" vert="horz" wrap="square" lIns="91440" tIns="45720" rIns="91440" bIns="45720" numCol="1" spcCol="0" rtlCol="0" fromWordArt="0" anchor="t" anchorCtr="0" forceAA="0" compatLnSpc="1">
-            <a:prstTxWarp prst="textNoShape">
-              <a:avLst/>
-            </a:prstTxWarp>
-            <a:spAutoFit/>
-          </a:bodyPr>
-          <a:lstStyle/>
-          <a:p>
-            <a:r>
-              <a:rPr lang="en-US" sz="2000" u="sng"/>
-              <a:t>After the Prompt</a:t>
-            </a:r>
-          </a:p>
-        </p:txBody>
-      </p:sp>
     </p:spTree>
     <p:extLst>
       <p:ext uri="{BB962C8B-B14F-4D97-AF65-F5344CB8AC3E}">
-        <p14:creationId xmlns:p14="http://schemas.microsoft.com/office/powerpoint/2010/main" val="2115484872"/>
+        <p14:creationId xmlns:p14="http://schemas.microsoft.com/office/powerpoint/2010/main" val="2605851928"/>
       </p:ext>
     </p:extLst>
   </p:cSld>
@@ -12359,243 +12037,10 @@
   <p:cSld>
     <p:spTree>
       <p:nvGrpSpPr>
-        <p:cNvPr id="1" name="Shape 200">
-          <a:extLst>
-            <a:ext uri="{FF2B5EF4-FFF2-40B4-BE49-F238E27FC236}">
-              <a16:creationId xmlns:a16="http://schemas.microsoft.com/office/drawing/2014/main" id="{EEDEC80F-FA4E-F3FF-DE90-87B861D0BD13}"/>
-            </a:ext>
-          </a:extLst>
-        </p:cNvPr>
-        <p:cNvGrpSpPr/>
-        <p:nvPr/>
-      </p:nvGrpSpPr>
-      <p:grpSpPr>
-        <a:xfrm>
-          <a:off x="0" y="0"/>
-          <a:ext cx="0" cy="0"/>
-          <a:chOff x="0" y="0"/>
-          <a:chExt cx="0" cy="0"/>
-        </a:xfrm>
-      </p:grpSpPr>
-      <p:sp>
-        <p:nvSpPr>
-          <p:cNvPr id="2" name="TextBox 1">
-            <a:extLst>
-              <a:ext uri="{FF2B5EF4-FFF2-40B4-BE49-F238E27FC236}">
-                <a16:creationId xmlns:a16="http://schemas.microsoft.com/office/drawing/2014/main" id="{6FA184BA-BCF2-3D7B-30D0-0F3CF30C161B}"/>
-              </a:ext>
-            </a:extLst>
-          </p:cNvPr>
-          <p:cNvSpPr txBox="1"/>
-          <p:nvPr/>
-        </p:nvSpPr>
-        <p:spPr>
-          <a:xfrm>
-            <a:off x="777240" y="484632"/>
-            <a:ext cx="7123176" cy="461665"/>
-          </a:xfrm>
-          <a:prstGeom prst="rect">
-            <a:avLst/>
-          </a:prstGeom>
-          <a:noFill/>
-        </p:spPr>
-        <p:txBody>
-          <a:bodyPr wrap="square" rtlCol="0">
-            <a:spAutoFit/>
-          </a:bodyPr>
-          <a:lstStyle/>
-          <a:p>
-            <a:r>
-              <a:rPr lang="en-US" sz="2400" b="1"/>
-              <a:t>Novelty and Uniqueness</a:t>
-            </a:r>
-            <a:endParaRPr lang="en-IN" sz="2400" b="1"/>
-          </a:p>
-        </p:txBody>
-      </p:sp>
-      <p:sp>
-        <p:nvSpPr>
-          <p:cNvPr id="3" name="TextBox 2">
-            <a:extLst>
-              <a:ext uri="{FF2B5EF4-FFF2-40B4-BE49-F238E27FC236}">
-                <a16:creationId xmlns:a16="http://schemas.microsoft.com/office/drawing/2014/main" id="{ED65F54F-855A-0DB6-09A6-3212C5F7405B}"/>
-              </a:ext>
-            </a:extLst>
-          </p:cNvPr>
-          <p:cNvSpPr txBox="1"/>
-          <p:nvPr/>
-        </p:nvSpPr>
-        <p:spPr>
-          <a:xfrm>
-            <a:off x="777240" y="1207008"/>
-            <a:ext cx="11301984" cy="5293757"/>
-          </a:xfrm>
-          <a:prstGeom prst="rect">
-            <a:avLst/>
-          </a:prstGeom>
-          <a:noFill/>
-        </p:spPr>
-        <p:txBody>
-          <a:bodyPr wrap="square" rtlCol="0">
-            <a:spAutoFit/>
-          </a:bodyPr>
-          <a:lstStyle/>
-          <a:p>
-            <a:r>
-              <a:rPr lang="en-IN" sz="1800"/>
-              <a:t>The proposed Nutrition Agent stands out by combining </a:t>
-            </a:r>
-            <a:r>
-              <a:rPr lang="en-IN" sz="1800" b="1"/>
-              <a:t>Agentic AI, RAG, and personalization</a:t>
-            </a:r>
-            <a:r>
-              <a:rPr lang="en-IN" sz="1800"/>
-              <a:t> into a single intelligent system.</a:t>
-            </a:r>
-          </a:p>
-          <a:p>
-            <a:endParaRPr lang="en-IN" sz="1800"/>
-          </a:p>
-          <a:p>
-            <a:r>
-              <a:rPr lang="en-IN" sz="1800" b="1"/>
-              <a:t>Multi-Agent Intelligence</a:t>
-            </a:r>
-            <a:r>
-              <a:rPr lang="en-IN" sz="1800"/>
-              <a:t> – Instead of a single chatbot, multiple specialized agents collaborate to deliver accurate and context-aware nutrition guidance. </a:t>
-            </a:r>
-          </a:p>
-          <a:p>
-            <a:r>
-              <a:rPr lang="en-IN" sz="1800" b="1"/>
-              <a:t>RAG-Based Accuracy</a:t>
-            </a:r>
-            <a:r>
-              <a:rPr lang="en-IN" sz="1800"/>
-              <a:t> – Integrates real-time data retrieval with AI generation, reducing misinformation and ensuring trustworthy recommendations. </a:t>
-            </a:r>
-          </a:p>
-          <a:p>
-            <a:r>
-              <a:rPr lang="en-IN" sz="1800" b="1"/>
-              <a:t>Hyper-Personalization</a:t>
-            </a:r>
-            <a:r>
-              <a:rPr lang="en-IN" sz="1800"/>
-              <a:t> – Tailors diet plans based on health conditions, cultural preferences, and fitness goals. </a:t>
-            </a:r>
-          </a:p>
-          <a:p>
-            <a:r>
-              <a:rPr lang="en-IN" sz="1800" b="1"/>
-              <a:t>Real-Time Feedback Loop</a:t>
-            </a:r>
-            <a:r>
-              <a:rPr lang="en-IN" sz="1800"/>
-              <a:t> – Continuously adapts recommendations based on daily food logs and user </a:t>
-            </a:r>
-            <a:r>
-              <a:rPr lang="en-IN" sz="1800" err="1"/>
-              <a:t>behavior</a:t>
-            </a:r>
-            <a:r>
-              <a:rPr lang="en-IN" sz="1800"/>
-              <a:t>. </a:t>
-            </a:r>
-          </a:p>
-          <a:p>
-            <a:r>
-              <a:rPr lang="en-IN" sz="1800" b="1"/>
-              <a:t>Multi-Modal Input</a:t>
-            </a:r>
-            <a:r>
-              <a:rPr lang="en-IN" sz="1800"/>
-              <a:t> – Supports text, voice, and image-based meal tracking for better usability. </a:t>
-            </a:r>
-          </a:p>
-          <a:p>
-            <a:r>
-              <a:rPr lang="en-IN" sz="1800" b="1"/>
-              <a:t>Preventive Healthcare Focus</a:t>
-            </a:r>
-            <a:r>
-              <a:rPr lang="en-IN" sz="1800"/>
-              <a:t> – Goes beyond diet planning to provide disease-specific nutrition advice. </a:t>
-            </a:r>
-          </a:p>
-          <a:p>
-            <a:r>
-              <a:rPr lang="en-IN" sz="1800" b="1"/>
-              <a:t>Scalable &amp; Enterprise-Ready</a:t>
-            </a:r>
-            <a:r>
-              <a:rPr lang="en-IN" sz="1800"/>
-              <a:t> – Built on </a:t>
-            </a:r>
-            <a:r>
-              <a:rPr lang="en-IN" sz="1800" b="1"/>
-              <a:t>IBM watsonx.ai</a:t>
-            </a:r>
-            <a:r>
-              <a:rPr lang="en-IN" sz="1800"/>
-              <a:t> with </a:t>
-            </a:r>
-            <a:r>
-              <a:rPr lang="en-IN" sz="1800" b="1"/>
-              <a:t>IBM Granite models</a:t>
-            </a:r>
-            <a:r>
-              <a:rPr lang="en-IN" sz="1800"/>
-              <a:t>, ensuring reliability and governance. </a:t>
-            </a:r>
-          </a:p>
-          <a:p>
-            <a:endParaRPr lang="en-IN" sz="1800"/>
-          </a:p>
-          <a:p>
-            <a:r>
-              <a:rPr lang="en-IN" sz="1800"/>
-              <a:t>This makes the solution a </a:t>
-            </a:r>
-            <a:r>
-              <a:rPr lang="en-IN" sz="1800" b="1"/>
-              <a:t>smart, adaptive, and proactive digital nutritionist</a:t>
-            </a:r>
-            <a:r>
-              <a:rPr lang="en-IN" sz="1800"/>
-              <a:t>, not just a static diet recommendation tool.</a:t>
-            </a:r>
-            <a:endParaRPr lang="en-US"/>
-          </a:p>
-          <a:p>
-            <a:endParaRPr lang="en-IN"/>
-          </a:p>
-        </p:txBody>
-      </p:sp>
-    </p:spTree>
-    <p:extLst>
-      <p:ext uri="{BB962C8B-B14F-4D97-AF65-F5344CB8AC3E}">
-        <p14:creationId xmlns:p14="http://schemas.microsoft.com/office/powerpoint/2010/main" val="917964102"/>
-      </p:ext>
-    </p:extLst>
-  </p:cSld>
-  <p:clrMapOvr>
-    <a:masterClrMapping/>
-  </p:clrMapOvr>
-</p:sld>
-</file>
-
-<file path=ppt/slides/slide12.xml><?xml version="1.0" encoding="utf-8"?>
-<p:sld xmlns:a="http://schemas.openxmlformats.org/drawingml/2006/main" xmlns:r="http://schemas.openxmlformats.org/officeDocument/2006/relationships" xmlns:p="http://schemas.openxmlformats.org/presentationml/2006/main">
-  <p:cSld>
-    <p:spTree>
-      <p:nvGrpSpPr>
         <p:cNvPr id="1" name="Shape 274">
           <a:extLst>
             <a:ext uri="{FF2B5EF4-FFF2-40B4-BE49-F238E27FC236}">
-              <a16:creationId xmlns:a16="http://schemas.microsoft.com/office/drawing/2014/main" id="{7BB3C0CA-2F24-30DF-1D65-4440B864F08E}"/>
+              <a16:creationId xmlns="" xmlns:a16="http://schemas.microsoft.com/office/drawing/2014/main" id="{6FA0F82B-7EE5-EAB0-F470-130BDAC8254B}"/>
             </a:ext>
           </a:extLst>
         </p:cNvPr>
@@ -12615,7 +12060,7 @@
           <p:cNvPr id="278" name="Google Shape;278;p18">
             <a:extLst>
               <a:ext uri="{FF2B5EF4-FFF2-40B4-BE49-F238E27FC236}">
-                <a16:creationId xmlns:a16="http://schemas.microsoft.com/office/drawing/2014/main" id="{187EEB9C-2E84-113A-3CE6-1507BF5B039F}"/>
+                <a16:creationId xmlns="" xmlns:a16="http://schemas.microsoft.com/office/drawing/2014/main" id="{0668C6FD-577A-7288-5642-1AFC22BD04F2}"/>
               </a:ext>
             </a:extLst>
           </p:cNvPr>
@@ -12637,7 +12082,7 @@
         </p:spPr>
         <p:txBody>
           <a:bodyPr spcFirstLastPara="1" wrap="square" lIns="0" tIns="0" rIns="0" bIns="0" anchor="t" anchorCtr="0">
-            <a:noAutofit/>
+            <a:normAutofit/>
           </a:bodyPr>
           <a:lstStyle/>
           <a:p>
@@ -12659,10 +12104,10 @@
               <a:buNone/>
             </a:pPr>
             <a:r>
-              <a:rPr lang="en-US" sz="2400" b="1">
+              <a:rPr lang="en-US" sz="1920" b="1">
                 <a:sym typeface="Times New Roman"/>
               </a:rPr>
-              <a:t>Git Hub Link</a:t>
+              <a:t>Future Scope </a:t>
             </a:r>
             <a:endParaRPr sz="2400" b="1">
               <a:sym typeface="Times New Roman"/>
@@ -12675,7 +12120,7 @@
           <p:cNvPr id="279" name="Google Shape;279;p18">
             <a:extLst>
               <a:ext uri="{FF2B5EF4-FFF2-40B4-BE49-F238E27FC236}">
-                <a16:creationId xmlns:a16="http://schemas.microsoft.com/office/drawing/2014/main" id="{3711AF54-94A6-B837-31EF-9A8C4ECB9AF6}"/>
+                <a16:creationId xmlns="" xmlns:a16="http://schemas.microsoft.com/office/drawing/2014/main" id="{EAFA16CB-0A72-5AC5-69A0-ABF4A752B43F}"/>
               </a:ext>
             </a:extLst>
           </p:cNvPr>
@@ -12684,7 +12129,7 @@
         </p:nvSpPr>
         <p:spPr>
           <a:xfrm>
-            <a:off x="1218724" y="1153712"/>
+            <a:off x="1218724" y="1221715"/>
             <a:ext cx="9214580" cy="4277001"/>
           </a:xfrm>
           <a:prstGeom prst="rect">
@@ -12697,7 +12142,7 @@
         </p:spPr>
         <p:txBody>
           <a:bodyPr spcFirstLastPara="1" wrap="square" lIns="0" tIns="0" rIns="0" bIns="0" anchor="t" anchorCtr="0">
-            <a:noAutofit/>
+            <a:normAutofit/>
           </a:bodyPr>
           <a:lstStyle/>
           <a:p>
@@ -12719,7 +12164,7 @@
               <a:buNone/>
             </a:pPr>
             <a:r>
-              <a:rPr lang="en-US" sz="1850" b="0" i="0" u="none" strike="noStrike" cap="none">
+              <a:rPr lang="en-US" sz="1480" b="1" i="0" u="none" strike="noStrike" cap="none" dirty="0">
                 <a:solidFill>
                   <a:srgbClr val="2B3541"/>
                 </a:solidFill>
@@ -12728,10 +12173,10 @@
                 <a:cs typeface="Times New Roman"/>
                 <a:sym typeface="Times New Roman"/>
               </a:rPr>
-              <a:t>Please create public </a:t>
-            </a:r>
-            <a:r>
-              <a:rPr lang="en-US" sz="1850" b="0" i="0" u="none" strike="noStrike" cap="none" dirty="0" err="1">
+              <a:t>1. </a:t>
+            </a:r>
+            <a:r>
+              <a:rPr lang="en-US" sz="1480" b="1" i="0" u="none" strike="noStrike" cap="none" dirty="0" err="1">
                 <a:solidFill>
                   <a:srgbClr val="2B3541"/>
                 </a:solidFill>
@@ -12740,10 +12185,10 @@
                 <a:cs typeface="Times New Roman"/>
                 <a:sym typeface="Times New Roman"/>
               </a:rPr>
-              <a:t>github</a:t>
-            </a:r>
-            <a:r>
-              <a:rPr lang="en-US" sz="1850" b="0" i="0" u="none" strike="noStrike" cap="none" dirty="0">
+              <a:t>iOS</a:t>
+            </a:r>
+            <a:r>
+              <a:rPr lang="en-US" sz="1480" b="1" i="0" u="none" strike="noStrike" cap="none" dirty="0">
                 <a:solidFill>
                   <a:srgbClr val="2B3541"/>
                 </a:solidFill>
@@ -12752,7 +12197,7 @@
                 <a:cs typeface="Times New Roman"/>
                 <a:sym typeface="Times New Roman"/>
               </a:rPr>
-              <a:t> repository (Enable Add README  button while creating repository) with format – </a:t>
+              <a:t> and Desktop Apps – </a:t>
             </a:r>
           </a:p>
           <a:p>
@@ -12774,7 +12219,7 @@
               <a:buNone/>
             </a:pPr>
             <a:r>
-              <a:rPr lang="en-US" sz="1850" dirty="0">
+              <a:rPr lang="en-US" sz="1480" b="0" i="0" u="none" strike="noStrike" cap="none" dirty="0">
                 <a:solidFill>
                   <a:srgbClr val="2B3541"/>
                 </a:solidFill>
@@ -12783,10 +12228,10 @@
                 <a:cs typeface="Times New Roman"/>
                 <a:sym typeface="Times New Roman"/>
               </a:rPr>
-              <a:t>Please test and Paste the working  </a:t>
-            </a:r>
-            <a:r>
-              <a:rPr lang="en-US" sz="1850" dirty="0" err="1">
+              <a:t>Expanding beyond Android and Chrome to offer system-wide protection on all major platforms. This will enable </a:t>
+            </a:r>
+            <a:r>
+              <a:rPr lang="en-US" sz="1480" b="0" i="0" u="none" strike="noStrike" cap="none" dirty="0" err="1">
                 <a:solidFill>
                   <a:srgbClr val="2B3541"/>
                 </a:solidFill>
@@ -12795,10 +12240,10 @@
                 <a:cs typeface="Times New Roman"/>
                 <a:sym typeface="Times New Roman"/>
               </a:rPr>
-              <a:t>Github</a:t>
-            </a:r>
-            <a:r>
-              <a:rPr lang="en-US" sz="1850" dirty="0">
+              <a:t>ScamShield</a:t>
+            </a:r>
+            <a:r>
+              <a:rPr lang="en-US" sz="1480" b="0" i="0" u="none" strike="noStrike" cap="none" dirty="0">
                 <a:solidFill>
                   <a:srgbClr val="2B3541"/>
                 </a:solidFill>
@@ -12807,29 +12252,29 @@
                 <a:cs typeface="Times New Roman"/>
                 <a:sym typeface="Times New Roman"/>
               </a:rPr>
-              <a:t> URL –</a:t>
-            </a:r>
-            <a:endParaRPr lang="en-US" sz="1850" dirty="0">
-              <a:solidFill>
-                <a:srgbClr val="2B3541"/>
-              </a:solidFill>
-              <a:latin typeface="Times New Roman"/>
-              <a:ea typeface="Times New Roman"/>
-              <a:cs typeface="Times New Roman"/>
-            </a:endParaRPr>
-          </a:p>
-          <a:p>
-            <a:pPr lvl="0">
+              <a:t> to provide a ubiquitous safety net across the entire digital ecosystem.</a:t>
+            </a:r>
+          </a:p>
+          <a:p>
+            <a:pPr marL="0" marR="0" lvl="0" indent="0" algn="l" rtl="0">
               <a:lnSpc>
                 <a:spcPct val="162162"/>
               </a:lnSpc>
+              <a:spcBef>
+                <a:spcPts val="0"/>
+              </a:spcBef>
+              <a:spcAft>
+                <a:spcPts val="0"/>
+              </a:spcAft>
               <a:buClr>
                 <a:srgbClr val="2B3541"/>
               </a:buClr>
               <a:buSzPts val="1850"/>
+              <a:buFont typeface="Times New Roman"/>
+              <a:buNone/>
             </a:pPr>
             <a:r>
-              <a:rPr lang="en-US" sz="1850" b="1" dirty="0">
+              <a:rPr lang="en-US" sz="1480" b="1" dirty="0">
                 <a:solidFill>
                   <a:srgbClr val="2B3541"/>
                 </a:solidFill>
@@ -12838,10 +12283,10 @@
                 <a:cs typeface="Times New Roman"/>
                 <a:sym typeface="Times New Roman"/>
               </a:rPr>
-              <a:t>Make sure you have Uploaded following three files into your </a:t>
-            </a:r>
-            <a:r>
-              <a:rPr lang="en-US" sz="1850" b="1" dirty="0" err="1">
+              <a:t>2.</a:t>
+            </a:r>
+            <a:r>
+              <a:rPr lang="en-US" sz="1480" b="1" i="0" u="none" strike="noStrike" cap="none" dirty="0">
                 <a:solidFill>
                   <a:srgbClr val="2B3541"/>
                 </a:solidFill>
@@ -12850,10 +12295,10 @@
                 <a:cs typeface="Times New Roman"/>
                 <a:sym typeface="Times New Roman"/>
               </a:rPr>
-              <a:t>github</a:t>
-            </a:r>
-            <a:r>
-              <a:rPr lang="en-US" sz="1850" b="1" dirty="0">
+              <a:t>Multilingual Support </a:t>
+            </a:r>
+            <a:r>
+              <a:rPr lang="en-US" sz="1480" b="0" i="0" u="none" strike="noStrike" cap="none" dirty="0">
                 <a:solidFill>
                   <a:srgbClr val="2B3541"/>
                 </a:solidFill>
@@ -12862,17 +12307,29 @@
                 <a:cs typeface="Times New Roman"/>
                 <a:sym typeface="Times New Roman"/>
               </a:rPr>
-              <a:t> repository  </a:t>
-            </a:r>
-            <a:br>
-              <a:rPr lang="en-US" sz="1850" dirty="0">
-                <a:latin typeface="Times New Roman"/>
-                <a:ea typeface="Times New Roman"/>
-                <a:cs typeface="Times New Roman"/>
-              </a:rPr>
-            </a:br>
-            <a:r>
-              <a:rPr lang="en-US" sz="1850" dirty="0">
+              <a:t>– </a:t>
+            </a:r>
+          </a:p>
+          <a:p>
+            <a:pPr marL="0" marR="0" lvl="0" indent="0" algn="l" rtl="0">
+              <a:lnSpc>
+                <a:spcPct val="162162"/>
+              </a:lnSpc>
+              <a:spcBef>
+                <a:spcPts val="0"/>
+              </a:spcBef>
+              <a:spcAft>
+                <a:spcPts val="0"/>
+              </a:spcAft>
+              <a:buClr>
+                <a:srgbClr val="2B3541"/>
+              </a:buClr>
+              <a:buSzPts val="1850"/>
+              <a:buFont typeface="Times New Roman"/>
+              <a:buNone/>
+            </a:pPr>
+            <a:r>
+              <a:rPr lang="en-US" sz="1480" b="0" i="0" u="none" strike="noStrike" cap="none" dirty="0">
                 <a:solidFill>
                   <a:srgbClr val="2B3541"/>
                 </a:solidFill>
@@ -12881,60 +12338,9 @@
                 <a:cs typeface="Times New Roman"/>
                 <a:sym typeface="Times New Roman"/>
               </a:rPr>
-              <a:t>1) </a:t>
-            </a:r>
-            <a:r>
-              <a:rPr lang="en-US" sz="1850" dirty="0" err="1">
-                <a:solidFill>
-                  <a:srgbClr val="2B3541"/>
-                </a:solidFill>
-                <a:latin typeface="Times New Roman"/>
-                <a:ea typeface="Times New Roman"/>
-                <a:cs typeface="Times New Roman"/>
-                <a:sym typeface="Times New Roman"/>
-              </a:rPr>
-              <a:t>app.json</a:t>
-            </a:r>
-            <a:r>
-              <a:rPr lang="en-US" sz="1850" dirty="0">
-                <a:solidFill>
-                  <a:srgbClr val="2B3541"/>
-                </a:solidFill>
-                <a:latin typeface="Times New Roman"/>
-                <a:ea typeface="Times New Roman"/>
-                <a:cs typeface="Times New Roman"/>
-                <a:sym typeface="Times New Roman"/>
-              </a:rPr>
-              <a:t> file , 2) yourproblemstatement.pdf file  3) your projectpresntation.pptx file 4)any other files </a:t>
-            </a:r>
-            <a:endParaRPr lang="en-US" sz="1850" dirty="0">
-              <a:solidFill>
-                <a:srgbClr val="2B3541"/>
-              </a:solidFill>
-              <a:latin typeface="Times New Roman"/>
-              <a:ea typeface="Times New Roman"/>
-              <a:cs typeface="Times New Roman"/>
-            </a:endParaRPr>
-          </a:p>
-          <a:p>
-            <a:pPr marL="0" marR="0" lvl="0" indent="0" algn="l" rtl="0">
-              <a:lnSpc>
-                <a:spcPct val="162162"/>
-              </a:lnSpc>
-              <a:spcBef>
-                <a:spcPts val="0"/>
-              </a:spcBef>
-              <a:spcAft>
-                <a:spcPts val="0"/>
-              </a:spcAft>
-              <a:buClr>
-                <a:srgbClr val="2B3541"/>
-              </a:buClr>
-              <a:buSzPts val="1850"/>
-              <a:buFont typeface="Times New Roman"/>
-              <a:buNone/>
-            </a:pPr>
-            <a:endParaRPr sz="1850" b="0" i="0" u="none" strike="noStrike" cap="none">
+              <a:t>Enhancing the text agent to detect scams in regional languages and translate warnings for diverse user bases. Users can interact safely in their preferred language, making the solution more inclusive for diverse populations.</a:t>
+            </a:r>
+            <a:endParaRPr sz="1850" b="0" i="0" u="none" strike="noStrike" cap="none" dirty="0">
               <a:solidFill>
                 <a:srgbClr val="000000"/>
               </a:solidFill>
@@ -12951,7 +12357,7 @@
           <p:cNvPr id="280" name="Google Shape;280;p18">
             <a:extLst>
               <a:ext uri="{FF2B5EF4-FFF2-40B4-BE49-F238E27FC236}">
-                <a16:creationId xmlns:a16="http://schemas.microsoft.com/office/drawing/2014/main" id="{E228982D-BF81-530A-CBA1-E897A3CA8EF7}"/>
+                <a16:creationId xmlns="" xmlns:a16="http://schemas.microsoft.com/office/drawing/2014/main" id="{B888011B-E4AC-77DB-4A60-BE2C891C49F5}"/>
               </a:ext>
             </a:extLst>
           </p:cNvPr>
@@ -12973,7 +12379,7 @@
         </p:spPr>
         <p:txBody>
           <a:bodyPr spcFirstLastPara="1" wrap="square" lIns="0" tIns="0" rIns="0" bIns="0" anchor="t" anchorCtr="0">
-            <a:noAutofit/>
+            <a:normAutofit/>
           </a:bodyPr>
           <a:lstStyle/>
           <a:p>
@@ -12995,7 +12401,7 @@
               <a:buNone/>
             </a:pPr>
             <a:r>
-              <a:rPr lang="en-US" sz="1850" b="0" i="0" u="none" strike="noStrike" cap="none">
+              <a:rPr lang="en-US" sz="1480" b="0" i="0" u="none" strike="noStrike" cap="none">
                 <a:solidFill>
                   <a:srgbClr val="2B3541"/>
                 </a:solidFill>
@@ -13023,7 +12429,7 @@
           <p:cNvPr id="281" name="Google Shape;281;p18">
             <a:extLst>
               <a:ext uri="{FF2B5EF4-FFF2-40B4-BE49-F238E27FC236}">
-                <a16:creationId xmlns:a16="http://schemas.microsoft.com/office/drawing/2014/main" id="{7BC356B8-92F8-3187-D065-667AACF68E72}"/>
+                <a16:creationId xmlns="" xmlns:a16="http://schemas.microsoft.com/office/drawing/2014/main" id="{91F05971-9256-10B5-6575-4E7C679C6DAA}"/>
               </a:ext>
             </a:extLst>
           </p:cNvPr>
@@ -13045,7 +12451,7 @@
         </p:spPr>
         <p:txBody>
           <a:bodyPr spcFirstLastPara="1" wrap="square" lIns="0" tIns="0" rIns="0" bIns="0" anchor="t" anchorCtr="0">
-            <a:noAutofit/>
+            <a:normAutofit/>
           </a:bodyPr>
           <a:lstStyle/>
           <a:p>
@@ -13067,7 +12473,7 @@
               <a:buNone/>
             </a:pPr>
             <a:r>
-              <a:rPr lang="en-US" sz="1850" b="0" i="0" u="none" strike="noStrike" cap="none">
+              <a:rPr lang="en-US" sz="1480" b="0" i="0" u="none" strike="noStrike" cap="none">
                 <a:solidFill>
                   <a:srgbClr val="2B3541"/>
                 </a:solidFill>
@@ -13095,7 +12501,7 @@
           <p:cNvPr id="282" name="Google Shape;282;p18">
             <a:extLst>
               <a:ext uri="{FF2B5EF4-FFF2-40B4-BE49-F238E27FC236}">
-                <a16:creationId xmlns:a16="http://schemas.microsoft.com/office/drawing/2014/main" id="{1558A011-60D6-B010-6117-1B9F7C786B2B}"/>
+                <a16:creationId xmlns="" xmlns:a16="http://schemas.microsoft.com/office/drawing/2014/main" id="{F1C3EBC2-438F-C150-9ABF-F14321C2CC5C}"/>
               </a:ext>
             </a:extLst>
           </p:cNvPr>
@@ -13117,7 +12523,7 @@
         </p:spPr>
         <p:txBody>
           <a:bodyPr spcFirstLastPara="1" wrap="square" lIns="0" tIns="0" rIns="0" bIns="0" anchor="t" anchorCtr="0">
-            <a:noAutofit/>
+            <a:normAutofit/>
           </a:bodyPr>
           <a:lstStyle/>
           <a:p>
@@ -13139,508 +12545,7 @@
               <a:buNone/>
             </a:pPr>
             <a:r>
-              <a:rPr lang="en-US" sz="1850" b="0" i="0" u="none" strike="noStrike" cap="none">
-                <a:solidFill>
-                  <a:srgbClr val="2B3541"/>
-                </a:solidFill>
-                <a:latin typeface="Times New Roman"/>
-                <a:ea typeface="Times New Roman"/>
-                <a:cs typeface="Times New Roman"/>
-                <a:sym typeface="Times New Roman"/>
-              </a:rPr>
-              <a:t>·</a:t>
-            </a:r>
-            <a:endParaRPr sz="1850" b="0" i="0" u="none" strike="noStrike" cap="none">
-              <a:solidFill>
-                <a:srgbClr val="000000"/>
-              </a:solidFill>
-              <a:latin typeface="Times New Roman"/>
-              <a:ea typeface="Times New Roman"/>
-              <a:cs typeface="Times New Roman"/>
-              <a:sym typeface="Times New Roman"/>
-            </a:endParaRPr>
-          </a:p>
-        </p:txBody>
-      </p:sp>
-    </p:spTree>
-    <p:extLst>
-      <p:ext uri="{BB962C8B-B14F-4D97-AF65-F5344CB8AC3E}">
-        <p14:creationId xmlns:p14="http://schemas.microsoft.com/office/powerpoint/2010/main" val="2605851928"/>
-      </p:ext>
-    </p:extLst>
-  </p:cSld>
-  <p:clrMapOvr>
-    <a:masterClrMapping/>
-  </p:clrMapOvr>
-</p:sld>
-</file>
-
-<file path=ppt/slides/slide13.xml><?xml version="1.0" encoding="utf-8"?>
-<p:sld xmlns:a="http://schemas.openxmlformats.org/drawingml/2006/main" xmlns:r="http://schemas.openxmlformats.org/officeDocument/2006/relationships" xmlns:p="http://schemas.openxmlformats.org/presentationml/2006/main">
-  <p:cSld>
-    <p:spTree>
-      <p:nvGrpSpPr>
-        <p:cNvPr id="1" name="Shape 274">
-          <a:extLst>
-            <a:ext uri="{FF2B5EF4-FFF2-40B4-BE49-F238E27FC236}">
-              <a16:creationId xmlns:a16="http://schemas.microsoft.com/office/drawing/2014/main" id="{6FA0F82B-7EE5-EAB0-F470-130BDAC8254B}"/>
-            </a:ext>
-          </a:extLst>
-        </p:cNvPr>
-        <p:cNvGrpSpPr/>
-        <p:nvPr/>
-      </p:nvGrpSpPr>
-      <p:grpSpPr>
-        <a:xfrm>
-          <a:off x="0" y="0"/>
-          <a:ext cx="0" cy="0"/>
-          <a:chOff x="0" y="0"/>
-          <a:chExt cx="0" cy="0"/>
-        </a:xfrm>
-      </p:grpSpPr>
-      <p:sp>
-        <p:nvSpPr>
-          <p:cNvPr id="278" name="Google Shape;278;p18">
-            <a:extLst>
-              <a:ext uri="{FF2B5EF4-FFF2-40B4-BE49-F238E27FC236}">
-                <a16:creationId xmlns:a16="http://schemas.microsoft.com/office/drawing/2014/main" id="{0668C6FD-577A-7288-5642-1AFC22BD04F2}"/>
-              </a:ext>
-            </a:extLst>
-          </p:cNvPr>
-          <p:cNvSpPr/>
-          <p:nvPr/>
-        </p:nvSpPr>
-        <p:spPr>
-          <a:xfrm>
-            <a:off x="1218724" y="420729"/>
-            <a:ext cx="6444496" cy="704017"/>
-          </a:xfrm>
-          <a:prstGeom prst="rect">
-            <a:avLst/>
-          </a:prstGeom>
-          <a:noFill/>
-          <a:ln>
-            <a:noFill/>
-          </a:ln>
-        </p:spPr>
-        <p:txBody>
-          <a:bodyPr spcFirstLastPara="1" wrap="square" lIns="0" tIns="0" rIns="0" bIns="0" anchor="t" anchorCtr="0">
-            <a:noAutofit/>
-          </a:bodyPr>
-          <a:lstStyle/>
-          <a:p>
-            <a:pPr marL="0" marR="0" lvl="0" indent="0" algn="l" rtl="0">
-              <a:lnSpc>
-                <a:spcPct val="157142"/>
-              </a:lnSpc>
-              <a:spcBef>
-                <a:spcPts val="0"/>
-              </a:spcBef>
-              <a:spcAft>
-                <a:spcPts val="0"/>
-              </a:spcAft>
-              <a:buClr>
-                <a:srgbClr val="051D3A"/>
-              </a:buClr>
-              <a:buSzPts val="3500"/>
-              <a:buFont typeface="Times New Roman"/>
-              <a:buNone/>
-            </a:pPr>
-            <a:r>
-              <a:rPr lang="en-US" sz="2400" b="1">
-                <a:sym typeface="Times New Roman"/>
-              </a:rPr>
-              <a:t>Future Scope </a:t>
-            </a:r>
-            <a:endParaRPr sz="2400" b="1">
-              <a:sym typeface="Times New Roman"/>
-            </a:endParaRPr>
-          </a:p>
-        </p:txBody>
-      </p:sp>
-      <p:sp>
-        <p:nvSpPr>
-          <p:cNvPr id="279" name="Google Shape;279;p18">
-            <a:extLst>
-              <a:ext uri="{FF2B5EF4-FFF2-40B4-BE49-F238E27FC236}">
-                <a16:creationId xmlns:a16="http://schemas.microsoft.com/office/drawing/2014/main" id="{EAFA16CB-0A72-5AC5-69A0-ABF4A752B43F}"/>
-              </a:ext>
-            </a:extLst>
-          </p:cNvPr>
-          <p:cNvSpPr/>
-          <p:nvPr/>
-        </p:nvSpPr>
-        <p:spPr>
-          <a:xfrm>
-            <a:off x="1218724" y="1221715"/>
-            <a:ext cx="9214580" cy="4277001"/>
-          </a:xfrm>
-          <a:prstGeom prst="rect">
-            <a:avLst/>
-          </a:prstGeom>
-          <a:noFill/>
-          <a:ln>
-            <a:noFill/>
-          </a:ln>
-        </p:spPr>
-        <p:txBody>
-          <a:bodyPr spcFirstLastPara="1" wrap="square" lIns="0" tIns="0" rIns="0" bIns="0" anchor="t" anchorCtr="0">
-            <a:noAutofit/>
-          </a:bodyPr>
-          <a:lstStyle/>
-          <a:p>
-            <a:pPr marL="0" marR="0" lvl="0" indent="0" algn="l" rtl="0">
-              <a:lnSpc>
-                <a:spcPct val="162162"/>
-              </a:lnSpc>
-              <a:spcBef>
-                <a:spcPts val="0"/>
-              </a:spcBef>
-              <a:spcAft>
-                <a:spcPts val="0"/>
-              </a:spcAft>
-              <a:buClr>
-                <a:srgbClr val="2B3541"/>
-              </a:buClr>
-              <a:buSzPts val="1850"/>
-              <a:buFont typeface="Times New Roman"/>
-              <a:buNone/>
-            </a:pPr>
-            <a:r>
-              <a:rPr lang="en-US" sz="1850" b="1" i="0" u="none" strike="noStrike" cap="none">
-                <a:solidFill>
-                  <a:srgbClr val="2B3541"/>
-                </a:solidFill>
-                <a:latin typeface="Times New Roman"/>
-                <a:ea typeface="Times New Roman"/>
-                <a:cs typeface="Times New Roman"/>
-                <a:sym typeface="Times New Roman"/>
-              </a:rPr>
-              <a:t>1.Integration with Wearables &amp; Health Devices – </a:t>
-            </a:r>
-          </a:p>
-          <a:p>
-            <a:pPr marL="0" marR="0" lvl="0" indent="0" algn="l" rtl="0">
-              <a:lnSpc>
-                <a:spcPct val="162162"/>
-              </a:lnSpc>
-              <a:spcBef>
-                <a:spcPts val="0"/>
-              </a:spcBef>
-              <a:spcAft>
-                <a:spcPts val="0"/>
-              </a:spcAft>
-              <a:buClr>
-                <a:srgbClr val="2B3541"/>
-              </a:buClr>
-              <a:buSzPts val="1850"/>
-              <a:buFont typeface="Times New Roman"/>
-              <a:buNone/>
-            </a:pPr>
-            <a:r>
-              <a:rPr lang="en-US" sz="1850" b="0" i="0" u="none" strike="noStrike" cap="none">
-                <a:solidFill>
-                  <a:srgbClr val="2B3541"/>
-                </a:solidFill>
-                <a:latin typeface="Times New Roman"/>
-                <a:ea typeface="Times New Roman"/>
-                <a:cs typeface="Times New Roman"/>
-                <a:sym typeface="Times New Roman"/>
-              </a:rPr>
-              <a:t>The system can be integrated with smartwatches and fitness trackers to collect real-time data such as steps, calories burned, heart rate, and sleep patterns. This will enable the Nutrition Agent to provide more accurate and dynamic diet recommendations based on actual user activity and health metrics.</a:t>
-            </a:r>
-          </a:p>
-          <a:p>
-            <a:pPr marL="0" marR="0" lvl="0" indent="0" algn="l" rtl="0">
-              <a:lnSpc>
-                <a:spcPct val="162162"/>
-              </a:lnSpc>
-              <a:spcBef>
-                <a:spcPts val="0"/>
-              </a:spcBef>
-              <a:spcAft>
-                <a:spcPts val="0"/>
-              </a:spcAft>
-              <a:buClr>
-                <a:srgbClr val="2B3541"/>
-              </a:buClr>
-              <a:buSzPts val="1850"/>
-              <a:buFont typeface="Times New Roman"/>
-              <a:buNone/>
-            </a:pPr>
-            <a:r>
-              <a:rPr lang="en-US" sz="1850" b="1">
-                <a:solidFill>
-                  <a:srgbClr val="2B3541"/>
-                </a:solidFill>
-                <a:latin typeface="Times New Roman"/>
-                <a:ea typeface="Times New Roman"/>
-                <a:cs typeface="Times New Roman"/>
-                <a:sym typeface="Times New Roman"/>
-              </a:rPr>
-              <a:t>2.</a:t>
-            </a:r>
-            <a:r>
-              <a:rPr lang="en-US" sz="1850" b="1" i="0" u="none" strike="noStrike" cap="none">
-                <a:solidFill>
-                  <a:srgbClr val="2B3541"/>
-                </a:solidFill>
-                <a:latin typeface="Times New Roman"/>
-                <a:ea typeface="Times New Roman"/>
-                <a:cs typeface="Times New Roman"/>
-                <a:sym typeface="Times New Roman"/>
-              </a:rPr>
-              <a:t>AI-Powered Voice Assistant &amp; Multilingual Support </a:t>
-            </a:r>
-            <a:r>
-              <a:rPr lang="en-US" sz="1850" b="0" i="0" u="none" strike="noStrike" cap="none">
-                <a:solidFill>
-                  <a:srgbClr val="2B3541"/>
-                </a:solidFill>
-                <a:latin typeface="Times New Roman"/>
-                <a:ea typeface="Times New Roman"/>
-                <a:cs typeface="Times New Roman"/>
-                <a:sym typeface="Times New Roman"/>
-              </a:rPr>
-              <a:t>– </a:t>
-            </a:r>
-          </a:p>
-          <a:p>
-            <a:pPr marL="0" marR="0" lvl="0" indent="0" algn="l" rtl="0">
-              <a:lnSpc>
-                <a:spcPct val="162162"/>
-              </a:lnSpc>
-              <a:spcBef>
-                <a:spcPts val="0"/>
-              </a:spcBef>
-              <a:spcAft>
-                <a:spcPts val="0"/>
-              </a:spcAft>
-              <a:buClr>
-                <a:srgbClr val="2B3541"/>
-              </a:buClr>
-              <a:buSzPts val="1850"/>
-              <a:buFont typeface="Times New Roman"/>
-              <a:buNone/>
-            </a:pPr>
-            <a:r>
-              <a:rPr lang="en-US" sz="1850" b="0" i="0" u="none" strike="noStrike" cap="none">
-                <a:solidFill>
-                  <a:srgbClr val="2B3541"/>
-                </a:solidFill>
-                <a:latin typeface="Times New Roman"/>
-                <a:ea typeface="Times New Roman"/>
-                <a:cs typeface="Times New Roman"/>
-                <a:sym typeface="Times New Roman"/>
-              </a:rPr>
-              <a:t>Enhancing the system with a voice-enabled assistant and support for multiple languages will improve accessibility. Users can interact naturally in their preferred language, making the solution more inclusive and suitable for diverse populations, especially in regions with varied linguistic backgrounds.</a:t>
-            </a:r>
-            <a:endParaRPr sz="1850" b="0" i="0" u="none" strike="noStrike" cap="none">
-              <a:solidFill>
-                <a:srgbClr val="000000"/>
-              </a:solidFill>
-              <a:latin typeface="Times New Roman"/>
-              <a:ea typeface="Times New Roman"/>
-              <a:cs typeface="Times New Roman"/>
-              <a:sym typeface="Times New Roman"/>
-            </a:endParaRPr>
-          </a:p>
-        </p:txBody>
-      </p:sp>
-      <p:sp>
-        <p:nvSpPr>
-          <p:cNvPr id="280" name="Google Shape;280;p18">
-            <a:extLst>
-              <a:ext uri="{FF2B5EF4-FFF2-40B4-BE49-F238E27FC236}">
-                <a16:creationId xmlns:a16="http://schemas.microsoft.com/office/drawing/2014/main" id="{B888011B-E4AC-77DB-4A60-BE2C891C49F5}"/>
-              </a:ext>
-            </a:extLst>
-          </p:cNvPr>
-          <p:cNvSpPr/>
-          <p:nvPr/>
-        </p:nvSpPr>
-        <p:spPr>
-          <a:xfrm>
-            <a:off x="1218724" y="3360216"/>
-            <a:ext cx="7468553" cy="766048"/>
-          </a:xfrm>
-          <a:prstGeom prst="rect">
-            <a:avLst/>
-          </a:prstGeom>
-          <a:noFill/>
-          <a:ln>
-            <a:noFill/>
-          </a:ln>
-        </p:spPr>
-        <p:txBody>
-          <a:bodyPr spcFirstLastPara="1" wrap="square" lIns="0" tIns="0" rIns="0" bIns="0" anchor="t" anchorCtr="0">
-            <a:noAutofit/>
-          </a:bodyPr>
-          <a:lstStyle/>
-          <a:p>
-            <a:pPr marL="0" marR="0" lvl="0" indent="0" algn="l" rtl="0">
-              <a:lnSpc>
-                <a:spcPct val="162162"/>
-              </a:lnSpc>
-              <a:spcBef>
-                <a:spcPts val="0"/>
-              </a:spcBef>
-              <a:spcAft>
-                <a:spcPts val="0"/>
-              </a:spcAft>
-              <a:buClr>
-                <a:srgbClr val="2B3541"/>
-              </a:buClr>
-              <a:buSzPts val="1850"/>
-              <a:buFont typeface="Times New Roman"/>
-              <a:buNone/>
-            </a:pPr>
-            <a:r>
-              <a:rPr lang="en-US" sz="1850" b="0" i="0" u="none" strike="noStrike" cap="none">
-                <a:solidFill>
-                  <a:srgbClr val="2B3541"/>
-                </a:solidFill>
-                <a:latin typeface="Times New Roman"/>
-                <a:ea typeface="Times New Roman"/>
-                <a:cs typeface="Times New Roman"/>
-                <a:sym typeface="Times New Roman"/>
-              </a:rPr>
-              <a:t>·</a:t>
-            </a:r>
-            <a:endParaRPr sz="1850" b="0" i="0" u="none" strike="noStrike" cap="none">
-              <a:solidFill>
-                <a:srgbClr val="000000"/>
-              </a:solidFill>
-              <a:latin typeface="Times New Roman"/>
-              <a:ea typeface="Times New Roman"/>
-              <a:cs typeface="Times New Roman"/>
-              <a:sym typeface="Times New Roman"/>
-            </a:endParaRPr>
-          </a:p>
-        </p:txBody>
-      </p:sp>
-      <p:sp>
-        <p:nvSpPr>
-          <p:cNvPr id="281" name="Google Shape;281;p18">
-            <a:extLst>
-              <a:ext uri="{FF2B5EF4-FFF2-40B4-BE49-F238E27FC236}">
-                <a16:creationId xmlns:a16="http://schemas.microsoft.com/office/drawing/2014/main" id="{91F05971-9256-10B5-6575-4E7C679C6DAA}"/>
-              </a:ext>
-            </a:extLst>
-          </p:cNvPr>
-          <p:cNvSpPr/>
-          <p:nvPr/>
-        </p:nvSpPr>
-        <p:spPr>
-          <a:xfrm>
-            <a:off x="1218724" y="4395464"/>
-            <a:ext cx="7468553" cy="766048"/>
-          </a:xfrm>
-          <a:prstGeom prst="rect">
-            <a:avLst/>
-          </a:prstGeom>
-          <a:noFill/>
-          <a:ln>
-            <a:noFill/>
-          </a:ln>
-        </p:spPr>
-        <p:txBody>
-          <a:bodyPr spcFirstLastPara="1" wrap="square" lIns="0" tIns="0" rIns="0" bIns="0" anchor="t" anchorCtr="0">
-            <a:noAutofit/>
-          </a:bodyPr>
-          <a:lstStyle/>
-          <a:p>
-            <a:pPr marL="0" marR="0" lvl="0" indent="0" algn="l" rtl="0">
-              <a:lnSpc>
-                <a:spcPct val="162162"/>
-              </a:lnSpc>
-              <a:spcBef>
-                <a:spcPts val="0"/>
-              </a:spcBef>
-              <a:spcAft>
-                <a:spcPts val="0"/>
-              </a:spcAft>
-              <a:buClr>
-                <a:srgbClr val="2B3541"/>
-              </a:buClr>
-              <a:buSzPts val="1850"/>
-              <a:buFont typeface="Times New Roman"/>
-              <a:buNone/>
-            </a:pPr>
-            <a:r>
-              <a:rPr lang="en-US" sz="1850" b="0" i="0" u="none" strike="noStrike" cap="none">
-                <a:solidFill>
-                  <a:srgbClr val="2B3541"/>
-                </a:solidFill>
-                <a:latin typeface="Times New Roman"/>
-                <a:ea typeface="Times New Roman"/>
-                <a:cs typeface="Times New Roman"/>
-                <a:sym typeface="Times New Roman"/>
-              </a:rPr>
-              <a:t>·</a:t>
-            </a:r>
-            <a:endParaRPr sz="1850" b="0" i="0" u="none" strike="noStrike" cap="none">
-              <a:solidFill>
-                <a:srgbClr val="000000"/>
-              </a:solidFill>
-              <a:latin typeface="Times New Roman"/>
-              <a:ea typeface="Times New Roman"/>
-              <a:cs typeface="Times New Roman"/>
-              <a:sym typeface="Times New Roman"/>
-            </a:endParaRPr>
-          </a:p>
-        </p:txBody>
-      </p:sp>
-      <p:sp>
-        <p:nvSpPr>
-          <p:cNvPr id="282" name="Google Shape;282;p18">
-            <a:extLst>
-              <a:ext uri="{FF2B5EF4-FFF2-40B4-BE49-F238E27FC236}">
-                <a16:creationId xmlns:a16="http://schemas.microsoft.com/office/drawing/2014/main" id="{F1C3EBC2-438F-C150-9ABF-F14321C2CC5C}"/>
-              </a:ext>
-            </a:extLst>
-          </p:cNvPr>
-          <p:cNvSpPr/>
-          <p:nvPr/>
-        </p:nvSpPr>
-        <p:spPr>
-          <a:xfrm>
-            <a:off x="1218724" y="5430713"/>
-            <a:ext cx="7468553" cy="383024"/>
-          </a:xfrm>
-          <a:prstGeom prst="rect">
-            <a:avLst/>
-          </a:prstGeom>
-          <a:noFill/>
-          <a:ln>
-            <a:noFill/>
-          </a:ln>
-        </p:spPr>
-        <p:txBody>
-          <a:bodyPr spcFirstLastPara="1" wrap="square" lIns="0" tIns="0" rIns="0" bIns="0" anchor="t" anchorCtr="0">
-            <a:noAutofit/>
-          </a:bodyPr>
-          <a:lstStyle/>
-          <a:p>
-            <a:pPr marL="0" marR="0" lvl="0" indent="0" algn="l" rtl="0">
-              <a:lnSpc>
-                <a:spcPct val="162162"/>
-              </a:lnSpc>
-              <a:spcBef>
-                <a:spcPts val="0"/>
-              </a:spcBef>
-              <a:spcAft>
-                <a:spcPts val="0"/>
-              </a:spcAft>
-              <a:buClr>
-                <a:srgbClr val="2B3541"/>
-              </a:buClr>
-              <a:buSzPts val="1850"/>
-              <a:buFont typeface="Times New Roman"/>
-              <a:buNone/>
-            </a:pPr>
-            <a:r>
-              <a:rPr lang="en-US" sz="1850" b="0" i="0" u="none" strike="noStrike" cap="none">
+              <a:rPr lang="en-US" sz="1480" b="0" i="0" u="none" strike="noStrike" cap="none">
                 <a:solidFill>
                   <a:srgbClr val="2B3541"/>
                 </a:solidFill>
@@ -13676,7 +12581,7 @@
 </p:sld>
 </file>
 
-<file path=ppt/slides/slide14.xml><?xml version="1.0" encoding="utf-8"?>
+<file path=ppt/slides/slide12.xml><?xml version="1.0" encoding="utf-8"?>
 <p:sld xmlns:a="http://schemas.openxmlformats.org/drawingml/2006/main" xmlns:r="http://schemas.openxmlformats.org/officeDocument/2006/relationships" xmlns:p="http://schemas.openxmlformats.org/presentationml/2006/main">
   <p:cSld>
     <p:spTree>
@@ -13698,7 +12603,7 @@
           <p:cNvPr id="6" name="TextBox 5">
             <a:extLst>
               <a:ext uri="{FF2B5EF4-FFF2-40B4-BE49-F238E27FC236}">
-                <a16:creationId xmlns:a16="http://schemas.microsoft.com/office/drawing/2014/main" id="{3F1C7BCA-5DD7-F4D3-A937-D1C56976DA01}"/>
+                <a16:creationId xmlns="" xmlns:a16="http://schemas.microsoft.com/office/drawing/2014/main" id="{3F1C7BCA-5DD7-F4D3-A937-D1C56976DA01}"/>
               </a:ext>
             </a:extLst>
           </p:cNvPr>
@@ -13720,12 +12625,12 @@
             <a:prstTxWarp prst="textNoShape">
               <a:avLst/>
             </a:prstTxWarp>
-            <a:spAutoFit/>
+            <a:normAutofit/>
           </a:bodyPr>
           <a:lstStyle/>
           <a:p>
             <a:r>
-              <a:rPr lang="en-US" sz="2400" b="1"/>
+              <a:rPr lang="en-US" sz="1920" b="1"/>
               <a:t>Certificates Earned:</a:t>
             </a:r>
           </a:p>
@@ -13740,7 +12645,7 @@
           <p:cNvPr id="3" name="TextBox 2">
             <a:extLst>
               <a:ext uri="{FF2B5EF4-FFF2-40B4-BE49-F238E27FC236}">
-                <a16:creationId xmlns:a16="http://schemas.microsoft.com/office/drawing/2014/main" id="{4837D5EE-379B-FDC5-0854-8AC81D31FADF}"/>
+                <a16:creationId xmlns="" xmlns:a16="http://schemas.microsoft.com/office/drawing/2014/main" id="{4837D5EE-379B-FDC5-0854-8AC81D31FADF}"/>
               </a:ext>
             </a:extLst>
           </p:cNvPr>
@@ -13762,12 +12667,12 @@
             <a:prstTxWarp prst="textNoShape">
               <a:avLst/>
             </a:prstTxWarp>
-            <a:spAutoFit/>
+            <a:normAutofit/>
           </a:bodyPr>
           <a:lstStyle/>
           <a:p>
             <a:r>
-              <a:rPr lang="en-US" sz="2800" b="1"/>
+              <a:rPr lang="en-US" sz="2240" b="1"/>
               <a:t>Please  add your credly certificate </a:t>
             </a:r>
           </a:p>
@@ -13775,32 +12680,66 @@
       </p:sp>
       <p:pic>
         <p:nvPicPr>
-          <p:cNvPr id="4" name="Picture 3" descr="A screen shot of a computer&#10;&#10;AI-generated content may be incorrect.">
-            <a:extLst>
-              <a:ext uri="{FF2B5EF4-FFF2-40B4-BE49-F238E27FC236}">
-                <a16:creationId xmlns:a16="http://schemas.microsoft.com/office/drawing/2014/main" id="{A037CFD0-B7FF-D9BE-3433-88E5844EF332}"/>
-              </a:ext>
-            </a:extLst>
-          </p:cNvPr>
+          <p:cNvPr id="1026" name="Picture 2"/>
           <p:cNvPicPr>
-            <a:picLocks noChangeAspect="1"/>
+            <a:picLocks noChangeAspect="1" noChangeArrowheads="1"/>
           </p:cNvPicPr>
           <p:nvPr/>
         </p:nvPicPr>
         <p:blipFill>
-          <a:blip r:embed="rId2"/>
+          <a:blip r:embed="rId2">
+            <a:extLst>
+              <a:ext uri="{28A0092B-C50C-407E-A947-70E740481C1C}">
+                <a14:useLocalDpi xmlns:a14="http://schemas.microsoft.com/office/drawing/2010/main" val="0"/>
+              </a:ext>
+            </a:extLst>
+          </a:blip>
+          <a:srcRect/>
           <a:stretch>
             <a:fillRect/>
           </a:stretch>
         </p:blipFill>
-        <p:spPr>
+        <p:spPr bwMode="auto">
           <a:xfrm>
-            <a:off x="2335728" y="1212767"/>
-            <a:ext cx="7075219" cy="5309259"/>
+            <a:off x="2895600" y="1475754"/>
+            <a:ext cx="6307137" cy="4753596"/>
           </a:xfrm>
           <a:prstGeom prst="rect">
             <a:avLst/>
           </a:prstGeom>
+          <a:noFill/>
+          <a:ln>
+            <a:noFill/>
+          </a:ln>
+          <a:effectLst/>
+          <a:extLst>
+            <a:ext uri="{909E8E84-426E-40DD-AFC4-6F175D3DCCD1}">
+              <a14:hiddenFill xmlns:a14="http://schemas.microsoft.com/office/drawing/2010/main">
+                <a:solidFill>
+                  <a:schemeClr val="accent1"/>
+                </a:solidFill>
+              </a14:hiddenFill>
+            </a:ext>
+            <a:ext uri="{91240B29-F687-4F45-9708-019B960494DF}">
+              <a14:hiddenLine xmlns:a14="http://schemas.microsoft.com/office/drawing/2010/main" w="9525">
+                <a:solidFill>
+                  <a:schemeClr val="tx1"/>
+                </a:solidFill>
+                <a:miter lim="800000"/>
+                <a:headEnd/>
+                <a:tailEnd/>
+              </a14:hiddenLine>
+            </a:ext>
+            <a:ext uri="{AF507438-7753-43E0-B8FC-AC1667EBCBE1}">
+              <a14:hiddenEffects xmlns:a14="http://schemas.microsoft.com/office/drawing/2010/main">
+                <a:effectLst>
+                  <a:outerShdw dist="35921" dir="2700000" algn="ctr" rotWithShape="0">
+                    <a:schemeClr val="bg2"/>
+                  </a:outerShdw>
+                </a:effectLst>
+              </a14:hiddenEffects>
+            </a:ext>
+          </a:extLst>
         </p:spPr>
       </p:pic>
     </p:spTree>
@@ -13816,7 +12755,7 @@
 </p:sld>
 </file>
 
-<file path=ppt/slides/slide15.xml><?xml version="1.0" encoding="utf-8"?>
+<file path=ppt/slides/slide13.xml><?xml version="1.0" encoding="utf-8"?>
 <p:sld xmlns:a="http://schemas.openxmlformats.org/drawingml/2006/main" xmlns:r="http://schemas.openxmlformats.org/officeDocument/2006/relationships" xmlns:p="http://schemas.openxmlformats.org/presentationml/2006/main">
   <p:cSld>
     <p:spTree>
@@ -13833,43 +12772,12 @@
           <a:chExt cx="0" cy="0"/>
         </a:xfrm>
       </p:grpSpPr>
-      <p:pic>
-        <p:nvPicPr>
-          <p:cNvPr id="4" name="Picture 3" descr="A certificate with red text&#10;&#10;AI-generated content may be incorrect.">
-            <a:extLst>
-              <a:ext uri="{FF2B5EF4-FFF2-40B4-BE49-F238E27FC236}">
-                <a16:creationId xmlns:a16="http://schemas.microsoft.com/office/drawing/2014/main" id="{099C3698-991D-7A38-C456-893C84C23FC9}"/>
-              </a:ext>
-            </a:extLst>
-          </p:cNvPr>
-          <p:cNvPicPr>
-            <a:picLocks noChangeAspect="1"/>
-          </p:cNvPicPr>
-          <p:nvPr/>
-        </p:nvPicPr>
-        <p:blipFill>
-          <a:blip r:embed="rId2"/>
-          <a:srcRect r="177" b="-275"/>
-          <a:stretch>
-            <a:fillRect/>
-          </a:stretch>
-        </p:blipFill>
-        <p:spPr>
-          <a:xfrm>
-            <a:off x="2512736" y="1712637"/>
-            <a:ext cx="7177553" cy="4658577"/>
-          </a:xfrm>
-          <a:prstGeom prst="rect">
-            <a:avLst/>
-          </a:prstGeom>
-        </p:spPr>
-      </p:pic>
       <p:sp>
         <p:nvSpPr>
           <p:cNvPr id="5" name="TextBox 4">
             <a:extLst>
               <a:ext uri="{FF2B5EF4-FFF2-40B4-BE49-F238E27FC236}">
-                <a16:creationId xmlns:a16="http://schemas.microsoft.com/office/drawing/2014/main" id="{CA8544A9-CF92-3FAF-D3EE-31DF90F7A64D}"/>
+                <a16:creationId xmlns="" xmlns:a16="http://schemas.microsoft.com/office/drawing/2014/main" id="{CA8544A9-CF92-3FAF-D3EE-31DF90F7A64D}"/>
               </a:ext>
             </a:extLst>
           </p:cNvPr>
@@ -13891,12 +12799,12 @@
             <a:prstTxWarp prst="textNoShape">
               <a:avLst/>
             </a:prstTxWarp>
-            <a:spAutoFit/>
+            <a:normAutofit/>
           </a:bodyPr>
           <a:lstStyle/>
           <a:p>
             <a:r>
-              <a:rPr lang="en-US" sz="2400" b="1" i="0" u="none" strike="noStrike" baseline="0">
+              <a:rPr lang="en-US" sz="1920" b="1" i="0" u="none" strike="noStrike" baseline="0">
                 <a:solidFill>
                   <a:srgbClr val="000000"/>
                 </a:solidFill>
@@ -13905,7 +12813,7 @@
               <a:t>Certificates Earned:</a:t>
             </a:r>
             <a:r>
-              <a:rPr sz="2400" b="0" i="0">
+              <a:rPr sz="1920" b="0" i="0">
                 <a:solidFill>
                   <a:srgbClr val="000000"/>
                 </a:solidFill>
@@ -13928,7 +12836,7 @@
           <p:cNvPr id="6" name="TextBox 5">
             <a:extLst>
               <a:ext uri="{FF2B5EF4-FFF2-40B4-BE49-F238E27FC236}">
-                <a16:creationId xmlns:a16="http://schemas.microsoft.com/office/drawing/2014/main" id="{C0D36B1A-26C2-CD55-1032-4CB5E4EDF305}"/>
+                <a16:creationId xmlns="" xmlns:a16="http://schemas.microsoft.com/office/drawing/2014/main" id="{C0D36B1A-26C2-CD55-1032-4CB5E4EDF305}"/>
               </a:ext>
             </a:extLst>
           </p:cNvPr>
@@ -13950,17 +12858,81 @@
             <a:prstTxWarp prst="textNoShape">
               <a:avLst/>
             </a:prstTxWarp>
-            <a:spAutoFit/>
+            <a:normAutofit/>
           </a:bodyPr>
           <a:lstStyle/>
           <a:p>
             <a:r>
-              <a:rPr lang="en-US" sz="2000" b="1"/>
+              <a:rPr lang="en-US" sz="1600" b="1"/>
               <a:t>Add your IBM BOB Certificate</a:t>
             </a:r>
           </a:p>
         </p:txBody>
       </p:sp>
+      <p:pic>
+        <p:nvPicPr>
+          <p:cNvPr id="2050" name="Picture 2"/>
+          <p:cNvPicPr>
+            <a:picLocks noChangeAspect="1" noChangeArrowheads="1"/>
+          </p:cNvPicPr>
+          <p:nvPr/>
+        </p:nvPicPr>
+        <p:blipFill>
+          <a:blip r:embed="rId2">
+            <a:extLst>
+              <a:ext uri="{28A0092B-C50C-407E-A947-70E740481C1C}">
+                <a14:useLocalDpi xmlns:a14="http://schemas.microsoft.com/office/drawing/2010/main" val="0"/>
+              </a:ext>
+            </a:extLst>
+          </a:blip>
+          <a:srcRect/>
+          <a:stretch>
+            <a:fillRect/>
+          </a:stretch>
+        </p:blipFill>
+        <p:spPr bwMode="auto">
+          <a:xfrm>
+            <a:off x="2362200" y="1449169"/>
+            <a:ext cx="7559675" cy="4675406"/>
+          </a:xfrm>
+          <a:prstGeom prst="rect">
+            <a:avLst/>
+          </a:prstGeom>
+          <a:noFill/>
+          <a:ln>
+            <a:noFill/>
+          </a:ln>
+          <a:effectLst/>
+          <a:extLst>
+            <a:ext uri="{909E8E84-426E-40DD-AFC4-6F175D3DCCD1}">
+              <a14:hiddenFill xmlns:a14="http://schemas.microsoft.com/office/drawing/2010/main">
+                <a:solidFill>
+                  <a:schemeClr val="accent1"/>
+                </a:solidFill>
+              </a14:hiddenFill>
+            </a:ext>
+            <a:ext uri="{91240B29-F687-4F45-9708-019B960494DF}">
+              <a14:hiddenLine xmlns:a14="http://schemas.microsoft.com/office/drawing/2010/main" w="9525">
+                <a:solidFill>
+                  <a:schemeClr val="tx1"/>
+                </a:solidFill>
+                <a:miter lim="800000"/>
+                <a:headEnd/>
+                <a:tailEnd/>
+              </a14:hiddenLine>
+            </a:ext>
+            <a:ext uri="{AF507438-7753-43E0-B8FC-AC1667EBCBE1}">
+              <a14:hiddenEffects xmlns:a14="http://schemas.microsoft.com/office/drawing/2010/main">
+                <a:effectLst>
+                  <a:outerShdw dist="35921" dir="2700000" algn="ctr" rotWithShape="0">
+                    <a:schemeClr val="bg2"/>
+                  </a:outerShdw>
+                </a:effectLst>
+              </a14:hiddenEffects>
+            </a:ext>
+          </a:extLst>
+        </p:spPr>
+      </p:pic>
     </p:spTree>
     <p:extLst>
       <p:ext uri="{BB962C8B-B14F-4D97-AF65-F5344CB8AC3E}">
@@ -13974,7 +12946,7 @@
 </p:sld>
 </file>
 
-<file path=ppt/slides/slide16.xml><?xml version="1.0" encoding="utf-8"?>
+<file path=ppt/slides/slide14.xml><?xml version="1.0" encoding="utf-8"?>
 <p:sld xmlns:a="http://schemas.openxmlformats.org/drawingml/2006/main" xmlns:r="http://schemas.openxmlformats.org/officeDocument/2006/relationships" xmlns:p="http://schemas.openxmlformats.org/presentationml/2006/main">
   <p:cSld>
     <p:spTree>
@@ -14064,7 +13036,7 @@
         </p:spPr>
         <p:txBody>
           <a:bodyPr spcFirstLastPara="1" wrap="square" lIns="0" tIns="0" rIns="0" bIns="0" anchor="t" anchorCtr="0">
-            <a:noAutofit/>
+            <a:normAutofit/>
           </a:bodyPr>
           <a:lstStyle/>
           <a:p>
@@ -14118,7 +13090,7 @@
         </p:spPr>
         <p:txBody>
           <a:bodyPr spcFirstLastPara="1" wrap="square" lIns="91425" tIns="45700" rIns="91425" bIns="45700" anchor="ctr" anchorCtr="0">
-            <a:noAutofit/>
+            <a:normAutofit/>
           </a:bodyPr>
           <a:lstStyle/>
           <a:p>
@@ -14158,7 +13130,7 @@
           <p:nvPr>
             <p:extLst>
               <p:ext uri="{D42A27DB-BD31-4B8C-83A1-F6EECF244321}">
-                <p14:modId xmlns:p14="http://schemas.microsoft.com/office/powerpoint/2010/main" val="2897107072"/>
+                <p14:modId xmlns:p14="http://schemas.microsoft.com/office/powerpoint/2010/main" val="2501183037"/>
               </p:ext>
             </p:extLst>
           </p:nvPr>
@@ -14178,28 +13150,28 @@
                 <a:gridCol w="2064867">
                   <a:extLst>
                     <a:ext uri="{9D8B030D-6E8A-4147-A177-3AD203B41FA5}">
-                      <a16:colId xmlns:a16="http://schemas.microsoft.com/office/drawing/2014/main" val="20000"/>
+                      <a16:colId xmlns="" xmlns:a16="http://schemas.microsoft.com/office/drawing/2014/main" val="20000"/>
                     </a:ext>
                   </a:extLst>
                 </a:gridCol>
                 <a:gridCol w="2443374">
                   <a:extLst>
                     <a:ext uri="{9D8B030D-6E8A-4147-A177-3AD203B41FA5}">
-                      <a16:colId xmlns:a16="http://schemas.microsoft.com/office/drawing/2014/main" val="20002"/>
+                      <a16:colId xmlns="" xmlns:a16="http://schemas.microsoft.com/office/drawing/2014/main" val="20002"/>
                     </a:ext>
                   </a:extLst>
                 </a:gridCol>
                 <a:gridCol w="2443374">
                   <a:extLst>
                     <a:ext uri="{9D8B030D-6E8A-4147-A177-3AD203B41FA5}">
-                      <a16:colId xmlns:a16="http://schemas.microsoft.com/office/drawing/2014/main" val="20003"/>
+                      <a16:colId xmlns="" xmlns:a16="http://schemas.microsoft.com/office/drawing/2014/main" val="20003"/>
                     </a:ext>
                   </a:extLst>
                 </a:gridCol>
                 <a:gridCol w="2443374">
                   <a:extLst>
                     <a:ext uri="{9D8B030D-6E8A-4147-A177-3AD203B41FA5}">
-                      <a16:colId xmlns:a16="http://schemas.microsoft.com/office/drawing/2014/main" val="20004"/>
+                      <a16:colId xmlns="" xmlns:a16="http://schemas.microsoft.com/office/drawing/2014/main" val="20004"/>
                     </a:ext>
                   </a:extLst>
                 </a:gridCol>
@@ -14220,10 +13192,10 @@
                         <a:buNone/>
                       </a:pPr>
                       <a:r>
-                        <a:rPr lang="en-US" sz="1800" u="none" strike="noStrike" cap="none"/>
+                        <a:rPr lang="en-US" sz="1800" u="none" strike="noStrike" cap="none" dirty="0"/>
                         <a:t>Student Name</a:t>
                       </a:r>
-                      <a:endParaRPr sz="1800" u="none" strike="noStrike" cap="none"/>
+                      <a:endParaRPr sz="1800" u="none" strike="noStrike" cap="none" dirty="0"/>
                     </a:p>
                   </a:txBody>
                   <a:tcPr marL="91450" marR="91450" marT="45725" marB="45725" anchor="ctr">
@@ -14544,7 +13516,7 @@
                 </a:tc>
                 <a:extLst>
                   <a:ext uri="{0D108BD9-81ED-4DB2-BD59-A6C34878D82A}">
-                    <a16:rowId xmlns:a16="http://schemas.microsoft.com/office/drawing/2014/main" val="10000"/>
+                    <a16:rowId xmlns="" xmlns:a16="http://schemas.microsoft.com/office/drawing/2014/main" val="10000"/>
                   </a:ext>
                 </a:extLst>
               </a:tr>
@@ -14563,7 +13535,19 @@
                         </a:spcAft>
                         <a:buNone/>
                       </a:pPr>
-                      <a:endParaRPr/>
+                      <a:r>
+                        <a:rPr lang="en-US" dirty="0" err="1" smtClean="0"/>
+                        <a:t>Anirudh</a:t>
+                      </a:r>
+                      <a:r>
+                        <a:rPr lang="en-US" dirty="0" smtClean="0"/>
+                        <a:t> </a:t>
+                      </a:r>
+                      <a:r>
+                        <a:rPr lang="en-US" dirty="0" err="1" smtClean="0"/>
+                        <a:t>Verma</a:t>
+                      </a:r>
+                      <a:endParaRPr dirty="0"/>
                     </a:p>
                   </a:txBody>
                   <a:tcPr marL="91450" marR="91450" marT="45725" marB="45725">
@@ -14681,7 +13665,11 @@
                         </a:spcAft>
                         <a:buNone/>
                       </a:pPr>
-                      <a:endParaRPr/>
+                      <a:r>
+                        <a:rPr lang="en-US" dirty="0" smtClean="0"/>
+                        <a:t>techmax1245@gmail.com</a:t>
+                      </a:r>
+                      <a:endParaRPr dirty="0"/>
                     </a:p>
                   </a:txBody>
                   <a:tcPr marL="91450" marR="91450" marT="45725" marB="45725">
@@ -14740,7 +13728,11 @@
                         </a:spcAft>
                         <a:buNone/>
                       </a:pPr>
-                      <a:endParaRPr/>
+                      <a:r>
+                        <a:rPr lang="en-US" dirty="0" smtClean="0"/>
+                        <a:t>9016703180</a:t>
+                      </a:r>
+                      <a:endParaRPr dirty="0"/>
                     </a:p>
                   </a:txBody>
                   <a:tcPr marL="91450" marR="91450" marT="45725" marB="45725">
@@ -14787,7 +13779,7 @@
                 </a:tc>
                 <a:extLst>
                   <a:ext uri="{0D108BD9-81ED-4DB2-BD59-A6C34878D82A}">
-                    <a16:rowId xmlns:a16="http://schemas.microsoft.com/office/drawing/2014/main" val="10001"/>
+                    <a16:rowId xmlns="" xmlns:a16="http://schemas.microsoft.com/office/drawing/2014/main" val="10001"/>
                   </a:ext>
                 </a:extLst>
               </a:tr>
@@ -14803,15 +13795,19 @@
         </p:nvPicPr>
         <p:blipFill rotWithShape="1">
           <a:blip r:embed="rId3">
-            <a:alphaModFix/>
+            <a:extLst>
+              <a:ext uri="{28A0092B-C50C-407E-A947-70E740481C1C}">
+                <a14:useLocalDpi xmlns:a14="http://schemas.microsoft.com/office/drawing/2010/main" val="0"/>
+              </a:ext>
+            </a:extLst>
           </a:blip>
-          <a:srcRect/>
+          <a:srcRect t="10115" r="14426" b="34051"/>
           <a:stretch/>
         </p:blipFill>
         <p:spPr>
           <a:xfrm>
-            <a:off x="4053024" y="3738417"/>
-            <a:ext cx="762500" cy="801811"/>
+            <a:off x="4038600" y="3643525"/>
+            <a:ext cx="1124205" cy="981075"/>
           </a:xfrm>
           <a:prstGeom prst="rect">
             <a:avLst/>
@@ -14827,7 +13823,7 @@
           <p:cNvPr id="4" name="TextBox 3">
             <a:extLst>
               <a:ext uri="{FF2B5EF4-FFF2-40B4-BE49-F238E27FC236}">
-                <a16:creationId xmlns:a16="http://schemas.microsoft.com/office/drawing/2014/main" id="{A828B9EF-C084-F5D4-CA27-75AF7D995640}"/>
+                <a16:creationId xmlns="" xmlns:a16="http://schemas.microsoft.com/office/drawing/2014/main" id="{A828B9EF-C084-F5D4-CA27-75AF7D995640}"/>
               </a:ext>
             </a:extLst>
           </p:cNvPr>
@@ -14846,23 +13842,19 @@
         </p:spPr>
         <p:txBody>
           <a:bodyPr wrap="square" rtlCol="0">
-            <a:spAutoFit/>
+            <a:normAutofit/>
           </a:bodyPr>
           <a:lstStyle/>
           <a:p>
             <a:r>
-              <a:rPr lang="en-US" sz="2400" b="1"/>
+              <a:rPr lang="en-US" sz="1920" b="1" dirty="0"/>
               <a:t>Domain of  Project – </a:t>
             </a:r>
             <a:r>
-              <a:rPr lang="en-US" sz="2400" b="1">
-                <a:highlight>
-                  <a:srgbClr val="FFFF00"/>
-                </a:highlight>
-              </a:rPr>
-              <a:t>[ like Agriculture / Education / Healthcare / … ]</a:t>
-            </a:r>
-            <a:endParaRPr lang="en-IN" sz="2400" b="1">
+              <a:rPr lang="en-US" sz="1920" b="1" dirty="0" smtClean="0"/>
+              <a:t>Cyber Security and Privacy.</a:t>
+            </a:r>
+            <a:endParaRPr lang="en-IN" sz="2400" b="1" dirty="0">
               <a:highlight>
                 <a:srgbClr val="FFFF00"/>
               </a:highlight>
@@ -14875,7 +13867,7 @@
           <p:cNvPr id="7" name="TextBox 6">
             <a:extLst>
               <a:ext uri="{FF2B5EF4-FFF2-40B4-BE49-F238E27FC236}">
-                <a16:creationId xmlns:a16="http://schemas.microsoft.com/office/drawing/2014/main" id="{3D723CA3-EC2D-165A-F109-3759C4E9C8A4}"/>
+                <a16:creationId xmlns="" xmlns:a16="http://schemas.microsoft.com/office/drawing/2014/main" id="{3D723CA3-EC2D-165A-F109-3759C4E9C8A4}"/>
               </a:ext>
             </a:extLst>
           </p:cNvPr>
@@ -14894,16 +13886,16 @@
         </p:spPr>
         <p:txBody>
           <a:bodyPr wrap="square" rtlCol="0">
-            <a:spAutoFit/>
+            <a:normAutofit/>
           </a:bodyPr>
           <a:lstStyle/>
           <a:p>
             <a:r>
-              <a:rPr lang="en-US" sz="2400" b="1"/>
+              <a:rPr lang="en-US" sz="1920" b="1"/>
               <a:t>Project Tile – </a:t>
             </a:r>
             <a:r>
-              <a:rPr lang="en-US" sz="2400" b="1">
+              <a:rPr lang="en-US" sz="1920" b="1">
                 <a:highlight>
                   <a:srgbClr val="FFFF00"/>
                 </a:highlight>
@@ -14911,7 +13903,7 @@
               <a:t>[</a:t>
             </a:r>
             <a:r>
-              <a:rPr lang="en-US" sz="2400" b="1">
+              <a:rPr lang="en-US" sz="1920" b="1">
                 <a:solidFill>
                   <a:srgbClr val="002060"/>
                 </a:solidFill>
@@ -14923,10 +13915,10 @@
                 <a:cs typeface="Times New Roman"/>
                 <a:sym typeface="Times New Roman"/>
               </a:rPr>
-              <a:t>Write your project title here</a:t>
-            </a:r>
-            <a:r>
-              <a:rPr lang="en-US" sz="2400" b="1">
+              <a:t>ScamShield - AI + Blockchain Scam Protection</a:t>
+            </a:r>
+            <a:r>
+              <a:rPr lang="en-US" sz="1920" b="1">
                 <a:highlight>
                   <a:srgbClr val="FFFF00"/>
                 </a:highlight>
@@ -14938,91 +13930,6 @@
                 <a:srgbClr val="FFFF00"/>
               </a:highlight>
             </a:endParaRPr>
-          </a:p>
-        </p:txBody>
-      </p:sp>
-      <p:sp>
-        <p:nvSpPr>
-          <p:cNvPr id="3" name="TextBox 2">
-            <a:extLst>
-              <a:ext uri="{FF2B5EF4-FFF2-40B4-BE49-F238E27FC236}">
-                <a16:creationId xmlns:a16="http://schemas.microsoft.com/office/drawing/2014/main" id="{B0B023FA-CFEB-ACE9-8425-7E72E307CDC5}"/>
-              </a:ext>
-            </a:extLst>
-          </p:cNvPr>
-          <p:cNvSpPr txBox="1"/>
-          <p:nvPr/>
-        </p:nvSpPr>
-        <p:spPr>
-          <a:xfrm>
-            <a:off x="1211005" y="5210667"/>
-            <a:ext cx="6456743" cy="1631216"/>
-          </a:xfrm>
-          <a:prstGeom prst="rect">
-            <a:avLst/>
-          </a:prstGeom>
-          <a:noFill/>
-        </p:spPr>
-        <p:txBody>
-          <a:bodyPr rot="0" spcFirstLastPara="0" vertOverflow="overflow" horzOverflow="overflow" vert="horz" wrap="square" lIns="91440" tIns="45720" rIns="91440" bIns="45720" numCol="1" spcCol="0" rtlCol="0" fromWordArt="0" anchor="t" anchorCtr="0" forceAA="0" compatLnSpc="1">
-            <a:prstTxWarp prst="textNoShape">
-              <a:avLst/>
-            </a:prstTxWarp>
-            <a:spAutoFit/>
-          </a:bodyPr>
-          <a:lstStyle/>
-          <a:p>
-            <a:r>
-              <a:rPr lang="en-US" sz="2000">
-                <a:solidFill>
-                  <a:srgbClr val="FF0000"/>
-                </a:solidFill>
-              </a:rPr>
-              <a:t>Recommended font style and size:</a:t>
-            </a:r>
-            <a:br>
-              <a:rPr lang="en-US" sz="2000">
-                <a:solidFill>
-                  <a:srgbClr val="FF0000"/>
-                </a:solidFill>
-              </a:rPr>
-            </a:br>
-            <a:br>
-              <a:rPr lang="en-US" sz="2000"/>
-            </a:br>
-            <a:r>
-              <a:rPr lang="en-US" sz="2000">
-                <a:solidFill>
-                  <a:srgbClr val="FF0000"/>
-                </a:solidFill>
-              </a:rPr>
-              <a:t>Font Style: Arial</a:t>
-            </a:r>
-            <a:br>
-              <a:rPr lang="en-US" sz="2000">
-                <a:solidFill>
-                  <a:srgbClr val="FF0000"/>
-                </a:solidFill>
-              </a:rPr>
-            </a:br>
-            <a:r>
-              <a:rPr lang="en-US" sz="2000">
-                <a:solidFill>
-                  <a:srgbClr val="FF0000"/>
-                </a:solidFill>
-              </a:rPr>
-              <a:t>Font Size (Heading): 28</a:t>
-            </a:r>
-          </a:p>
-          <a:p>
-            <a:r>
-              <a:rPr lang="en-US" sz="2000">
-                <a:solidFill>
-                  <a:srgbClr val="FF0000"/>
-                </a:solidFill>
-              </a:rPr>
-              <a:t>Font Size (Content): 20</a:t>
-            </a:r>
           </a:p>
         </p:txBody>
       </p:sp>
@@ -15042,7 +13949,7 @@
         <p:cNvPr id="1" name="Shape 103">
           <a:extLst>
             <a:ext uri="{FF2B5EF4-FFF2-40B4-BE49-F238E27FC236}">
-              <a16:creationId xmlns:a16="http://schemas.microsoft.com/office/drawing/2014/main" id="{F4C0A7C6-2888-EA53-35AB-4072E6B1FDAC}"/>
+              <a16:creationId xmlns="" xmlns:a16="http://schemas.microsoft.com/office/drawing/2014/main" id="{F4C0A7C6-2888-EA53-35AB-4072E6B1FDAC}"/>
             </a:ext>
           </a:extLst>
         </p:cNvPr>
@@ -15062,7 +13969,7 @@
           <p:cNvPr id="2" name="TextBox 1">
             <a:extLst>
               <a:ext uri="{FF2B5EF4-FFF2-40B4-BE49-F238E27FC236}">
-                <a16:creationId xmlns:a16="http://schemas.microsoft.com/office/drawing/2014/main" id="{C6F6745E-14BA-0766-CE1E-32E29663832D}"/>
+                <a16:creationId xmlns="" xmlns:a16="http://schemas.microsoft.com/office/drawing/2014/main" id="{C6F6745E-14BA-0766-CE1E-32E29663832D}"/>
               </a:ext>
             </a:extLst>
           </p:cNvPr>
@@ -15081,14 +13988,14 @@
         </p:spPr>
         <p:txBody>
           <a:bodyPr wrap="square" rtlCol="0">
-            <a:spAutoFit/>
+            <a:normAutofit/>
           </a:bodyPr>
           <a:lstStyle/>
           <a:p>
             <a:pPr fontAlgn="base"/>
             <a:r>
               <a:rPr lang="en-US" b="1"/>
-              <a:t>Problem Statement : Nutrition Agent</a:t>
+              <a:t>Problem Statement : ScamShield</a:t>
             </a:r>
             <a:r>
               <a:rPr lang="en-US"/>
@@ -15114,23 +14021,23 @@
             <a:pPr fontAlgn="base"/>
             <a:r>
               <a:rPr lang="en-US"/>
-              <a:t>Good nutrition is the foundation of health, but individuals often struggle with </a:t>
+              <a:t>Users are increasingly targeted by sophisticated phishing, but often struggle with </a:t>
             </a:r>
             <a:r>
               <a:rPr lang="en-US" b="1"/>
-              <a:t>diet planning, portion control, and tracking nutritional intake</a:t>
+              <a:t>identifying OTP scams, and detecting fraudulent links on mobile</a:t>
             </a:r>
             <a:r>
               <a:rPr lang="en-US"/>
-              <a:t>. Information about healthy diets, disease-specific nutrition, and food composition is scattered across unreliable sources. Without </a:t>
+              <a:t>. Information about current scams is scattered. Without </a:t>
             </a:r>
             <a:r>
               <a:rPr lang="en-US" b="1"/>
-              <a:t>personalized, real-time guidance</a:t>
+              <a:t>personalized, real-time threat detection</a:t>
             </a:r>
             <a:r>
               <a:rPr lang="en-US"/>
-              <a:t>, many fail to maintain balanced diets or make informed food choices. </a:t>
+              <a:t>, many fall victim to fraudulent schemes.</a:t>
             </a:r>
           </a:p>
           <a:p>
@@ -15156,7 +14063,7 @@
             </a:r>
             <a:r>
               <a:rPr lang="en-US" b="1"/>
-              <a:t>AI-powered Nutrition Agent</a:t>
+              <a:t>AI-powered Scam Protection Agent</a:t>
             </a:r>
             <a:r>
               <a:rPr lang="en-US"/>
@@ -15164,11 +14071,11 @@
             </a:r>
             <a:r>
               <a:rPr lang="en-US" b="1"/>
-              <a:t>personalized dietary insights and guidance</a:t>
+              <a:t>real-time risk analysis for individuals</a:t>
             </a:r>
             <a:r>
               <a:rPr lang="en-US"/>
-              <a:t> for individuals, families, and health professionals. The solution should: </a:t>
+              <a:t> The solution should:</a:t>
             </a:r>
           </a:p>
           <a:p>
@@ -15178,11 +14085,11 @@
             </a:pPr>
             <a:r>
               <a:rPr lang="en-US" b="1"/>
-              <a:t>Personalized Diet Plans</a:t>
+              <a:t>Real-time Text Analysis</a:t>
             </a:r>
             <a:r>
               <a:rPr lang="en-US"/>
-              <a:t> – Recommend meals based on age, health conditions, allergies, cultural preferences, and fitness goals. </a:t>
+              <a:t> – Analyze screen text via OCR for OTP scams and fraudulent intent. </a:t>
             </a:r>
           </a:p>
           <a:p>
@@ -15192,11 +14099,11 @@
             </a:pPr>
             <a:r>
               <a:rPr lang="en-US" b="1"/>
-              <a:t>Food Data RAG Retrieval</a:t>
+              <a:t>URL Risk Detection</a:t>
             </a:r>
             <a:r>
               <a:rPr lang="en-US"/>
-              <a:t> – Fetch and summarize nutritional values (calories, macros, vitamins) from reliable sources. </a:t>
+              <a:t> – Evaluate links using Safe Browsing and AI spoof-domain judgment. </a:t>
             </a:r>
           </a:p>
           <a:p>
@@ -15206,11 +14113,11 @@
             </a:pPr>
             <a:r>
               <a:rPr lang="en-US" b="1"/>
-              <a:t>Diet Tracking &amp; Feedback</a:t>
+              <a:t>Blockchain Ledger</a:t>
             </a:r>
             <a:r>
               <a:rPr lang="en-US"/>
-              <a:t> – Allow users to log meals via text, images, or voice, and provide instant nutritional analysis. </a:t>
+              <a:t> – Report and verify known scam numbers/URLs securely via a blockchain ledger. </a:t>
             </a:r>
           </a:p>
           <a:p>
@@ -15220,11 +14127,11 @@
             </a:pPr>
             <a:r>
               <a:rPr lang="en-US" b="1"/>
-              <a:t>Preventive Health Focus</a:t>
+              <a:t>Privacy-First Execution</a:t>
             </a:r>
             <a:r>
               <a:rPr lang="en-US"/>
-              <a:t> – Suggest diets for chronic disease management (e.g., diabetes-friendly or heart-healthy plans). </a:t>
+              <a:t> Perform OCR on-device so sensitive screenshots never leave the phone.</a:t>
             </a:r>
           </a:p>
           <a:p>
@@ -15248,11 +14155,11 @@
             </a:pPr>
             <a:r>
               <a:rPr lang="en-US" b="1"/>
-              <a:t>Nutrition Knowledge Agent</a:t>
+              <a:t>Scam Text Agent</a:t>
             </a:r>
             <a:r>
               <a:rPr lang="en-US"/>
-              <a:t> (fetches nutritional data) </a:t>
+              <a:t> (analyzes text intent) </a:t>
             </a:r>
           </a:p>
           <a:p>
@@ -15262,11 +14169,11 @@
             </a:pPr>
             <a:r>
               <a:rPr lang="en-US" b="1"/>
-              <a:t>Diet Recommendation Agent</a:t>
+              <a:t>URL Risk Agent</a:t>
             </a:r>
             <a:r>
               <a:rPr lang="en-US"/>
-              <a:t> (personalized meal plans) </a:t>
+              <a:t> (checks for malicious links) </a:t>
             </a:r>
           </a:p>
           <a:p>
@@ -15276,11 +14183,11 @@
             </a:pPr>
             <a:r>
               <a:rPr lang="en-US" b="1"/>
-              <a:t>Health Advisory Agent</a:t>
+              <a:t>Ledger Agent</a:t>
             </a:r>
             <a:r>
               <a:rPr lang="en-US"/>
-              <a:t> (preventive health suggestions) </a:t>
+              <a:t> (interfaces with scam registry) </a:t>
             </a:r>
           </a:p>
           <a:p>
@@ -15290,11 +14197,11 @@
             </a:pPr>
             <a:r>
               <a:rPr lang="en-US" b="1"/>
-              <a:t>Food Log &amp; Feedback Agent</a:t>
+              <a:t>Orchestrator Agent</a:t>
             </a:r>
             <a:r>
               <a:rPr lang="en-US"/>
-              <a:t> (meal tracking + analysis) </a:t>
+              <a:t> (coordinates parallel analysis) </a:t>
             </a:r>
           </a:p>
           <a:p>
@@ -15304,11 +14211,11 @@
             </a:pPr>
             <a:r>
               <a:rPr lang="en-US" b="1"/>
-              <a:t>Visualization Dashboard</a:t>
+              <a:t>User Interface</a:t>
             </a:r>
             <a:r>
               <a:rPr lang="en-US"/>
-              <a:t> – Show daily/weekly nutrient intake, deficiencies, and progress toward health goals. </a:t>
+              <a:t> – Provide on-demand floating widget overlay and Chrome extension alerts. </a:t>
             </a:r>
           </a:p>
           <a:p>
@@ -15325,7 +14232,7 @@
           <p:cNvPr id="3" name="TextBox 2">
             <a:extLst>
               <a:ext uri="{FF2B5EF4-FFF2-40B4-BE49-F238E27FC236}">
-                <a16:creationId xmlns:a16="http://schemas.microsoft.com/office/drawing/2014/main" id="{3847FA31-EA47-D27A-9D69-AF50A3080AEC}"/>
+                <a16:creationId xmlns="" xmlns:a16="http://schemas.microsoft.com/office/drawing/2014/main" id="{3847FA31-EA47-D27A-9D69-AF50A3080AEC}"/>
               </a:ext>
             </a:extLst>
           </p:cNvPr>
@@ -15344,12 +14251,12 @@
         </p:spPr>
         <p:txBody>
           <a:bodyPr wrap="square" rtlCol="0">
-            <a:spAutoFit/>
+            <a:normAutofit/>
           </a:bodyPr>
           <a:lstStyle/>
           <a:p>
             <a:r>
-              <a:rPr lang="en-US" sz="2400" b="1"/>
+              <a:rPr lang="en-US" sz="1920" b="1"/>
               <a:t>Problem Statement -</a:t>
             </a:r>
             <a:endParaRPr lang="en-IN" sz="2400" b="1"/>
@@ -15377,7 +14284,7 @@
         <p:cNvPr id="1" name="Shape 103">
           <a:extLst>
             <a:ext uri="{FF2B5EF4-FFF2-40B4-BE49-F238E27FC236}">
-              <a16:creationId xmlns:a16="http://schemas.microsoft.com/office/drawing/2014/main" id="{0471B467-61AA-7BCA-460D-43041E805F9C}"/>
+              <a16:creationId xmlns="" xmlns:a16="http://schemas.microsoft.com/office/drawing/2014/main" id="{0471B467-61AA-7BCA-460D-43041E805F9C}"/>
             </a:ext>
           </a:extLst>
         </p:cNvPr>
@@ -15397,7 +14304,7 @@
           <p:cNvPr id="2" name="TextBox 1">
             <a:extLst>
               <a:ext uri="{FF2B5EF4-FFF2-40B4-BE49-F238E27FC236}">
-                <a16:creationId xmlns:a16="http://schemas.microsoft.com/office/drawing/2014/main" id="{4A1BF701-ABCA-4DF0-8330-B6AF71EF8E39}"/>
+                <a16:creationId xmlns="" xmlns:a16="http://schemas.microsoft.com/office/drawing/2014/main" id="{4A1BF701-ABCA-4DF0-8330-B6AF71EF8E39}"/>
               </a:ext>
             </a:extLst>
           </p:cNvPr>
@@ -15416,7 +14323,7 @@
         </p:spPr>
         <p:txBody>
           <a:bodyPr wrap="square" rtlCol="0">
-            <a:spAutoFit/>
+            <a:normAutofit/>
           </a:bodyPr>
           <a:lstStyle/>
           <a:p>
@@ -15426,7 +14333,7 @@
           <a:p>
             <a:r>
               <a:rPr lang="en-US" b="1"/>
-              <a:t>Proposed Solution: AI-Powered Nutrition Agent</a:t>
+              <a:t>Proposed Solution: ScamShield</a:t>
             </a:r>
           </a:p>
           <a:p>
@@ -15436,7 +14343,7 @@
             </a:r>
             <a:r>
               <a:rPr lang="en-US" b="1"/>
-              <a:t>multi-agent AI-powered Nutrition Agent</a:t>
+              <a:t>multi-agent AI-powered scam protection system</a:t>
             </a:r>
             <a:r>
               <a:rPr lang="en-US"/>
@@ -15444,7 +14351,7 @@
             </a:r>
             <a:r>
               <a:rPr lang="en-US" b="1" err="1"/>
-              <a:t>LangFlow</a:t>
+              <a:t>FastAPI</a:t>
             </a:r>
             <a:r>
               <a:rPr lang="en-US" b="1"/>
@@ -15452,7 +14359,7 @@
             </a:r>
             <a:r>
               <a:rPr lang="en-US"/>
-              <a:t> to provide personalized, real-time dietary guidance. The system addresses challenges in diet planning, nutrition tracking, and preventive healthcare through an intelligent, modular architecture.</a:t>
+              <a:t> to provide real-time risk analysis. The system addresses challenges in scam detection and reporting through an intelligent, modular architecture.</a:t>
             </a:r>
           </a:p>
           <a:p>
@@ -15462,11 +14369,11 @@
             </a:r>
             <a:r>
               <a:rPr lang="en-US" b="1"/>
-              <a:t>Retrieval-Augmented Generation (RAG)</a:t>
+              <a:t>parallel agent orchestration</a:t>
             </a:r>
             <a:r>
               <a:rPr lang="en-US"/>
-              <a:t> pipeline to fetch accurate nutritional data from trusted sources such as USDA and WHO datasets. This data is embedded and stored in a vector database, enabling the system to retrieve and summarize food nutrition details (calories, macros, vitamins) using Granite models.</a:t>
+              <a:t> pipeline to analyze screen text and URLs. This data is processed securely, enabling the system to detect and flag fraudulent intent using Granite models.</a:t>
             </a:r>
           </a:p>
           <a:p>
@@ -15478,41 +14385,41 @@
           <a:p>
             <a:r>
               <a:rPr lang="en-US" b="1"/>
-              <a:t>Nutrition Knowledge Agent</a:t>
+              <a:t>Scam Text Agent</a:t>
             </a:r>
             <a:r>
               <a:rPr lang="en-US"/>
-              <a:t> retrieves and summarizes nutritional information using RAG. </a:t>
+              <a:t> analyzes text for phishing or OTP fraud intent. </a:t>
             </a:r>
           </a:p>
           <a:p>
             <a:r>
               <a:rPr lang="en-US" b="1"/>
-              <a:t>Diet Recommendation Agent</a:t>
+              <a:t>URL Risk Agent</a:t>
             </a:r>
             <a:r>
               <a:rPr lang="en-US"/>
-              <a:t> generates personalized meal plans based on user inputs such as age, health conditions, dietary preferences, and fitness goals. </a:t>
+              <a:t> checks links against Safe Browsing and Granite spoof-judgment. </a:t>
             </a:r>
           </a:p>
           <a:p>
             <a:r>
               <a:rPr lang="en-US" b="1"/>
-              <a:t>Health Advisory Agent</a:t>
+              <a:t>Ledger Agent</a:t>
             </a:r>
             <a:r>
               <a:rPr lang="en-US"/>
-              <a:t> provides preventive health suggestions, including disease-specific diets (e.g., diabetes-friendly or heart-healthy plans). </a:t>
+              <a:t> handles secure reporting and verification of malicious entities. </a:t>
             </a:r>
           </a:p>
           <a:p>
             <a:r>
               <a:rPr lang="en-US" b="1"/>
-              <a:t>Food Log &amp; Feedback Agent</a:t>
+              <a:t>Orchestrator Agent</a:t>
             </a:r>
             <a:r>
               <a:rPr lang="en-US"/>
-              <a:t> allows users to log meals via text, voice, or images and delivers instant nutritional analysis with actionable feedback. </a:t>
+              <a:t> coordinates fan-out requests and aggregates risk scores. </a:t>
             </a:r>
           </a:p>
           <a:p>
@@ -15522,7 +14429,7 @@
             </a:r>
             <a:r>
               <a:rPr lang="en-US" b="1"/>
-              <a:t>user-friendly dashboard</a:t>
+              <a:t>user-friendly Android floating widget</a:t>
             </a:r>
             <a:r>
               <a:rPr lang="en-US"/>
@@ -15530,21 +14437,21 @@
             </a:r>
             <a:r>
               <a:rPr lang="en-US" err="1"/>
-              <a:t>Streamlit</a:t>
+              <a:t>Kotlin</a:t>
             </a:r>
             <a:r>
               <a:rPr lang="en-US"/>
-              <a:t> or React) that visualizes daily and weekly nutrient intake, highlights deficiencies, and tracks progress toward health goals.</a:t>
+              <a:t> and Manifest V3) that visualizes risk levels and highlights malicious links.</a:t>
             </a:r>
           </a:p>
           <a:p>
             <a:r>
               <a:rPr lang="en-US" err="1"/>
-              <a:t>LangFlow</a:t>
+              <a:t>FastAPI</a:t>
             </a:r>
             <a:r>
               <a:rPr lang="en-US"/>
-              <a:t> is used to orchestrate agent workflows, while watsonx.ai ensures scalable model deployment, embeddings, and AI governance. Granite models power reasoning, summarization, and personalization.</a:t>
+              <a:t> is used to orchestrate workflows, while watsonx.ai ensures scalable model deployment. Granite models power reasoning and spoof-domain judgment.</a:t>
             </a:r>
           </a:p>
           <a:p>
@@ -15554,11 +14461,11 @@
             </a:r>
             <a:r>
               <a:rPr lang="en-US" b="1"/>
-              <a:t>end-to-end intelligent nutrition assistant</a:t>
+              <a:t>end-to-end intelligent scam protection assistant</a:t>
             </a:r>
             <a:r>
               <a:rPr lang="en-US"/>
-              <a:t> that promotes healthier lifestyles through personalized insights, real-time feedback, and preventive healthcare recommendations.</a:t>
+              <a:t> that promotes digital safety through real-time feedback and preventive alerts.</a:t>
             </a:r>
           </a:p>
           <a:p>
@@ -15575,7 +14482,7 @@
           <p:cNvPr id="3" name="TextBox 2">
             <a:extLst>
               <a:ext uri="{FF2B5EF4-FFF2-40B4-BE49-F238E27FC236}">
-                <a16:creationId xmlns:a16="http://schemas.microsoft.com/office/drawing/2014/main" id="{527F30CC-07EF-8FCC-DA00-C9212F5DAECE}"/>
+                <a16:creationId xmlns="" xmlns:a16="http://schemas.microsoft.com/office/drawing/2014/main" id="{527F30CC-07EF-8FCC-DA00-C9212F5DAECE}"/>
               </a:ext>
             </a:extLst>
           </p:cNvPr>
@@ -15594,12 +14501,12 @@
         </p:spPr>
         <p:txBody>
           <a:bodyPr wrap="square" rtlCol="0">
-            <a:spAutoFit/>
+            <a:normAutofit/>
           </a:bodyPr>
           <a:lstStyle/>
           <a:p>
             <a:r>
-              <a:rPr lang="en-US" sz="2400" b="1"/>
+              <a:rPr lang="en-US" sz="1920" b="1"/>
               <a:t>Proposed Solution -</a:t>
             </a:r>
             <a:endParaRPr lang="en-IN" sz="2400" b="1"/>
@@ -15627,7 +14534,7 @@
         <p:cNvPr id="1" name="Shape 200">
           <a:extLst>
             <a:ext uri="{FF2B5EF4-FFF2-40B4-BE49-F238E27FC236}">
-              <a16:creationId xmlns:a16="http://schemas.microsoft.com/office/drawing/2014/main" id="{7C2A09DE-0AE2-AA94-B2C1-84FDBDB9DC64}"/>
+              <a16:creationId xmlns="" xmlns:a16="http://schemas.microsoft.com/office/drawing/2014/main" id="{7C2A09DE-0AE2-AA94-B2C1-84FDBDB9DC64}"/>
             </a:ext>
           </a:extLst>
         </p:cNvPr>
@@ -15647,7 +14554,7 @@
           <p:cNvPr id="2" name="TextBox 1">
             <a:extLst>
               <a:ext uri="{FF2B5EF4-FFF2-40B4-BE49-F238E27FC236}">
-                <a16:creationId xmlns:a16="http://schemas.microsoft.com/office/drawing/2014/main" id="{151FBD4A-3273-E454-091D-D5B0678FC299}"/>
+                <a16:creationId xmlns="" xmlns:a16="http://schemas.microsoft.com/office/drawing/2014/main" id="{151FBD4A-3273-E454-091D-D5B0678FC299}"/>
               </a:ext>
             </a:extLst>
           </p:cNvPr>
@@ -15666,12 +14573,12 @@
         </p:spPr>
         <p:txBody>
           <a:bodyPr wrap="square" lIns="91440" tIns="45720" rIns="91440" bIns="45720" rtlCol="0" anchor="t">
-            <a:spAutoFit/>
+            <a:normAutofit/>
           </a:bodyPr>
           <a:lstStyle/>
           <a:p>
             <a:r>
-              <a:rPr lang="en-US" sz="2400" b="1"/>
+              <a:rPr lang="en-US" sz="1920" b="1"/>
               <a:t>Technology Used</a:t>
             </a:r>
             <a:endParaRPr lang="en-IN" sz="2400" b="1"/>
@@ -15683,7 +14590,7 @@
           <p:cNvPr id="3" name="TextBox 2">
             <a:extLst>
               <a:ext uri="{FF2B5EF4-FFF2-40B4-BE49-F238E27FC236}">
-                <a16:creationId xmlns:a16="http://schemas.microsoft.com/office/drawing/2014/main" id="{4A7608B5-9906-EFCF-959A-E89FC2E3EE19}"/>
+                <a16:creationId xmlns="" xmlns:a16="http://schemas.microsoft.com/office/drawing/2014/main" id="{4A7608B5-9906-EFCF-959A-E89FC2E3EE19}"/>
               </a:ext>
             </a:extLst>
           </p:cNvPr>
@@ -15702,7 +14609,7 @@
         </p:spPr>
         <p:txBody>
           <a:bodyPr wrap="square" lIns="91440" tIns="45720" rIns="91440" bIns="45720" rtlCol="0" anchor="t">
-            <a:spAutoFit/>
+            <a:normAutofit/>
           </a:bodyPr>
           <a:lstStyle/>
           <a:p>
@@ -15711,16 +14618,16 @@
               <a:buChar char="•"/>
             </a:pPr>
             <a:r>
-              <a:rPr lang="en-US" sz="1800" b="1" dirty="0" err="1"/>
+              <a:rPr lang="en-US" sz="1440" b="1" dirty="0" err="1"/>
               <a:t>Langflow</a:t>
             </a:r>
             <a:r>
-              <a:rPr lang="en-US" sz="1800" b="1" dirty="0"/>
+              <a:rPr lang="en-US" sz="1440" b="1" dirty="0"/>
               <a:t> platform </a:t>
             </a:r>
             <a:r>
-              <a:rPr lang="en-US" sz="1800" dirty="0"/>
-              <a:t>-For designing and orchestrating multi-agent workflows visually</a:t>
+              <a:rPr lang="en-US" sz="1440" dirty="0"/>
+              <a:t>- For designing and orchestrating high-performance API endpoints</a:t>
             </a:r>
           </a:p>
           <a:p>
@@ -15743,20 +14650,20 @@
               <a:buChar char="•"/>
             </a:pPr>
             <a:r>
-              <a:rPr lang="en-US" sz="1800" b="1" dirty="0"/>
+              <a:rPr lang="en-US" sz="1440" b="1" dirty="0"/>
               <a:t>IBM Granite model </a:t>
             </a:r>
             <a:r>
-              <a:rPr lang="en-US" sz="1800" dirty="0"/>
+              <a:rPr lang="en-US" sz="1440" dirty="0"/>
               <a:t>-  for </a:t>
             </a:r>
             <a:r>
-              <a:rPr lang="en-US" sz="1800" dirty="0" err="1"/>
+              <a:rPr lang="en-US" sz="1440" dirty="0" err="1"/>
               <a:t>eg</a:t>
             </a:r>
             <a:r>
-              <a:rPr lang="en-US" sz="1800" dirty="0"/>
-              <a:t> – ibm-granite-3-2-8b – For natural language understanding, reasoning, and personalization</a:t>
+              <a:rPr lang="en-US" sz="1440" dirty="0"/>
+              <a:t> - ibm/granite-4-h-small - For natural language understanding and spoof-domain judgment</a:t>
             </a:r>
           </a:p>
           <a:p>
@@ -15772,20 +14679,20 @@
               <a:buChar char="•"/>
             </a:pPr>
             <a:r>
-              <a:rPr lang="en-US" sz="1800" b="1"/>
+              <a:rPr lang="en-US" sz="1440" b="1"/>
               <a:t>IBM Cloud </a:t>
             </a:r>
             <a:r>
-              <a:rPr lang="en-US" sz="1800"/>
-              <a:t>– It provides the infrastructure to build, deploy, and scale the Nutrition Agent efficiently. IBM Cloud enables a </a:t>
-            </a:r>
-            <a:r>
-              <a:rPr lang="en-US" sz="1800" b="1"/>
+              <a:rPr lang="en-US" sz="1440"/>
+              <a:t>- It provides the infrastructure to build, deploy, and scale ScamShield efficiently. IBM Cloud enables a </a:t>
+            </a:r>
+            <a:r>
+              <a:rPr lang="en-US" sz="1440" b="1"/>
               <a:t>reliable, secure, and scalable environment</a:t>
             </a:r>
             <a:r>
-              <a:rPr lang="en-US" sz="1800"/>
-              <a:t> for deploying the Nutrition Agent.</a:t>
+              <a:rPr lang="en-US" sz="1440"/>
+              <a:t> for deploying ScamShield.</a:t>
             </a:r>
           </a:p>
           <a:p>
@@ -15801,20 +14708,20 @@
               <a:buChar char="•"/>
             </a:pPr>
             <a:r>
-              <a:rPr lang="en-US" sz="1800" b="1"/>
-              <a:t>RAG– </a:t>
-            </a:r>
-            <a:r>
-              <a:rPr lang="en-US" sz="1800"/>
-              <a:t>RAG to </a:t>
-            </a:r>
-            <a:r>
-              <a:rPr lang="en-US" sz="1800" b="1"/>
-              <a:t>fetch real data first, then generate intelligent answers</a:t>
-            </a:r>
-            <a:r>
-              <a:rPr lang="en-US" sz="1800"/>
-              <a:t>, making the Nutrition Agent more trustworthy and effective.</a:t>
+              <a:rPr lang="en-US" sz="1440" b="1"/>
+              <a:t>Blockchain / Ledger - </a:t>
+            </a:r>
+            <a:r>
+              <a:rPr lang="en-US" sz="1440"/>
+              <a:t>Hash-chained fallback or Fabric ledger to </a:t>
+            </a:r>
+            <a:r>
+              <a:rPr lang="en-US" sz="1440" b="1"/>
+              <a:t>store and verify reports</a:t>
+            </a:r>
+            <a:r>
+              <a:rPr lang="en-US" sz="1440"/>
+              <a:t>, making ScamShield more trustworthy and effective.</a:t>
             </a:r>
           </a:p>
           <a:p>
@@ -15830,11 +14737,11 @@
               <a:buChar char="•"/>
             </a:pPr>
             <a:r>
-              <a:rPr lang="en-US" sz="1800" b="1"/>
+              <a:rPr lang="en-US" sz="1440" b="1"/>
               <a:t>IBM Watsonx.ai - </a:t>
             </a:r>
             <a:r>
-              <a:rPr lang="en-US" sz="1800"/>
+              <a:rPr lang="en-US" sz="1440"/>
               <a:t>For model deployment, embeddings, and AI governance</a:t>
             </a:r>
           </a:p>
@@ -15851,12 +14758,12 @@
               <a:buChar char="•"/>
             </a:pPr>
             <a:r>
-              <a:rPr lang="en-IN" sz="1800" b="1"/>
-              <a:t>Vector Database </a:t>
-            </a:r>
-            <a:r>
-              <a:rPr lang="en-IN" sz="1800"/>
-              <a:t>(FAISS/Chroma) – For RAG-based nutritional data retrieval</a:t>
+              <a:rPr lang="en-IN" sz="1440" b="1"/>
+              <a:t>SQLite / Hyperledger Fabric </a:t>
+            </a:r>
+            <a:r>
+              <a:rPr lang="en-IN" sz="1440"/>
+              <a:t>– For decentralized and tamper-evident scam registry storage</a:t>
             </a:r>
             <a:endParaRPr lang="en-US" sz="1800"/>
           </a:p>
@@ -15903,7 +14810,7 @@
         <p:cNvPr id="1" name="Shape 131">
           <a:extLst>
             <a:ext uri="{FF2B5EF4-FFF2-40B4-BE49-F238E27FC236}">
-              <a16:creationId xmlns:a16="http://schemas.microsoft.com/office/drawing/2014/main" id="{CDF2A78E-5A0E-6814-8AF4-0AE54B0366E1}"/>
+              <a16:creationId xmlns="" xmlns:a16="http://schemas.microsoft.com/office/drawing/2014/main" id="{CDF2A78E-5A0E-6814-8AF4-0AE54B0366E1}"/>
             </a:ext>
           </a:extLst>
         </p:cNvPr>
@@ -15923,7 +14830,7 @@
           <p:cNvPr id="135" name="Google Shape;135;p5">
             <a:extLst>
               <a:ext uri="{FF2B5EF4-FFF2-40B4-BE49-F238E27FC236}">
-                <a16:creationId xmlns:a16="http://schemas.microsoft.com/office/drawing/2014/main" id="{2A145802-2DD3-EEBA-7D44-210C05B98C91}"/>
+                <a16:creationId xmlns="" xmlns:a16="http://schemas.microsoft.com/office/drawing/2014/main" id="{2A145802-2DD3-EEBA-7D44-210C05B98C91}"/>
               </a:ext>
             </a:extLst>
           </p:cNvPr>
@@ -15945,7 +14852,7 @@
         </p:spPr>
         <p:txBody>
           <a:bodyPr spcFirstLastPara="1" wrap="square" lIns="0" tIns="0" rIns="0" bIns="0" anchor="t" anchorCtr="0">
-            <a:noAutofit/>
+            <a:normAutofit/>
           </a:bodyPr>
           <a:lstStyle/>
           <a:p>
@@ -15967,13 +14874,13 @@
               <a:buNone/>
             </a:pPr>
             <a:r>
-              <a:rPr lang="en-US" sz="2400" b="1" err="1">
+              <a:rPr lang="en-US" sz="1920" b="1" err="1">
                 <a:sym typeface="Times New Roman"/>
               </a:rPr>
               <a:t>Langflow</a:t>
             </a:r>
             <a:r>
-              <a:rPr lang="en-US" sz="3500" b="1" i="0" u="none" strike="noStrike" cap="none">
+              <a:rPr lang="en-US" sz="2800" b="1" i="0" u="none" strike="noStrike" cap="none">
                 <a:solidFill>
                   <a:srgbClr val="051D3A"/>
                 </a:solidFill>
@@ -15985,7 +14892,7 @@
               <a:t> </a:t>
             </a:r>
             <a:r>
-              <a:rPr lang="en-US" sz="2400" b="1">
+              <a:rPr lang="en-US" sz="1920" b="1">
                 <a:sym typeface="Times New Roman"/>
               </a:rPr>
               <a:t>component Used -</a:t>
@@ -16001,7 +14908,7 @@
           <p:cNvPr id="148" name="Google Shape;148;p5">
             <a:extLst>
               <a:ext uri="{FF2B5EF4-FFF2-40B4-BE49-F238E27FC236}">
-                <a16:creationId xmlns:a16="http://schemas.microsoft.com/office/drawing/2014/main" id="{69E3EADC-1EAD-7419-145C-20998925206E}"/>
+                <a16:creationId xmlns="" xmlns:a16="http://schemas.microsoft.com/office/drawing/2014/main" id="{69E3EADC-1EAD-7419-145C-20998925206E}"/>
               </a:ext>
             </a:extLst>
           </p:cNvPr>
@@ -16023,7 +14930,7 @@
         </p:spPr>
         <p:txBody>
           <a:bodyPr spcFirstLastPara="1" wrap="square" lIns="0" tIns="0" rIns="0" bIns="0" anchor="t" anchorCtr="0">
-            <a:noAutofit/>
+            <a:normAutofit/>
           </a:bodyPr>
           <a:lstStyle/>
           <a:p>
@@ -16061,7 +14968,7 @@
           <p:cNvPr id="149" name="Google Shape;149;p5">
             <a:extLst>
               <a:ext uri="{FF2B5EF4-FFF2-40B4-BE49-F238E27FC236}">
-                <a16:creationId xmlns:a16="http://schemas.microsoft.com/office/drawing/2014/main" id="{04E5872A-C331-C8F3-5D71-8E953BAAFE03}"/>
+                <a16:creationId xmlns="" xmlns:a16="http://schemas.microsoft.com/office/drawing/2014/main" id="{04E5872A-C331-C8F3-5D71-8E953BAAFE03}"/>
               </a:ext>
             </a:extLst>
           </p:cNvPr>
@@ -16083,7 +14990,7 @@
         </p:spPr>
         <p:txBody>
           <a:bodyPr spcFirstLastPara="1" wrap="square" lIns="0" tIns="0" rIns="0" bIns="0" anchor="t" anchorCtr="0">
-            <a:noAutofit/>
+            <a:normAutofit/>
           </a:bodyPr>
           <a:lstStyle/>
           <a:p>
@@ -16121,7 +15028,7 @@
           <p:cNvPr id="150" name="Google Shape;150;p5">
             <a:extLst>
               <a:ext uri="{FF2B5EF4-FFF2-40B4-BE49-F238E27FC236}">
-                <a16:creationId xmlns:a16="http://schemas.microsoft.com/office/drawing/2014/main" id="{76EF3801-5D99-5EFA-9AA2-AD265775E354}"/>
+                <a16:creationId xmlns="" xmlns:a16="http://schemas.microsoft.com/office/drawing/2014/main" id="{76EF3801-5D99-5EFA-9AA2-AD265775E354}"/>
               </a:ext>
             </a:extLst>
           </p:cNvPr>
@@ -16143,7 +15050,7 @@
         </p:spPr>
         <p:txBody>
           <a:bodyPr spcFirstLastPara="1" wrap="square" lIns="0" tIns="0" rIns="0" bIns="0" anchor="t" anchorCtr="0">
-            <a:noAutofit/>
+            <a:normAutofit/>
           </a:bodyPr>
           <a:lstStyle/>
           <a:p>
@@ -16181,7 +15088,7 @@
           <p:cNvPr id="151" name="Google Shape;151;p5">
             <a:extLst>
               <a:ext uri="{FF2B5EF4-FFF2-40B4-BE49-F238E27FC236}">
-                <a16:creationId xmlns:a16="http://schemas.microsoft.com/office/drawing/2014/main" id="{DAD76A8A-9F2C-9EA9-25E9-40CD0FFAA869}"/>
+                <a16:creationId xmlns="" xmlns:a16="http://schemas.microsoft.com/office/drawing/2014/main" id="{DAD76A8A-9F2C-9EA9-25E9-40CD0FFAA869}"/>
               </a:ext>
             </a:extLst>
           </p:cNvPr>
@@ -16203,7 +15110,7 @@
         </p:spPr>
         <p:txBody>
           <a:bodyPr spcFirstLastPara="1" wrap="square" lIns="0" tIns="0" rIns="0" bIns="0" anchor="t" anchorCtr="0">
-            <a:noAutofit/>
+            <a:normAutofit/>
           </a:bodyPr>
           <a:lstStyle/>
           <a:p>
@@ -16241,7 +15148,7 @@
           <p:cNvPr id="152" name="Google Shape;152;p5">
             <a:extLst>
               <a:ext uri="{FF2B5EF4-FFF2-40B4-BE49-F238E27FC236}">
-                <a16:creationId xmlns:a16="http://schemas.microsoft.com/office/drawing/2014/main" id="{8D9C4260-2673-337C-C898-4C22E0F8FD65}"/>
+                <a16:creationId xmlns="" xmlns:a16="http://schemas.microsoft.com/office/drawing/2014/main" id="{8D9C4260-2673-337C-C898-4C22E0F8FD65}"/>
               </a:ext>
             </a:extLst>
           </p:cNvPr>
@@ -16263,7 +15170,7 @@
         </p:spPr>
         <p:txBody>
           <a:bodyPr spcFirstLastPara="1" wrap="square" lIns="0" tIns="0" rIns="0" bIns="0" anchor="t" anchorCtr="0">
-            <a:noAutofit/>
+            <a:normAutofit/>
           </a:bodyPr>
           <a:lstStyle/>
           <a:p>
@@ -16301,7 +15208,7 @@
           <p:cNvPr id="153" name="Google Shape;153;p5">
             <a:extLst>
               <a:ext uri="{FF2B5EF4-FFF2-40B4-BE49-F238E27FC236}">
-                <a16:creationId xmlns:a16="http://schemas.microsoft.com/office/drawing/2014/main" id="{6167C3C6-3747-E373-84C3-3927C443B067}"/>
+                <a16:creationId xmlns="" xmlns:a16="http://schemas.microsoft.com/office/drawing/2014/main" id="{6167C3C6-3747-E373-84C3-3927C443B067}"/>
               </a:ext>
             </a:extLst>
           </p:cNvPr>
@@ -16323,7 +15230,7 @@
         </p:spPr>
         <p:txBody>
           <a:bodyPr spcFirstLastPara="1" wrap="square" lIns="0" tIns="0" rIns="0" bIns="0" anchor="t" anchorCtr="0">
-            <a:noAutofit/>
+            <a:normAutofit/>
           </a:bodyPr>
           <a:lstStyle/>
           <a:p>
@@ -16361,7 +15268,7 @@
           <p:cNvPr id="2" name="TextBox 1">
             <a:extLst>
               <a:ext uri="{FF2B5EF4-FFF2-40B4-BE49-F238E27FC236}">
-                <a16:creationId xmlns:a16="http://schemas.microsoft.com/office/drawing/2014/main" id="{9BB86949-7ED1-C43B-B1E3-5122BB67A596}"/>
+                <a16:creationId xmlns="" xmlns:a16="http://schemas.microsoft.com/office/drawing/2014/main" id="{9BB86949-7ED1-C43B-B1E3-5122BB67A596}"/>
               </a:ext>
             </a:extLst>
           </p:cNvPr>
@@ -16371,7 +15278,7 @@
         <p:spPr>
           <a:xfrm>
             <a:off x="474822" y="863187"/>
-            <a:ext cx="8823960" cy="5262979"/>
+            <a:ext cx="8823960" cy="3970318"/>
           </a:xfrm>
           <a:prstGeom prst="rect">
             <a:avLst/>
@@ -16380,144 +15287,153 @@
         </p:spPr>
         <p:txBody>
           <a:bodyPr wrap="square" rtlCol="0">
-            <a:spAutoFit/>
+            <a:normAutofit/>
           </a:bodyPr>
           <a:lstStyle/>
           <a:p>
-            <a:endParaRPr lang="en-US"/>
-          </a:p>
-          <a:p>
-            <a:r>
-              <a:rPr lang="en-US" b="1"/>
+            <a:endParaRPr lang="en-US" dirty="0"/>
+          </a:p>
+          <a:p>
+            <a:r>
+              <a:rPr lang="en-US" b="1" dirty="0"/>
               <a:t>1) Chat Input </a:t>
             </a:r>
             <a:r>
-              <a:rPr lang="en-US"/>
-              <a:t>– Interface where users enter their queries, preferences, or meal details (text/voice/image).</a:t>
-            </a:r>
-          </a:p>
-          <a:p>
-            <a:endParaRPr lang="en-US"/>
-          </a:p>
-          <a:p>
-            <a:r>
-              <a:rPr lang="en-US" b="1"/>
+              <a:rPr lang="en-US" dirty="0"/>
+              <a:t>– Interface where users trigger on-screen text scans or links are auto-scanned.</a:t>
+            </a:r>
+          </a:p>
+          <a:p>
+            <a:endParaRPr lang="en-US" dirty="0"/>
+          </a:p>
+          <a:p>
+            <a:r>
+              <a:rPr lang="en-US" b="1" dirty="0"/>
               <a:t>2) IBM </a:t>
             </a:r>
             <a:r>
-              <a:rPr lang="en-US" b="1" err="1"/>
+              <a:rPr lang="en-US" b="1" dirty="0" err="1"/>
               <a:t>watsonx</a:t>
             </a:r>
             <a:r>
-              <a:rPr lang="en-US" b="1"/>
+              <a:rPr lang="en-US" b="1" dirty="0"/>
               <a:t> AI Agent </a:t>
             </a:r>
             <a:r>
-              <a:rPr lang="en-US"/>
-              <a:t>- Processes user input using Granite models to generate personalized nutrition insights and recommendations. </a:t>
-            </a:r>
-          </a:p>
-          <a:p>
-            <a:endParaRPr lang="en-US"/>
-          </a:p>
-          <a:p>
-            <a:r>
-              <a:rPr lang="en-US" b="1"/>
+              <a:rPr lang="en-US" dirty="0"/>
+              <a:t>- Processes OCR text and URLs using Granite models to detect fraudulent intent. </a:t>
+            </a:r>
+          </a:p>
+          <a:p>
+            <a:endParaRPr lang="en-US" dirty="0"/>
+          </a:p>
+          <a:p>
+            <a:r>
+              <a:rPr lang="en-US" b="1" dirty="0"/>
               <a:t>3) Name of IBM Granite model - </a:t>
             </a:r>
             <a:r>
-              <a:rPr lang="en-US"/>
-              <a:t>Granite-4.0-8B-Instruct → Fast, efficient for real-time diet recommendations</a:t>
-            </a:r>
-          </a:p>
-          <a:p>
-            <a:endParaRPr lang="en-US"/>
-          </a:p>
-          <a:p>
-            <a:r>
-              <a:rPr lang="en-US" b="1"/>
+              <a:rPr lang="en-US" dirty="0" err="1"/>
+              <a:t>ibm</a:t>
+            </a:r>
+            <a:r>
+              <a:rPr lang="en-US" dirty="0"/>
+              <a:t>/granite-4-h-small → Fast, efficient for real-time risk assessment</a:t>
+            </a:r>
+          </a:p>
+          <a:p>
+            <a:endParaRPr lang="en-US" dirty="0"/>
+          </a:p>
+          <a:p>
+            <a:r>
+              <a:rPr lang="en-US" b="1" dirty="0"/>
               <a:t>4) Chat output -</a:t>
             </a:r>
             <a:r>
-              <a:rPr lang="en-US"/>
-              <a:t>Displays AI-generated responses such as diet plans, nutritional analysis, and health suggestions. </a:t>
-            </a:r>
-          </a:p>
-          <a:p>
-            <a:endParaRPr lang="en-US"/>
-          </a:p>
-          <a:p>
-            <a:r>
-              <a:rPr lang="en-US" b="1"/>
+              <a:rPr lang="en-US" dirty="0"/>
+              <a:t>Displays AI-generated risk levels (low/medium/high) and actionable reasoning. </a:t>
+            </a:r>
+          </a:p>
+          <a:p>
+            <a:endParaRPr lang="en-US" dirty="0"/>
+          </a:p>
+          <a:p>
+            <a:r>
+              <a:rPr lang="en-US" b="1" dirty="0"/>
               <a:t>5) </a:t>
             </a:r>
             <a:r>
-              <a:rPr lang="en-US" b="1">
+              <a:rPr lang="en-US" b="1" dirty="0">
+                <a:solidFill>
+                  <a:srgbClr val="FF0000"/>
+                </a:solidFill>
                 <a:highlight>
                   <a:srgbClr val="FFFF00"/>
                 </a:highlight>
               </a:rPr>
-              <a:t>File component - </a:t>
-            </a:r>
-            <a:r>
-              <a:rPr lang="en-US">
+              <a:t>Ledger Component - </a:t>
+            </a:r>
+            <a:r>
+              <a:rPr lang="en-US" dirty="0">
+                <a:solidFill>
+                  <a:srgbClr val="FF0000"/>
+                </a:solidFill>
                 <a:highlight>
                   <a:srgbClr val="FFFF00"/>
                 </a:highlight>
               </a:rPr>
-              <a:t>Stores and retrieves user data, meal logs, and nutritional datasets for analysis and tracking.</a:t>
-            </a:r>
-          </a:p>
-          <a:p>
-            <a:endParaRPr lang="en-US"/>
-          </a:p>
-          <a:p>
-            <a:endParaRPr lang="en-US"/>
-          </a:p>
-          <a:p>
-            <a:r>
-              <a:rPr lang="en-US"/>
-              <a:t>6) </a:t>
-            </a:r>
-            <a:r>
-              <a:rPr lang="en-US">
+              <a:t>Stores and retrieves scam reports via hash-chained SQLite or Fabric</a:t>
+            </a:r>
+            <a:r>
+              <a:rPr lang="en-US" dirty="0" smtClean="0">
+                <a:solidFill>
+                  <a:srgbClr val="FF0000"/>
+                </a:solidFill>
                 <a:highlight>
                   <a:srgbClr val="FFFF00"/>
                 </a:highlight>
               </a:rPr>
-              <a:t>Add name of any other component used.</a:t>
-            </a:r>
+              <a:t>.</a:t>
+            </a:r>
+            <a:endParaRPr lang="en-US" dirty="0">
+              <a:solidFill>
+                <a:srgbClr val="FF0000"/>
+              </a:solidFill>
+              <a:highlight>
+                <a:srgbClr val="FFFF00"/>
+              </a:highlight>
+            </a:endParaRPr>
           </a:p>
           <a:p>
             <a:pPr marL="342900" indent="-342900">
               <a:buAutoNum type="arabicParenR" startAt="3"/>
             </a:pPr>
-            <a:endParaRPr lang="en-US"/>
-          </a:p>
-          <a:p>
-            <a:endParaRPr lang="en-US"/>
-          </a:p>
-          <a:p>
-            <a:endParaRPr lang="en-US"/>
-          </a:p>
-          <a:p>
-            <a:endParaRPr lang="en-US"/>
-          </a:p>
-          <a:p>
-            <a:endParaRPr lang="en-US"/>
-          </a:p>
-          <a:p>
-            <a:endParaRPr lang="en-US"/>
-          </a:p>
-          <a:p>
-            <a:endParaRPr lang="en-US"/>
-          </a:p>
-          <a:p>
-            <a:r>
-              <a:rPr lang="en-US"/>
+            <a:endParaRPr lang="en-US" dirty="0"/>
+          </a:p>
+          <a:p>
+            <a:endParaRPr lang="en-US" dirty="0"/>
+          </a:p>
+          <a:p>
+            <a:endParaRPr lang="en-US" dirty="0"/>
+          </a:p>
+          <a:p>
+            <a:endParaRPr lang="en-US" dirty="0"/>
+          </a:p>
+          <a:p>
+            <a:endParaRPr lang="en-US" dirty="0"/>
+          </a:p>
+          <a:p>
+            <a:endParaRPr lang="en-US" dirty="0"/>
+          </a:p>
+          <a:p>
+            <a:endParaRPr lang="en-US" dirty="0"/>
+          </a:p>
+          <a:p>
+            <a:r>
+              <a:rPr lang="en-US" dirty="0"/>
               <a:t> </a:t>
             </a:r>
-            <a:endParaRPr lang="en-IN"/>
+            <a:endParaRPr lang="en-IN" dirty="0"/>
           </a:p>
         </p:txBody>
       </p:sp>
@@ -16539,13 +15455,7 @@
   <p:cSld>
     <p:spTree>
       <p:nvGrpSpPr>
-        <p:cNvPr id="1" name="Shape 173">
-          <a:extLst>
-            <a:ext uri="{FF2B5EF4-FFF2-40B4-BE49-F238E27FC236}">
-              <a16:creationId xmlns:a16="http://schemas.microsoft.com/office/drawing/2014/main" id="{CA6090C0-0478-84F9-6D20-717B6FEB7326}"/>
-            </a:ext>
-          </a:extLst>
-        </p:cNvPr>
+        <p:cNvPr id="1" name="Shape 173"/>
         <p:cNvGrpSpPr/>
         <p:nvPr/>
       </p:nvGrpSpPr>
@@ -16562,7 +15472,7 @@
           <p:cNvPr id="2" name="Google Shape;135;p5">
             <a:extLst>
               <a:ext uri="{FF2B5EF4-FFF2-40B4-BE49-F238E27FC236}">
-                <a16:creationId xmlns:a16="http://schemas.microsoft.com/office/drawing/2014/main" id="{B64CF172-D2AF-03D8-F919-AA7827A0D969}"/>
+                <a16:creationId xmlns="" xmlns:a16="http://schemas.microsoft.com/office/drawing/2014/main" id="{78578745-3233-E2C4-2AF4-55BA57C68D3F}"/>
               </a:ext>
             </a:extLst>
           </p:cNvPr>
@@ -16584,151 +15494,13 @@
         </p:spPr>
         <p:txBody>
           <a:bodyPr spcFirstLastPara="1" wrap="square" lIns="0" tIns="0" rIns="0" bIns="0" anchor="t" anchorCtr="0">
-            <a:noAutofit/>
+            <a:normAutofit/>
           </a:bodyPr>
           <a:lstStyle/>
           <a:p>
-            <a:pPr marL="0" marR="0" lvl="0" indent="0" algn="l" rtl="0">
-              <a:lnSpc>
-                <a:spcPct val="100000"/>
-              </a:lnSpc>
-              <a:spcBef>
-                <a:spcPts val="0"/>
-              </a:spcBef>
-              <a:spcAft>
-                <a:spcPts val="0"/>
-              </a:spcAft>
-              <a:buClr>
-                <a:srgbClr val="051D3A"/>
-              </a:buClr>
-              <a:buSzPts val="3500"/>
-              <a:buFont typeface="Times New Roman"/>
-              <a:buNone/>
-            </a:pPr>
-            <a:r>
-              <a:rPr lang="en-US" sz="2400" b="1" err="1">
-                <a:sym typeface="Times New Roman"/>
-              </a:rPr>
-              <a:t>Langflow</a:t>
-            </a:r>
-            <a:r>
-              <a:rPr lang="en-US" sz="3500" b="1" i="0" u="none" strike="noStrike" cap="none">
-                <a:solidFill>
-                  <a:srgbClr val="051D3A"/>
-                </a:solidFill>
-                <a:latin typeface="Times New Roman"/>
-                <a:ea typeface="Times New Roman"/>
-                <a:cs typeface="Times New Roman"/>
-                <a:sym typeface="Times New Roman"/>
-              </a:rPr>
-              <a:t> </a:t>
-            </a:r>
-            <a:r>
-              <a:rPr lang="en-US" sz="2400" b="1">
-                <a:sym typeface="Times New Roman"/>
-              </a:rPr>
-              <a:t>workflow -</a:t>
-            </a:r>
-            <a:endParaRPr sz="2400" b="1">
-              <a:sym typeface="Times New Roman"/>
-            </a:endParaRPr>
-          </a:p>
-        </p:txBody>
-      </p:sp>
-      <p:pic>
-        <p:nvPicPr>
-          <p:cNvPr id="4" name="Picture 3" descr="A screenshot of a computer&#10;&#10;AI-generated content may be incorrect.">
-            <a:extLst>
-              <a:ext uri="{FF2B5EF4-FFF2-40B4-BE49-F238E27FC236}">
-                <a16:creationId xmlns:a16="http://schemas.microsoft.com/office/drawing/2014/main" id="{C597681A-DF93-B190-DD21-CBAEDA4E3CBF}"/>
-              </a:ext>
-            </a:extLst>
-          </p:cNvPr>
-          <p:cNvPicPr>
-            <a:picLocks noChangeAspect="1"/>
-          </p:cNvPicPr>
-          <p:nvPr/>
-        </p:nvPicPr>
-        <p:blipFill>
-          <a:blip r:embed="rId3"/>
-          <a:stretch>
-            <a:fillRect/>
-          </a:stretch>
-        </p:blipFill>
-        <p:spPr>
-          <a:xfrm>
-            <a:off x="535570" y="1139263"/>
-            <a:ext cx="11468100" cy="5505450"/>
-          </a:xfrm>
-          <a:prstGeom prst="rect">
-            <a:avLst/>
-          </a:prstGeom>
-        </p:spPr>
-      </p:pic>
-    </p:spTree>
-    <p:extLst>
-      <p:ext uri="{BB962C8B-B14F-4D97-AF65-F5344CB8AC3E}">
-        <p14:creationId xmlns:p14="http://schemas.microsoft.com/office/powerpoint/2010/main" val="2772501912"/>
-      </p:ext>
-    </p:extLst>
-  </p:cSld>
-  <p:clrMapOvr>
-    <a:masterClrMapping/>
-  </p:clrMapOvr>
-</p:sld>
-</file>
-
-<file path=ppt/slides/slide8.xml><?xml version="1.0" encoding="utf-8"?>
-<p:sld xmlns:a="http://schemas.openxmlformats.org/drawingml/2006/main" xmlns:r="http://schemas.openxmlformats.org/officeDocument/2006/relationships" xmlns:p="http://schemas.openxmlformats.org/presentationml/2006/main">
-  <p:cSld>
-    <p:spTree>
-      <p:nvGrpSpPr>
-        <p:cNvPr id="1" name="Shape 173"/>
-        <p:cNvGrpSpPr/>
-        <p:nvPr/>
-      </p:nvGrpSpPr>
-      <p:grpSpPr>
-        <a:xfrm>
-          <a:off x="0" y="0"/>
-          <a:ext cx="0" cy="0"/>
-          <a:chOff x="0" y="0"/>
-          <a:chExt cx="0" cy="0"/>
-        </a:xfrm>
-      </p:grpSpPr>
-      <p:sp>
-        <p:nvSpPr>
-          <p:cNvPr id="2" name="Google Shape;135;p5">
-            <a:extLst>
-              <a:ext uri="{FF2B5EF4-FFF2-40B4-BE49-F238E27FC236}">
-                <a16:creationId xmlns:a16="http://schemas.microsoft.com/office/drawing/2014/main" id="{78578745-3233-E2C4-2AF4-55BA57C68D3F}"/>
-              </a:ext>
-            </a:extLst>
-          </p:cNvPr>
-          <p:cNvSpPr/>
-          <p:nvPr/>
-        </p:nvSpPr>
-        <p:spPr>
-          <a:xfrm>
-            <a:off x="537590" y="323239"/>
-            <a:ext cx="5908929" cy="448508"/>
-          </a:xfrm>
-          <a:prstGeom prst="rect">
-            <a:avLst/>
-          </a:prstGeom>
-          <a:noFill/>
-          <a:ln>
-            <a:noFill/>
-          </a:ln>
-        </p:spPr>
-        <p:txBody>
-          <a:bodyPr spcFirstLastPara="1" wrap="square" lIns="0" tIns="0" rIns="0" bIns="0" anchor="t" anchorCtr="0">
-            <a:noAutofit/>
-          </a:bodyPr>
-          <a:lstStyle/>
-          <a:p>
             <a:pPr lvl="0"/>
             <a:r>
-              <a:rPr lang="en-US" sz="2400" b="1">
+              <a:rPr lang="en-US" sz="1920" b="1">
                 <a:solidFill>
                   <a:schemeClr val="dk1"/>
                 </a:solidFill>
@@ -16745,32 +15517,66 @@
       </p:sp>
       <p:pic>
         <p:nvPicPr>
-          <p:cNvPr id="3" name="Picture 2">
-            <a:extLst>
-              <a:ext uri="{FF2B5EF4-FFF2-40B4-BE49-F238E27FC236}">
-                <a16:creationId xmlns:a16="http://schemas.microsoft.com/office/drawing/2014/main" id="{81932CE2-F219-0CA8-0102-55B8C682B8A2}"/>
-              </a:ext>
-            </a:extLst>
-          </p:cNvPr>
+          <p:cNvPr id="3074" name="Picture 2"/>
           <p:cNvPicPr>
-            <a:picLocks noChangeAspect="1"/>
+            <a:picLocks noChangeAspect="1" noChangeArrowheads="1"/>
           </p:cNvPicPr>
           <p:nvPr/>
         </p:nvPicPr>
         <p:blipFill>
-          <a:blip r:embed="rId3"/>
+          <a:blip r:embed="rId3">
+            <a:extLst>
+              <a:ext uri="{28A0092B-C50C-407E-A947-70E740481C1C}">
+                <a14:useLocalDpi xmlns:a14="http://schemas.microsoft.com/office/drawing/2010/main" val="0"/>
+              </a:ext>
+            </a:extLst>
+          </a:blip>
+          <a:srcRect/>
           <a:stretch>
             <a:fillRect/>
           </a:stretch>
         </p:blipFill>
-        <p:spPr>
+        <p:spPr bwMode="auto">
           <a:xfrm>
-            <a:off x="535570" y="675732"/>
-            <a:ext cx="11468100" cy="6181725"/>
+            <a:off x="2841625" y="936140"/>
+            <a:ext cx="5921375" cy="5531335"/>
           </a:xfrm>
           <a:prstGeom prst="rect">
             <a:avLst/>
           </a:prstGeom>
+          <a:noFill/>
+          <a:ln>
+            <a:noFill/>
+          </a:ln>
+          <a:effectLst/>
+          <a:extLst>
+            <a:ext uri="{909E8E84-426E-40DD-AFC4-6F175D3DCCD1}">
+              <a14:hiddenFill xmlns:a14="http://schemas.microsoft.com/office/drawing/2010/main">
+                <a:solidFill>
+                  <a:schemeClr val="accent1"/>
+                </a:solidFill>
+              </a14:hiddenFill>
+            </a:ext>
+            <a:ext uri="{91240B29-F687-4F45-9708-019B960494DF}">
+              <a14:hiddenLine xmlns:a14="http://schemas.microsoft.com/office/drawing/2010/main" w="9525">
+                <a:solidFill>
+                  <a:schemeClr val="tx1"/>
+                </a:solidFill>
+                <a:miter lim="800000"/>
+                <a:headEnd/>
+                <a:tailEnd/>
+              </a14:hiddenLine>
+            </a:ext>
+            <a:ext uri="{AF507438-7753-43E0-B8FC-AC1667EBCBE1}">
+              <a14:hiddenEffects xmlns:a14="http://schemas.microsoft.com/office/drawing/2010/main">
+                <a:effectLst>
+                  <a:outerShdw dist="35921" dir="2700000" algn="ctr" rotWithShape="0">
+                    <a:schemeClr val="bg2"/>
+                  </a:outerShdw>
+                </a:effectLst>
+              </a14:hiddenEffects>
+            </a:ext>
+          </a:extLst>
         </p:spPr>
       </p:pic>
     </p:spTree>
@@ -16781,7 +15587,7 @@
 </p:sld>
 </file>
 
-<file path=ppt/slides/slide9.xml><?xml version="1.0" encoding="utf-8"?>
+<file path=ppt/slides/slide8.xml><?xml version="1.0" encoding="utf-8"?>
 <p:sld xmlns:a="http://schemas.openxmlformats.org/drawingml/2006/main" xmlns:r="http://schemas.openxmlformats.org/officeDocument/2006/relationships" xmlns:p="http://schemas.openxmlformats.org/presentationml/2006/main">
   <p:cSld>
     <p:spTree>
@@ -16830,7 +15636,7 @@
           <p:cNvPr id="2" name="TextBox 1">
             <a:extLst>
               <a:ext uri="{FF2B5EF4-FFF2-40B4-BE49-F238E27FC236}">
-                <a16:creationId xmlns:a16="http://schemas.microsoft.com/office/drawing/2014/main" id="{B84A7B44-8B20-5A39-ED43-DA98D0FC7976}"/>
+                <a16:creationId xmlns="" xmlns:a16="http://schemas.microsoft.com/office/drawing/2014/main" id="{B84A7B44-8B20-5A39-ED43-DA98D0FC7976}"/>
               </a:ext>
             </a:extLst>
           </p:cNvPr>
@@ -16849,12 +15655,12 @@
         </p:spPr>
         <p:txBody>
           <a:bodyPr wrap="square" rtlCol="0">
-            <a:spAutoFit/>
+            <a:normAutofit/>
           </a:bodyPr>
           <a:lstStyle/>
           <a:p>
             <a:r>
-              <a:rPr lang="en-US" sz="3200" b="1"/>
+              <a:rPr lang="en-US" sz="2560" b="1"/>
               <a:t>Role of Agentic AI in the solution </a:t>
             </a:r>
             <a:endParaRPr lang="en-IN" sz="3200" b="1"/>
@@ -16866,7 +15672,7 @@
           <p:cNvPr id="3" name="TextBox 2">
             <a:extLst>
               <a:ext uri="{FF2B5EF4-FFF2-40B4-BE49-F238E27FC236}">
-                <a16:creationId xmlns:a16="http://schemas.microsoft.com/office/drawing/2014/main" id="{322462E8-EB3A-DA7D-44CB-4E757803A755}"/>
+                <a16:creationId xmlns="" xmlns:a16="http://schemas.microsoft.com/office/drawing/2014/main" id="{322462E8-EB3A-DA7D-44CB-4E757803A755}"/>
               </a:ext>
             </a:extLst>
           </p:cNvPr>
@@ -16885,13 +15691,13 @@
         </p:spPr>
         <p:txBody>
           <a:bodyPr wrap="square" rtlCol="0">
-            <a:spAutoFit/>
+            <a:normAutofit/>
           </a:bodyPr>
           <a:lstStyle/>
           <a:p>
             <a:r>
               <a:rPr lang="en-US" b="1"/>
-              <a:t>Role of Agentic AI in Nutrition Agent</a:t>
+              <a:t>Role of Agentic AI in ScamShield</a:t>
             </a:r>
           </a:p>
           <a:p>
@@ -16901,7 +15707,7 @@
             </a:r>
             <a:r>
               <a:rPr lang="en-US"/>
-              <a:t> enables the Nutrition Agent to function as an intelligent, autonomous system rather than a simple chatbot. Using </a:t>
+              <a:t> enables ScamShield to function as an intelligent, autonomous system rather than a simple rule-based filter. Using </a:t>
             </a:r>
             <a:r>
               <a:rPr lang="en-US" b="1"/>
@@ -16945,15 +15751,15 @@
             </a:r>
             <a:r>
               <a:rPr lang="en-US"/>
-              <a:t>, understanding user details like age, health conditions, and fitness goals to generate tailored recommendations. It supports </a:t>
+              <a:t>, understanding the nuance in text messages and URLs to distinguish legitimate requests from scams. It supports </a:t>
             </a:r>
             <a:r>
               <a:rPr lang="en-US" b="1"/>
-              <a:t>real-time adaptation</a:t>
+              <a:t>real-time execution</a:t>
             </a:r>
             <a:r>
               <a:rPr lang="en-US"/>
-              <a:t>, continuously updating suggestions based on user inputs like daily meals.</a:t>
+              <a:t>, providing immediate risk feedback as users navigate their digital environment.</a:t>
             </a:r>
           </a:p>
           <a:p>
@@ -16969,16 +15775,249 @@
             </a:r>
             <a:r>
               <a:rPr lang="en-US" b="1"/>
-              <a:t>smart digital nutritionist</a:t>
+              <a:t>smart digital security guard</a:t>
             </a:r>
             <a:r>
               <a:rPr lang="en-US"/>
-              <a:t> that helps users maintain a healthy lifestyle.</a:t>
+              <a:t> that helps users maintain a secure digital lifestyle.</a:t>
             </a:r>
           </a:p>
         </p:txBody>
       </p:sp>
     </p:spTree>
+  </p:cSld>
+  <p:clrMapOvr>
+    <a:masterClrMapping/>
+  </p:clrMapOvr>
+</p:sld>
+</file>
+
+<file path=ppt/slides/slide9.xml><?xml version="1.0" encoding="utf-8"?>
+<p:sld xmlns:a="http://schemas.openxmlformats.org/drawingml/2006/main" xmlns:r="http://schemas.openxmlformats.org/officeDocument/2006/relationships" xmlns:p="http://schemas.openxmlformats.org/presentationml/2006/main">
+  <p:cSld>
+    <p:spTree>
+      <p:nvGrpSpPr>
+        <p:cNvPr id="1" name="Shape 200">
+          <a:extLst>
+            <a:ext uri="{FF2B5EF4-FFF2-40B4-BE49-F238E27FC236}">
+              <a16:creationId xmlns="" xmlns:a16="http://schemas.microsoft.com/office/drawing/2014/main" id="{EEDEC80F-FA4E-F3FF-DE90-87B861D0BD13}"/>
+            </a:ext>
+          </a:extLst>
+        </p:cNvPr>
+        <p:cNvGrpSpPr/>
+        <p:nvPr/>
+      </p:nvGrpSpPr>
+      <p:grpSpPr>
+        <a:xfrm>
+          <a:off x="0" y="0"/>
+          <a:ext cx="0" cy="0"/>
+          <a:chOff x="0" y="0"/>
+          <a:chExt cx="0" cy="0"/>
+        </a:xfrm>
+      </p:grpSpPr>
+      <p:sp>
+        <p:nvSpPr>
+          <p:cNvPr id="2" name="TextBox 1">
+            <a:extLst>
+              <a:ext uri="{FF2B5EF4-FFF2-40B4-BE49-F238E27FC236}">
+                <a16:creationId xmlns="" xmlns:a16="http://schemas.microsoft.com/office/drawing/2014/main" id="{6FA184BA-BCF2-3D7B-30D0-0F3CF30C161B}"/>
+              </a:ext>
+            </a:extLst>
+          </p:cNvPr>
+          <p:cNvSpPr txBox="1"/>
+          <p:nvPr/>
+        </p:nvSpPr>
+        <p:spPr>
+          <a:xfrm>
+            <a:off x="777240" y="484632"/>
+            <a:ext cx="7123176" cy="461665"/>
+          </a:xfrm>
+          <a:prstGeom prst="rect">
+            <a:avLst/>
+          </a:prstGeom>
+          <a:noFill/>
+        </p:spPr>
+        <p:txBody>
+          <a:bodyPr wrap="square" rtlCol="0">
+            <a:normAutofit/>
+          </a:bodyPr>
+          <a:lstStyle/>
+          <a:p>
+            <a:r>
+              <a:rPr lang="en-US" sz="1920" b="1"/>
+              <a:t>Novelty and Uniqueness</a:t>
+            </a:r>
+            <a:endParaRPr lang="en-IN" sz="2400" b="1"/>
+          </a:p>
+        </p:txBody>
+      </p:sp>
+      <p:sp>
+        <p:nvSpPr>
+          <p:cNvPr id="3" name="TextBox 2">
+            <a:extLst>
+              <a:ext uri="{FF2B5EF4-FFF2-40B4-BE49-F238E27FC236}">
+                <a16:creationId xmlns="" xmlns:a16="http://schemas.microsoft.com/office/drawing/2014/main" id="{ED65F54F-855A-0DB6-09A6-3212C5F7405B}"/>
+              </a:ext>
+            </a:extLst>
+          </p:cNvPr>
+          <p:cNvSpPr txBox="1"/>
+          <p:nvPr/>
+        </p:nvSpPr>
+        <p:spPr>
+          <a:xfrm>
+            <a:off x="777240" y="1207008"/>
+            <a:ext cx="11301984" cy="5293757"/>
+          </a:xfrm>
+          <a:prstGeom prst="rect">
+            <a:avLst/>
+          </a:prstGeom>
+          <a:noFill/>
+        </p:spPr>
+        <p:txBody>
+          <a:bodyPr wrap="square" rtlCol="0">
+            <a:normAutofit/>
+          </a:bodyPr>
+          <a:lstStyle/>
+          <a:p>
+            <a:r>
+              <a:rPr lang="en-IN" sz="1440"/>
+              <a:t>The proposed ScamShield stands out by combining </a:t>
+            </a:r>
+            <a:r>
+              <a:rPr lang="en-IN" sz="1440" b="1"/>
+              <a:t>Agentic AI, OCR, and Blockchain</a:t>
+            </a:r>
+            <a:r>
+              <a:rPr lang="en-IN" sz="1440"/>
+              <a:t> into a single intelligent system.</a:t>
+            </a:r>
+          </a:p>
+          <a:p>
+            <a:endParaRPr lang="en-IN" sz="1800"/>
+          </a:p>
+          <a:p>
+            <a:r>
+              <a:rPr lang="en-IN" sz="1440" b="1"/>
+              <a:t>Multi-Agent Intelligence</a:t>
+            </a:r>
+            <a:r>
+              <a:rPr lang="en-IN" sz="1440"/>
+              <a:t> – Instead of a single chatbot, multiple specialized agents collaborate to deliver accurate and context-aware security guidance. </a:t>
+            </a:r>
+          </a:p>
+          <a:p>
+            <a:r>
+              <a:rPr lang="en-IN" sz="1440" b="1"/>
+              <a:t>Privacy-First OCR</a:t>
+            </a:r>
+            <a:r>
+              <a:rPr lang="en-IN" sz="1440"/>
+              <a:t> – Extracts text directly on-device without sending screenshots to the cloud. </a:t>
+            </a:r>
+          </a:p>
+          <a:p>
+            <a:r>
+              <a:rPr lang="en-IN" sz="1440" b="1"/>
+              <a:t>Real-Time Feedback Loop</a:t>
+            </a:r>
+            <a:r>
+              <a:rPr lang="en-IN" sz="1440"/>
+              <a:t> – Instantly highlights dangerous links and evaluates incoming messages. </a:t>
+            </a:r>
+          </a:p>
+          <a:p>
+            <a:r>
+              <a:rPr lang="en-IN" sz="1440" b="1"/>
+              <a:t>Multi-Platform</a:t>
+            </a:r>
+            <a:r>
+              <a:rPr lang="en-IN" sz="1440"/>
+              <a:t> – Supports Android overlays and Chrome extension auto-scanning. </a:t>
+            </a:r>
+            <a:r>
+              <a:rPr lang="en-IN" sz="1440" err="1"/>
+              <a:t>behavior</a:t>
+            </a:r>
+            <a:r>
+              <a:rPr lang="en-IN" sz="1440"/>
+              <a:t>. </a:t>
+            </a:r>
+          </a:p>
+          <a:p>
+            <a:r>
+              <a:rPr lang="en-IN" sz="1440" b="1"/>
+              <a:t>Proactive Security Focus</a:t>
+            </a:r>
+            <a:r>
+              <a:rPr lang="en-IN" sz="1440"/>
+              <a:t> – Goes beyond static blocklists to provide dynamic AI-based intent analysis. </a:t>
+            </a:r>
+          </a:p>
+          <a:p>
+            <a:r>
+              <a:rPr lang="en-IN" sz="1440" b="1"/>
+              <a:t>Scalable &amp; Enterprise-Ready</a:t>
+            </a:r>
+            <a:r>
+              <a:rPr lang="en-IN" sz="1440"/>
+              <a:t> – Built on FastAPI and IBM Code Engine for fast performance. </a:t>
+            </a:r>
+          </a:p>
+          <a:p>
+            <a:r>
+              <a:rPr lang="en-IN" sz="1440" b="1"/>
+              <a:t>Tamper-Evident Logs</a:t>
+            </a:r>
+            <a:r>
+              <a:rPr lang="en-IN" sz="1440"/>
+              <a:t> – Built on </a:t>
+            </a:r>
+            <a:r>
+              <a:rPr lang="en-IN" sz="1440" b="1"/>
+              <a:t>IBM watsonx.ai</a:t>
+            </a:r>
+            <a:r>
+              <a:rPr lang="en-IN" sz="1440"/>
+              <a:t> with </a:t>
+            </a:r>
+            <a:r>
+              <a:rPr lang="en-IN" sz="1440" b="1"/>
+              <a:t>IBM Granite models</a:t>
+            </a:r>
+            <a:r>
+              <a:rPr lang="en-IN" sz="1440"/>
+              <a:t>, ensuring reliability and governance. </a:t>
+            </a:r>
+          </a:p>
+          <a:p>
+            <a:endParaRPr lang="en-IN" sz="1800"/>
+          </a:p>
+          <a:p>
+            <a:r>
+              <a:rPr lang="en-IN" sz="1440"/>
+              <a:t>This makes the solution a </a:t>
+            </a:r>
+            <a:r>
+              <a:rPr lang="en-IN" sz="1440" b="1"/>
+              <a:t>smart, adaptive, and proactive digital security guard</a:t>
+            </a:r>
+            <a:r>
+              <a:rPr lang="en-IN" sz="1440"/>
+              <a:t>, not just a static blocklist tool.</a:t>
+            </a:r>
+            <a:endParaRPr lang="en-US"/>
+          </a:p>
+          <a:p>
+            <a:endParaRPr lang="en-IN"/>
+          </a:p>
+        </p:txBody>
+      </p:sp>
+    </p:spTree>
+    <p:extLst>
+      <p:ext uri="{BB962C8B-B14F-4D97-AF65-F5344CB8AC3E}">
+        <p14:creationId xmlns:p14="http://schemas.microsoft.com/office/powerpoint/2010/main" val="917964102"/>
+      </p:ext>
+    </p:extLst>
   </p:cSld>
   <p:clrMapOvr>
     <a:masterClrMapping/>

</xml_diff>